<commit_message>
Updates after demo day prep
</commit_message>
<xml_diff>
--- a/Lecture slides/AMOS A01 - Introduction.pptx
+++ b/Lecture slides/AMOS A01 - Introduction.pptx
@@ -11467,7 +11467,7 @@
             <a:tbl>
               <a:tblPr>
                 <a:noFill/>
-                <a:tableStyleId>{7EA05E9F-FED0-4B2F-B344-BC6183A9FCCF}</a:tableStyleId>
+                <a:tableStyleId>{B8C49189-0626-4E27-B65A-3A5F64F235E2}</a:tableStyleId>
               </a:tblPr>
               <a:tblGrid>
                 <a:gridCol w="1432550"/>
@@ -13123,7 +13123,11 @@
                       </a:pPr>
                       <a:r>
                         <a:rPr b="1" lang="en"/>
-                        <a:t>3 / 5</a:t>
+                        <a:t>6</a:t>
+                      </a:r>
+                      <a:r>
+                        <a:rPr b="1" lang="en"/>
+                        <a:t> / 5</a:t>
                       </a:r>
                       <a:endParaRPr b="1"/>
                     </a:p>
@@ -13386,7 +13390,7 @@
             <a:tbl>
               <a:tblPr>
                 <a:noFill/>
-                <a:tableStyleId>{7EA05E9F-FED0-4B2F-B344-BC6183A9FCCF}</a:tableStyleId>
+                <a:tableStyleId>{B8C49189-0626-4E27-B65A-3A5F64F235E2}</a:tableStyleId>
               </a:tblPr>
               <a:tblGrid>
                 <a:gridCol w="1432550"/>
@@ -19331,7 +19335,7 @@
           <a:p>
             <a:pPr indent="-342900" lvl="0" marL="457200" rtl="0" algn="l">
               <a:spcBef>
-                <a:spcPts val="0"/>
+                <a:spcPts val="1000"/>
               </a:spcBef>
               <a:spcAft>
                 <a:spcPts val="0"/>
@@ -19395,7 +19399,7 @@
           <a:p>
             <a:pPr indent="-342900" lvl="0" marL="457200" rtl="0" algn="l">
               <a:spcBef>
-                <a:spcPts val="0"/>
+                <a:spcPts val="1000"/>
               </a:spcBef>
               <a:spcAft>
                 <a:spcPts val="0"/>
@@ -22106,7 +22110,7 @@
             <a:tbl>
               <a:tblPr>
                 <a:noFill/>
-                <a:tableStyleId>{7EA05E9F-FED0-4B2F-B344-BC6183A9FCCF}</a:tableStyleId>
+                <a:tableStyleId>{B8C49189-0626-4E27-B65A-3A5F64F235E2}</a:tableStyleId>
               </a:tblPr>
               <a:tblGrid>
                 <a:gridCol w="859550"/>
@@ -27251,7 +27255,7 @@
 </file>
 
 <file path=ppt/theme/theme1.xml><?xml version="1.0" encoding="utf-8"?>
-<a:theme xmlns:a="http://schemas.openxmlformats.org/drawingml/2006/main" xmlns:r="http://schemas.openxmlformats.org/officeDocument/2006/relationships" name="AMOS Slides Template">
+<a:theme xmlns:a="http://schemas.openxmlformats.org/drawingml/2006/main" xmlns:r="http://schemas.openxmlformats.org/officeDocument/2006/relationships" name="POSS Slides Template">
   <a:themeElements>
     <a:clrScheme name="Simple Light">
       <a:dk1>
@@ -27530,285 +27534,6 @@
 </file>
 
 <file path=ppt/theme/theme2.xml><?xml version="1.0" encoding="utf-8"?>
-<a:theme xmlns:a="http://schemas.openxmlformats.org/drawingml/2006/main" xmlns:r="http://schemas.openxmlformats.org/officeDocument/2006/relationships" name="POSS Slides Template">
-  <a:themeElements>
-    <a:clrScheme name="Simple Light">
-      <a:dk1>
-        <a:srgbClr val="000000"/>
-      </a:dk1>
-      <a:lt1>
-        <a:srgbClr val="FFFFFF"/>
-      </a:lt1>
-      <a:dk2>
-        <a:srgbClr val="404040"/>
-      </a:dk2>
-      <a:lt2>
-        <a:srgbClr val="808080"/>
-      </a:lt2>
-      <a:accent1>
-        <a:srgbClr val="D0D0D0"/>
-      </a:accent1>
-      <a:accent2>
-        <a:srgbClr val="4169E1"/>
-      </a:accent2>
-      <a:accent3>
-        <a:srgbClr val="4CAF50"/>
-      </a:accent3>
-      <a:accent4>
-        <a:srgbClr val="FEB612"/>
-      </a:accent4>
-      <a:accent5>
-        <a:srgbClr val="F36838"/>
-      </a:accent5>
-      <a:accent6>
-        <a:srgbClr val="8E44AD"/>
-      </a:accent6>
-      <a:hlink>
-        <a:srgbClr val="1E90FF"/>
-      </a:hlink>
-      <a:folHlink>
-        <a:srgbClr val="0097A7"/>
-      </a:folHlink>
-    </a:clrScheme>
-    <a:fontScheme name="Office">
-      <a:majorFont>
-        <a:latin typeface="Arial"/>
-        <a:ea typeface=""/>
-        <a:cs typeface=""/>
-        <a:font script="Jpan" typeface="ＭＳ Ｐゴシック"/>
-        <a:font script="Hang" typeface="맑은 고딕"/>
-        <a:font script="Hans" typeface="宋体"/>
-        <a:font script="Hant" typeface="新細明體"/>
-        <a:font script="Arab" typeface="Times New Roman"/>
-        <a:font script="Hebr" typeface="Times New Roman"/>
-        <a:font script="Thai" typeface="Angsana New"/>
-        <a:font script="Ethi" typeface="Nyala"/>
-        <a:font script="Beng" typeface="Vrinda"/>
-        <a:font script="Gujr" typeface="Shruti"/>
-        <a:font script="Khmr" typeface="MoolBoran"/>
-        <a:font script="Knda" typeface="Tunga"/>
-        <a:font script="Guru" typeface="Raavi"/>
-        <a:font script="Cans" typeface="Euphemia"/>
-        <a:font script="Cher" typeface="Plantagenet Cherokee"/>
-        <a:font script="Yiii" typeface="Microsoft Yi Baiti"/>
-        <a:font script="Tibt" typeface="Microsoft Himalaya"/>
-        <a:font script="Thaa" typeface="MV Boli"/>
-        <a:font script="Deva" typeface="Mangal"/>
-        <a:font script="Telu" typeface="Gautami"/>
-        <a:font script="Taml" typeface="Latha"/>
-        <a:font script="Syrc" typeface="Estrangelo Edessa"/>
-        <a:font script="Orya" typeface="Kalinga"/>
-        <a:font script="Mlym" typeface="Kartika"/>
-        <a:font script="Laoo" typeface="DokChampa"/>
-        <a:font script="Sinh" typeface="Iskoola Pota"/>
-        <a:font script="Mong" typeface="Mongolian Baiti"/>
-        <a:font script="Viet" typeface="Times New Roman"/>
-        <a:font script="Uigh" typeface="Microsoft Uighur"/>
-        <a:font script="Geor" typeface="Sylfaen"/>
-      </a:majorFont>
-      <a:minorFont>
-        <a:latin typeface="Arial"/>
-        <a:ea typeface=""/>
-        <a:cs typeface=""/>
-        <a:font script="Jpan" typeface="ＭＳ Ｐゴシック"/>
-        <a:font script="Hang" typeface="맑은 고딕"/>
-        <a:font script="Hans" typeface="宋体"/>
-        <a:font script="Hant" typeface="新細明體"/>
-        <a:font script="Arab" typeface="Arial"/>
-        <a:font script="Hebr" typeface="Arial"/>
-        <a:font script="Thai" typeface="Cordia New"/>
-        <a:font script="Ethi" typeface="Nyala"/>
-        <a:font script="Beng" typeface="Vrinda"/>
-        <a:font script="Gujr" typeface="Shruti"/>
-        <a:font script="Khmr" typeface="DaunPenh"/>
-        <a:font script="Knda" typeface="Tunga"/>
-        <a:font script="Guru" typeface="Raavi"/>
-        <a:font script="Cans" typeface="Euphemia"/>
-        <a:font script="Cher" typeface="Plantagenet Cherokee"/>
-        <a:font script="Yiii" typeface="Microsoft Yi Baiti"/>
-        <a:font script="Tibt" typeface="Microsoft Himalaya"/>
-        <a:font script="Thaa" typeface="MV Boli"/>
-        <a:font script="Deva" typeface="Mangal"/>
-        <a:font script="Telu" typeface="Gautami"/>
-        <a:font script="Taml" typeface="Latha"/>
-        <a:font script="Syrc" typeface="Estrangelo Edessa"/>
-        <a:font script="Orya" typeface="Kalinga"/>
-        <a:font script="Mlym" typeface="Kartika"/>
-        <a:font script="Laoo" typeface="DokChampa"/>
-        <a:font script="Sinh" typeface="Iskoola Pota"/>
-        <a:font script="Mong" typeface="Mongolian Baiti"/>
-        <a:font script="Viet" typeface="Arial"/>
-        <a:font script="Uigh" typeface="Microsoft Uighur"/>
-        <a:font script="Geor" typeface="Sylfaen"/>
-      </a:minorFont>
-    </a:fontScheme>
-    <a:fmtScheme name="Office">
-      <a:fillStyleLst>
-        <a:solidFill>
-          <a:schemeClr val="phClr"/>
-        </a:solidFill>
-        <a:gradFill rotWithShape="1">
-          <a:gsLst>
-            <a:gs pos="0">
-              <a:schemeClr val="phClr">
-                <a:tint val="50000"/>
-                <a:satMod val="300000"/>
-              </a:schemeClr>
-            </a:gs>
-            <a:gs pos="35000">
-              <a:schemeClr val="phClr">
-                <a:tint val="37000"/>
-                <a:satMod val="300000"/>
-              </a:schemeClr>
-            </a:gs>
-            <a:gs pos="100000">
-              <a:schemeClr val="phClr">
-                <a:tint val="15000"/>
-                <a:satMod val="350000"/>
-              </a:schemeClr>
-            </a:gs>
-          </a:gsLst>
-          <a:lin ang="16200000" scaled="1"/>
-        </a:gradFill>
-        <a:gradFill rotWithShape="1">
-          <a:gsLst>
-            <a:gs pos="0">
-              <a:schemeClr val="phClr">
-                <a:tint val="100000"/>
-                <a:shade val="100000"/>
-                <a:satMod val="130000"/>
-              </a:schemeClr>
-            </a:gs>
-            <a:gs pos="100000">
-              <a:schemeClr val="phClr">
-                <a:tint val="50000"/>
-                <a:shade val="100000"/>
-                <a:satMod val="350000"/>
-              </a:schemeClr>
-            </a:gs>
-          </a:gsLst>
-          <a:lin ang="16200000" scaled="0"/>
-        </a:gradFill>
-      </a:fillStyleLst>
-      <a:lnStyleLst>
-        <a:ln w="9525" cap="flat" cmpd="sng" algn="ctr">
-          <a:solidFill>
-            <a:schemeClr val="phClr">
-              <a:shade val="95000"/>
-              <a:satMod val="105000"/>
-            </a:schemeClr>
-          </a:solidFill>
-          <a:prstDash val="solid"/>
-        </a:ln>
-        <a:ln w="25400" cap="flat" cmpd="sng" algn="ctr">
-          <a:solidFill>
-            <a:schemeClr val="phClr"/>
-          </a:solidFill>
-          <a:prstDash val="solid"/>
-        </a:ln>
-        <a:ln w="38100" cap="flat" cmpd="sng" algn="ctr">
-          <a:solidFill>
-            <a:schemeClr val="phClr"/>
-          </a:solidFill>
-          <a:prstDash val="solid"/>
-        </a:ln>
-      </a:lnStyleLst>
-      <a:effectStyleLst>
-        <a:effectStyle>
-          <a:effectLst>
-            <a:outerShdw blurRad="40000" dist="20000" dir="5400000" rotWithShape="0">
-              <a:srgbClr val="000000">
-                <a:alpha val="38000"/>
-              </a:srgbClr>
-            </a:outerShdw>
-          </a:effectLst>
-        </a:effectStyle>
-        <a:effectStyle>
-          <a:effectLst>
-            <a:outerShdw blurRad="40000" dist="23000" dir="5400000" rotWithShape="0">
-              <a:srgbClr val="000000">
-                <a:alpha val="35000"/>
-              </a:srgbClr>
-            </a:outerShdw>
-          </a:effectLst>
-        </a:effectStyle>
-        <a:effectStyle>
-          <a:effectLst>
-            <a:outerShdw blurRad="40000" dist="23000" dir="5400000" rotWithShape="0">
-              <a:srgbClr val="000000">
-                <a:alpha val="35000"/>
-              </a:srgbClr>
-            </a:outerShdw>
-          </a:effectLst>
-          <a:scene3d>
-            <a:camera prst="orthographicFront">
-              <a:rot lat="0" lon="0" rev="0"/>
-            </a:camera>
-            <a:lightRig rig="threePt" dir="t">
-              <a:rot lat="0" lon="0" rev="1200000"/>
-            </a:lightRig>
-          </a:scene3d>
-          <a:sp3d>
-            <a:bevelT w="63500" h="25400"/>
-          </a:sp3d>
-        </a:effectStyle>
-      </a:effectStyleLst>
-      <a:bgFillStyleLst>
-        <a:solidFill>
-          <a:schemeClr val="phClr"/>
-        </a:solidFill>
-        <a:gradFill rotWithShape="1">
-          <a:gsLst>
-            <a:gs pos="0">
-              <a:schemeClr val="phClr">
-                <a:tint val="40000"/>
-                <a:satMod val="350000"/>
-              </a:schemeClr>
-            </a:gs>
-            <a:gs pos="40000">
-              <a:schemeClr val="phClr">
-                <a:tint val="45000"/>
-                <a:shade val="99000"/>
-                <a:satMod val="350000"/>
-              </a:schemeClr>
-            </a:gs>
-            <a:gs pos="100000">
-              <a:schemeClr val="phClr">
-                <a:shade val="20000"/>
-                <a:satMod val="255000"/>
-              </a:schemeClr>
-            </a:gs>
-          </a:gsLst>
-          <a:path path="circle">
-            <a:fillToRect l="50000" t="-80000" r="50000" b="180000"/>
-          </a:path>
-        </a:gradFill>
-        <a:gradFill rotWithShape="1">
-          <a:gsLst>
-            <a:gs pos="0">
-              <a:schemeClr val="phClr">
-                <a:tint val="80000"/>
-                <a:satMod val="300000"/>
-              </a:schemeClr>
-            </a:gs>
-            <a:gs pos="100000">
-              <a:schemeClr val="phClr">
-                <a:shade val="30000"/>
-                <a:satMod val="200000"/>
-              </a:schemeClr>
-            </a:gs>
-          </a:gsLst>
-          <a:path path="circle">
-            <a:fillToRect l="50000" t="50000" r="50000" b="50000"/>
-          </a:path>
-        </a:gradFill>
-      </a:bgFillStyleLst>
-    </a:fmtScheme>
-  </a:themeElements>
-</a:theme>
-</file>
-
-<file path=ppt/theme/theme3.xml><?xml version="1.0" encoding="utf-8"?>
 <a:theme xmlns:a="http://schemas.openxmlformats.org/drawingml/2006/main" xmlns:r="http://schemas.openxmlformats.org/officeDocument/2006/relationships">
   <a:themeElements>
     <a:clrScheme name="Default">
@@ -28085,4 +27810,283 @@
     </a:fmtScheme>
   </a:themeElements>
 </a:theme>
+</file>
+
+<file path=ppt/theme/theme3.xml><?xml version="1.0" encoding="utf-8"?>
+<a:theme xmlns:a="http://schemas.openxmlformats.org/drawingml/2006/main" xmlns:r="http://schemas.openxmlformats.org/officeDocument/2006/relationships" name="AMOS Slides Template">
+  <a:themeElements>
+    <a:clrScheme name="Simple Light">
+      <a:dk1>
+        <a:srgbClr val="000000"/>
+      </a:dk1>
+      <a:lt1>
+        <a:srgbClr val="FFFFFF"/>
+      </a:lt1>
+      <a:dk2>
+        <a:srgbClr val="404040"/>
+      </a:dk2>
+      <a:lt2>
+        <a:srgbClr val="808080"/>
+      </a:lt2>
+      <a:accent1>
+        <a:srgbClr val="D0D0D0"/>
+      </a:accent1>
+      <a:accent2>
+        <a:srgbClr val="4169E1"/>
+      </a:accent2>
+      <a:accent3>
+        <a:srgbClr val="4CAF50"/>
+      </a:accent3>
+      <a:accent4>
+        <a:srgbClr val="FEB612"/>
+      </a:accent4>
+      <a:accent5>
+        <a:srgbClr val="F36838"/>
+      </a:accent5>
+      <a:accent6>
+        <a:srgbClr val="8E44AD"/>
+      </a:accent6>
+      <a:hlink>
+        <a:srgbClr val="1E90FF"/>
+      </a:hlink>
+      <a:folHlink>
+        <a:srgbClr val="0097A7"/>
+      </a:folHlink>
+    </a:clrScheme>
+    <a:fontScheme name="Office">
+      <a:majorFont>
+        <a:latin typeface="Arial"/>
+        <a:ea typeface=""/>
+        <a:cs typeface=""/>
+        <a:font script="Jpan" typeface="ＭＳ Ｐゴシック"/>
+        <a:font script="Hang" typeface="맑은 고딕"/>
+        <a:font script="Hans" typeface="宋体"/>
+        <a:font script="Hant" typeface="新細明體"/>
+        <a:font script="Arab" typeface="Times New Roman"/>
+        <a:font script="Hebr" typeface="Times New Roman"/>
+        <a:font script="Thai" typeface="Angsana New"/>
+        <a:font script="Ethi" typeface="Nyala"/>
+        <a:font script="Beng" typeface="Vrinda"/>
+        <a:font script="Gujr" typeface="Shruti"/>
+        <a:font script="Khmr" typeface="MoolBoran"/>
+        <a:font script="Knda" typeface="Tunga"/>
+        <a:font script="Guru" typeface="Raavi"/>
+        <a:font script="Cans" typeface="Euphemia"/>
+        <a:font script="Cher" typeface="Plantagenet Cherokee"/>
+        <a:font script="Yiii" typeface="Microsoft Yi Baiti"/>
+        <a:font script="Tibt" typeface="Microsoft Himalaya"/>
+        <a:font script="Thaa" typeface="MV Boli"/>
+        <a:font script="Deva" typeface="Mangal"/>
+        <a:font script="Telu" typeface="Gautami"/>
+        <a:font script="Taml" typeface="Latha"/>
+        <a:font script="Syrc" typeface="Estrangelo Edessa"/>
+        <a:font script="Orya" typeface="Kalinga"/>
+        <a:font script="Mlym" typeface="Kartika"/>
+        <a:font script="Laoo" typeface="DokChampa"/>
+        <a:font script="Sinh" typeface="Iskoola Pota"/>
+        <a:font script="Mong" typeface="Mongolian Baiti"/>
+        <a:font script="Viet" typeface="Times New Roman"/>
+        <a:font script="Uigh" typeface="Microsoft Uighur"/>
+        <a:font script="Geor" typeface="Sylfaen"/>
+      </a:majorFont>
+      <a:minorFont>
+        <a:latin typeface="Arial"/>
+        <a:ea typeface=""/>
+        <a:cs typeface=""/>
+        <a:font script="Jpan" typeface="ＭＳ Ｐゴシック"/>
+        <a:font script="Hang" typeface="맑은 고딕"/>
+        <a:font script="Hans" typeface="宋体"/>
+        <a:font script="Hant" typeface="新細明體"/>
+        <a:font script="Arab" typeface="Arial"/>
+        <a:font script="Hebr" typeface="Arial"/>
+        <a:font script="Thai" typeface="Cordia New"/>
+        <a:font script="Ethi" typeface="Nyala"/>
+        <a:font script="Beng" typeface="Vrinda"/>
+        <a:font script="Gujr" typeface="Shruti"/>
+        <a:font script="Khmr" typeface="DaunPenh"/>
+        <a:font script="Knda" typeface="Tunga"/>
+        <a:font script="Guru" typeface="Raavi"/>
+        <a:font script="Cans" typeface="Euphemia"/>
+        <a:font script="Cher" typeface="Plantagenet Cherokee"/>
+        <a:font script="Yiii" typeface="Microsoft Yi Baiti"/>
+        <a:font script="Tibt" typeface="Microsoft Himalaya"/>
+        <a:font script="Thaa" typeface="MV Boli"/>
+        <a:font script="Deva" typeface="Mangal"/>
+        <a:font script="Telu" typeface="Gautami"/>
+        <a:font script="Taml" typeface="Latha"/>
+        <a:font script="Syrc" typeface="Estrangelo Edessa"/>
+        <a:font script="Orya" typeface="Kalinga"/>
+        <a:font script="Mlym" typeface="Kartika"/>
+        <a:font script="Laoo" typeface="DokChampa"/>
+        <a:font script="Sinh" typeface="Iskoola Pota"/>
+        <a:font script="Mong" typeface="Mongolian Baiti"/>
+        <a:font script="Viet" typeface="Arial"/>
+        <a:font script="Uigh" typeface="Microsoft Uighur"/>
+        <a:font script="Geor" typeface="Sylfaen"/>
+      </a:minorFont>
+    </a:fontScheme>
+    <a:fmtScheme name="Office">
+      <a:fillStyleLst>
+        <a:solidFill>
+          <a:schemeClr val="phClr"/>
+        </a:solidFill>
+        <a:gradFill rotWithShape="1">
+          <a:gsLst>
+            <a:gs pos="0">
+              <a:schemeClr val="phClr">
+                <a:tint val="50000"/>
+                <a:satMod val="300000"/>
+              </a:schemeClr>
+            </a:gs>
+            <a:gs pos="35000">
+              <a:schemeClr val="phClr">
+                <a:tint val="37000"/>
+                <a:satMod val="300000"/>
+              </a:schemeClr>
+            </a:gs>
+            <a:gs pos="100000">
+              <a:schemeClr val="phClr">
+                <a:tint val="15000"/>
+                <a:satMod val="350000"/>
+              </a:schemeClr>
+            </a:gs>
+          </a:gsLst>
+          <a:lin ang="16200000" scaled="1"/>
+        </a:gradFill>
+        <a:gradFill rotWithShape="1">
+          <a:gsLst>
+            <a:gs pos="0">
+              <a:schemeClr val="phClr">
+                <a:tint val="100000"/>
+                <a:shade val="100000"/>
+                <a:satMod val="130000"/>
+              </a:schemeClr>
+            </a:gs>
+            <a:gs pos="100000">
+              <a:schemeClr val="phClr">
+                <a:tint val="50000"/>
+                <a:shade val="100000"/>
+                <a:satMod val="350000"/>
+              </a:schemeClr>
+            </a:gs>
+          </a:gsLst>
+          <a:lin ang="16200000" scaled="0"/>
+        </a:gradFill>
+      </a:fillStyleLst>
+      <a:lnStyleLst>
+        <a:ln w="9525" cap="flat" cmpd="sng" algn="ctr">
+          <a:solidFill>
+            <a:schemeClr val="phClr">
+              <a:shade val="95000"/>
+              <a:satMod val="105000"/>
+            </a:schemeClr>
+          </a:solidFill>
+          <a:prstDash val="solid"/>
+        </a:ln>
+        <a:ln w="25400" cap="flat" cmpd="sng" algn="ctr">
+          <a:solidFill>
+            <a:schemeClr val="phClr"/>
+          </a:solidFill>
+          <a:prstDash val="solid"/>
+        </a:ln>
+        <a:ln w="38100" cap="flat" cmpd="sng" algn="ctr">
+          <a:solidFill>
+            <a:schemeClr val="phClr"/>
+          </a:solidFill>
+          <a:prstDash val="solid"/>
+        </a:ln>
+      </a:lnStyleLst>
+      <a:effectStyleLst>
+        <a:effectStyle>
+          <a:effectLst>
+            <a:outerShdw blurRad="40000" dist="20000" dir="5400000" rotWithShape="0">
+              <a:srgbClr val="000000">
+                <a:alpha val="38000"/>
+              </a:srgbClr>
+            </a:outerShdw>
+          </a:effectLst>
+        </a:effectStyle>
+        <a:effectStyle>
+          <a:effectLst>
+            <a:outerShdw blurRad="40000" dist="23000" dir="5400000" rotWithShape="0">
+              <a:srgbClr val="000000">
+                <a:alpha val="35000"/>
+              </a:srgbClr>
+            </a:outerShdw>
+          </a:effectLst>
+        </a:effectStyle>
+        <a:effectStyle>
+          <a:effectLst>
+            <a:outerShdw blurRad="40000" dist="23000" dir="5400000" rotWithShape="0">
+              <a:srgbClr val="000000">
+                <a:alpha val="35000"/>
+              </a:srgbClr>
+            </a:outerShdw>
+          </a:effectLst>
+          <a:scene3d>
+            <a:camera prst="orthographicFront">
+              <a:rot lat="0" lon="0" rev="0"/>
+            </a:camera>
+            <a:lightRig rig="threePt" dir="t">
+              <a:rot lat="0" lon="0" rev="1200000"/>
+            </a:lightRig>
+          </a:scene3d>
+          <a:sp3d>
+            <a:bevelT w="63500" h="25400"/>
+          </a:sp3d>
+        </a:effectStyle>
+      </a:effectStyleLst>
+      <a:bgFillStyleLst>
+        <a:solidFill>
+          <a:schemeClr val="phClr"/>
+        </a:solidFill>
+        <a:gradFill rotWithShape="1">
+          <a:gsLst>
+            <a:gs pos="0">
+              <a:schemeClr val="phClr">
+                <a:tint val="40000"/>
+                <a:satMod val="350000"/>
+              </a:schemeClr>
+            </a:gs>
+            <a:gs pos="40000">
+              <a:schemeClr val="phClr">
+                <a:tint val="45000"/>
+                <a:shade val="99000"/>
+                <a:satMod val="350000"/>
+              </a:schemeClr>
+            </a:gs>
+            <a:gs pos="100000">
+              <a:schemeClr val="phClr">
+                <a:shade val="20000"/>
+                <a:satMod val="255000"/>
+              </a:schemeClr>
+            </a:gs>
+          </a:gsLst>
+          <a:path path="circle">
+            <a:fillToRect l="50000" t="-80000" r="50000" b="180000"/>
+          </a:path>
+        </a:gradFill>
+        <a:gradFill rotWithShape="1">
+          <a:gsLst>
+            <a:gs pos="0">
+              <a:schemeClr val="phClr">
+                <a:tint val="80000"/>
+                <a:satMod val="300000"/>
+              </a:schemeClr>
+            </a:gs>
+            <a:gs pos="100000">
+              <a:schemeClr val="phClr">
+                <a:shade val="30000"/>
+                <a:satMod val="200000"/>
+              </a:schemeClr>
+            </a:gs>
+          </a:gsLst>
+          <a:path path="circle">
+            <a:fillToRect l="50000" t="50000" r="50000" b="50000"/>
+          </a:path>
+        </a:gradFill>
+      </a:bgFillStyleLst>
+    </a:fmtScheme>
+  </a:themeElements>
+</a:theme>
 </file>
</xml_diff>

<commit_message>
Updates for AMOS-27 winter 2026/27
</commit_message>
<xml_diff>
--- a/Lecture slides/AMOS A01 - Introduction.pptx
+++ b/Lecture slides/AMOS A01 - Introduction.pptx
@@ -68,7 +68,7 @@
         <a:srgbClr val="000000"/>
       </a:buClr>
       <a:buFont typeface="Arial"/>
-      <a:defRPr b="0" i="0" sz="1400" u="none" cap="none" strike="noStrike">
+      <a:defRPr b="0" i="0" spc="0" sz="1400" u="none" cap="none" strike="noStrike">
         <a:solidFill>
           <a:srgbClr val="000000"/>
         </a:solidFill>
@@ -92,7 +92,7 @@
         <a:srgbClr val="000000"/>
       </a:buClr>
       <a:buFont typeface="Arial"/>
-      <a:defRPr b="0" i="0" sz="1400" u="none" cap="none" strike="noStrike">
+      <a:defRPr b="0" i="0" spc="0" sz="1400" u="none" cap="none" strike="noStrike">
         <a:solidFill>
           <a:srgbClr val="000000"/>
         </a:solidFill>
@@ -116,7 +116,7 @@
         <a:srgbClr val="000000"/>
       </a:buClr>
       <a:buFont typeface="Arial"/>
-      <a:defRPr b="0" i="0" sz="1400" u="none" cap="none" strike="noStrike">
+      <a:defRPr b="0" i="0" spc="0" sz="1400" u="none" cap="none" strike="noStrike">
         <a:solidFill>
           <a:srgbClr val="000000"/>
         </a:solidFill>
@@ -140,7 +140,7 @@
         <a:srgbClr val="000000"/>
       </a:buClr>
       <a:buFont typeface="Arial"/>
-      <a:defRPr b="0" i="0" sz="1400" u="none" cap="none" strike="noStrike">
+      <a:defRPr b="0" i="0" spc="0" sz="1400" u="none" cap="none" strike="noStrike">
         <a:solidFill>
           <a:srgbClr val="000000"/>
         </a:solidFill>
@@ -164,7 +164,7 @@
         <a:srgbClr val="000000"/>
       </a:buClr>
       <a:buFont typeface="Arial"/>
-      <a:defRPr b="0" i="0" sz="1400" u="none" cap="none" strike="noStrike">
+      <a:defRPr b="0" i="0" spc="0" sz="1400" u="none" cap="none" strike="noStrike">
         <a:solidFill>
           <a:srgbClr val="000000"/>
         </a:solidFill>
@@ -188,7 +188,7 @@
         <a:srgbClr val="000000"/>
       </a:buClr>
       <a:buFont typeface="Arial"/>
-      <a:defRPr b="0" i="0" sz="1400" u="none" cap="none" strike="noStrike">
+      <a:defRPr b="0" i="0" spc="0" sz="1400" u="none" cap="none" strike="noStrike">
         <a:solidFill>
           <a:srgbClr val="000000"/>
         </a:solidFill>
@@ -212,7 +212,7 @@
         <a:srgbClr val="000000"/>
       </a:buClr>
       <a:buFont typeface="Arial"/>
-      <a:defRPr b="0" i="0" sz="1400" u="none" cap="none" strike="noStrike">
+      <a:defRPr b="0" i="0" spc="0" sz="1400" u="none" cap="none" strike="noStrike">
         <a:solidFill>
           <a:srgbClr val="000000"/>
         </a:solidFill>
@@ -236,7 +236,7 @@
         <a:srgbClr val="000000"/>
       </a:buClr>
       <a:buFont typeface="Arial"/>
-      <a:defRPr b="0" i="0" sz="1400" u="none" cap="none" strike="noStrike">
+      <a:defRPr b="0" i="0" spc="0" sz="1400" u="none" cap="none" strike="noStrike">
         <a:solidFill>
           <a:srgbClr val="000000"/>
         </a:solidFill>
@@ -260,7 +260,7 @@
         <a:srgbClr val="000000"/>
       </a:buClr>
       <a:buFont typeface="Arial"/>
-      <a:defRPr b="0" i="0" sz="1400" u="none" cap="none" strike="noStrike">
+      <a:defRPr b="0" i="0" spc="0" sz="1400" u="none" cap="none" strike="noStrike">
         <a:solidFill>
           <a:srgbClr val="000000"/>
         </a:solidFill>
@@ -510,7 +510,7 @@
         <a:srgbClr val="000000"/>
       </a:buClr>
       <a:buFont typeface="Arial"/>
-      <a:defRPr b="0" i="0" sz="1400" u="none" cap="none" strike="noStrike">
+      <a:defRPr b="0" i="0" spc="0" sz="1400" u="none" cap="none" strike="noStrike">
         <a:solidFill>
           <a:srgbClr val="000000"/>
         </a:solidFill>
@@ -534,7 +534,7 @@
         <a:srgbClr val="000000"/>
       </a:buClr>
       <a:buFont typeface="Arial"/>
-      <a:defRPr b="0" i="0" sz="1400" u="none" cap="none" strike="noStrike">
+      <a:defRPr b="0" i="0" spc="0" sz="1400" u="none" cap="none" strike="noStrike">
         <a:solidFill>
           <a:srgbClr val="000000"/>
         </a:solidFill>
@@ -558,7 +558,7 @@
         <a:srgbClr val="000000"/>
       </a:buClr>
       <a:buFont typeface="Arial"/>
-      <a:defRPr b="0" i="0" sz="1400" u="none" cap="none" strike="noStrike">
+      <a:defRPr b="0" i="0" spc="0" sz="1400" u="none" cap="none" strike="noStrike">
         <a:solidFill>
           <a:srgbClr val="000000"/>
         </a:solidFill>
@@ -582,7 +582,7 @@
         <a:srgbClr val="000000"/>
       </a:buClr>
       <a:buFont typeface="Arial"/>
-      <a:defRPr b="0" i="0" sz="1400" u="none" cap="none" strike="noStrike">
+      <a:defRPr b="0" i="0" spc="0" sz="1400" u="none" cap="none" strike="noStrike">
         <a:solidFill>
           <a:srgbClr val="000000"/>
         </a:solidFill>
@@ -606,7 +606,7 @@
         <a:srgbClr val="000000"/>
       </a:buClr>
       <a:buFont typeface="Arial"/>
-      <a:defRPr b="0" i="0" sz="1400" u="none" cap="none" strike="noStrike">
+      <a:defRPr b="0" i="0" spc="0" sz="1400" u="none" cap="none" strike="noStrike">
         <a:solidFill>
           <a:srgbClr val="000000"/>
         </a:solidFill>
@@ -630,7 +630,7 @@
         <a:srgbClr val="000000"/>
       </a:buClr>
       <a:buFont typeface="Arial"/>
-      <a:defRPr b="0" i="0" sz="1400" u="none" cap="none" strike="noStrike">
+      <a:defRPr b="0" i="0" spc="0" sz="1400" u="none" cap="none" strike="noStrike">
         <a:solidFill>
           <a:srgbClr val="000000"/>
         </a:solidFill>
@@ -654,7 +654,7 @@
         <a:srgbClr val="000000"/>
       </a:buClr>
       <a:buFont typeface="Arial"/>
-      <a:defRPr b="0" i="0" sz="1400" u="none" cap="none" strike="noStrike">
+      <a:defRPr b="0" i="0" spc="0" sz="1400" u="none" cap="none" strike="noStrike">
         <a:solidFill>
           <a:srgbClr val="000000"/>
         </a:solidFill>
@@ -678,7 +678,7 @@
         <a:srgbClr val="000000"/>
       </a:buClr>
       <a:buFont typeface="Arial"/>
-      <a:defRPr b="0" i="0" sz="1400" u="none" cap="none" strike="noStrike">
+      <a:defRPr b="0" i="0" spc="0" sz="1400" u="none" cap="none" strike="noStrike">
         <a:solidFill>
           <a:srgbClr val="000000"/>
         </a:solidFill>
@@ -702,7 +702,7 @@
         <a:srgbClr val="000000"/>
       </a:buClr>
       <a:buFont typeface="Arial"/>
-      <a:defRPr b="0" i="0" sz="1400" u="none" cap="none" strike="noStrike">
+      <a:defRPr b="0" i="0" spc="0" sz="1400" u="none" cap="none" strike="noStrike">
         <a:solidFill>
           <a:srgbClr val="000000"/>
         </a:solidFill>
@@ -2121,7 +2121,7 @@
       </p:grpSpPr>
       <p:sp>
         <p:nvSpPr>
-          <p:cNvPr id="241" name="Google Shape;241;g23985d0d2d4_0_100:notes"/>
+          <p:cNvPr id="241" name="Google Shape;241;h16d105fe7552a398_0_145:notes"/>
           <p:cNvSpPr/>
           <p:nvPr>
             <p:ph idx="2" type="sldImg"/>
@@ -2156,7 +2156,7 @@
       </p:sp>
       <p:sp>
         <p:nvSpPr>
-          <p:cNvPr id="242" name="Google Shape;242;g23985d0d2d4_0_100:notes"/>
+          <p:cNvPr id="242" name="Google Shape;242;h16d105fe7552a398_0_145:notes"/>
           <p:cNvSpPr txBox="1"/>
           <p:nvPr>
             <p:ph idx="1" type="body"/>
@@ -3309,7 +3309,7 @@
       </p:grpSpPr>
       <p:sp>
         <p:nvSpPr>
-          <p:cNvPr id="124" name="Google Shape;124;g396f953ff6f_0_48:notes"/>
+          <p:cNvPr id="124" name="Google Shape;124;hd67168c52d779f0_0_192:notes"/>
           <p:cNvSpPr/>
           <p:nvPr>
             <p:ph idx="2" type="sldImg"/>
@@ -3344,7 +3344,7 @@
       </p:sp>
       <p:sp>
         <p:nvSpPr>
-          <p:cNvPr id="125" name="Google Shape;125;g396f953ff6f_0_48:notes"/>
+          <p:cNvPr id="125" name="Google Shape;125;hd67168c52d779f0_0_192:notes"/>
           <p:cNvSpPr txBox="1"/>
           <p:nvPr>
             <p:ph idx="1" type="body"/>
@@ -3408,7 +3408,7 @@
       </p:grpSpPr>
       <p:sp>
         <p:nvSpPr>
-          <p:cNvPr id="131" name="Google Shape;131;g38c894a4d12_0_48:notes"/>
+          <p:cNvPr id="131" name="Google Shape;131;h16d105fe7552a398_0_48:notes"/>
           <p:cNvSpPr/>
           <p:nvPr>
             <p:ph idx="2" type="sldImg"/>
@@ -3443,7 +3443,7 @@
       </p:sp>
       <p:sp>
         <p:nvSpPr>
-          <p:cNvPr id="132" name="Google Shape;132;g38c894a4d12_0_48:notes"/>
+          <p:cNvPr id="132" name="Google Shape;132;h16d105fe7552a398_0_48:notes"/>
           <p:cNvSpPr txBox="1"/>
           <p:nvPr>
             <p:ph idx="1" type="body"/>
@@ -5992,7 +5992,7 @@
                 </a:solidFill>
                 <a:hlinkClick r:id="rId2"/>
               </a:rPr>
-              <a:t>https://oss.cs.fau.de</a:t>
+              <a:t>https://uni1.de/amos</a:t>
             </a:r>
             <a:r>
               <a:rPr b="0" lang="en" sz="900">
@@ -6690,7 +6690,15 @@
                 </a:solidFill>
                 <a:hlinkClick r:id="rId2"/>
               </a:rPr>
-              <a:t>https://oss.cs.fau.de</a:t>
+              <a:t>https://uni1.de/amos</a:t>
+            </a:r>
+            <a:r>
+              <a:rPr b="0" lang="en" sz="900">
+                <a:solidFill>
+                  <a:schemeClr val="dk2"/>
+                </a:solidFill>
+              </a:rPr>
+              <a:t> </a:t>
             </a:r>
             <a:endParaRPr>
               <a:solidFill>
@@ -9197,7 +9205,7 @@
                 </a:solidFill>
                 <a:hlinkClick r:id="rId1"/>
               </a:rPr>
-              <a:t>https://oss.cs.fau.de</a:t>
+              <a:t>https://uni1.de/amos</a:t>
             </a:r>
             <a:r>
               <a:rPr b="0" lang="en" sz="900"/>
@@ -9246,7 +9254,7 @@
           <a:srgbClr val="000000"/>
         </a:buClr>
         <a:buFont typeface="Arial"/>
-        <a:defRPr b="0" i="0" sz="1400" u="none" cap="none" strike="noStrike">
+        <a:defRPr b="0" i="0" spc="0" sz="1400" u="none" cap="none" strike="noStrike">
           <a:solidFill>
             <a:srgbClr val="000000"/>
           </a:solidFill>
@@ -9270,7 +9278,7 @@
           <a:srgbClr val="000000"/>
         </a:buClr>
         <a:buFont typeface="Arial"/>
-        <a:defRPr b="0" i="0" sz="1400" u="none" cap="none" strike="noStrike">
+        <a:defRPr b="0" i="0" spc="0" sz="1400" u="none" cap="none" strike="noStrike">
           <a:solidFill>
             <a:srgbClr val="000000"/>
           </a:solidFill>
@@ -9294,7 +9302,7 @@
           <a:srgbClr val="000000"/>
         </a:buClr>
         <a:buFont typeface="Arial"/>
-        <a:defRPr b="0" i="0" sz="1400" u="none" cap="none" strike="noStrike">
+        <a:defRPr b="0" i="0" spc="0" sz="1400" u="none" cap="none" strike="noStrike">
           <a:solidFill>
             <a:srgbClr val="000000"/>
           </a:solidFill>
@@ -9318,7 +9326,7 @@
           <a:srgbClr val="000000"/>
         </a:buClr>
         <a:buFont typeface="Arial"/>
-        <a:defRPr b="0" i="0" sz="1400" u="none" cap="none" strike="noStrike">
+        <a:defRPr b="0" i="0" spc="0" sz="1400" u="none" cap="none" strike="noStrike">
           <a:solidFill>
             <a:srgbClr val="000000"/>
           </a:solidFill>
@@ -9342,7 +9350,7 @@
           <a:srgbClr val="000000"/>
         </a:buClr>
         <a:buFont typeface="Arial"/>
-        <a:defRPr b="0" i="0" sz="1400" u="none" cap="none" strike="noStrike">
+        <a:defRPr b="0" i="0" spc="0" sz="1400" u="none" cap="none" strike="noStrike">
           <a:solidFill>
             <a:srgbClr val="000000"/>
           </a:solidFill>
@@ -9366,7 +9374,7 @@
           <a:srgbClr val="000000"/>
         </a:buClr>
         <a:buFont typeface="Arial"/>
-        <a:defRPr b="0" i="0" sz="1400" u="none" cap="none" strike="noStrike">
+        <a:defRPr b="0" i="0" spc="0" sz="1400" u="none" cap="none" strike="noStrike">
           <a:solidFill>
             <a:srgbClr val="000000"/>
           </a:solidFill>
@@ -9390,7 +9398,7 @@
           <a:srgbClr val="000000"/>
         </a:buClr>
         <a:buFont typeface="Arial"/>
-        <a:defRPr b="0" i="0" sz="1400" u="none" cap="none" strike="noStrike">
+        <a:defRPr b="0" i="0" spc="0" sz="1400" u="none" cap="none" strike="noStrike">
           <a:solidFill>
             <a:srgbClr val="000000"/>
           </a:solidFill>
@@ -9414,7 +9422,7 @@
           <a:srgbClr val="000000"/>
         </a:buClr>
         <a:buFont typeface="Arial"/>
-        <a:defRPr b="0" i="0" sz="1400" u="none" cap="none" strike="noStrike">
+        <a:defRPr b="0" i="0" spc="0" sz="1400" u="none" cap="none" strike="noStrike">
           <a:solidFill>
             <a:srgbClr val="000000"/>
           </a:solidFill>
@@ -9438,7 +9446,7 @@
           <a:srgbClr val="000000"/>
         </a:buClr>
         <a:buFont typeface="Arial"/>
-        <a:defRPr b="0" i="0" sz="1400" u="none" cap="none" strike="noStrike">
+        <a:defRPr b="0" i="0" spc="0" sz="1400" u="none" cap="none" strike="noStrike">
           <a:solidFill>
             <a:srgbClr val="000000"/>
           </a:solidFill>
@@ -9475,7 +9483,7 @@
           <a:srgbClr val="000000"/>
         </a:buClr>
         <a:buFont typeface="Arial"/>
-        <a:defRPr b="0" i="0" sz="1400" u="none" cap="none" strike="noStrike">
+        <a:defRPr b="0" i="0" spc="0" sz="1400" u="none" cap="none" strike="noStrike">
           <a:solidFill>
             <a:srgbClr val="000000"/>
           </a:solidFill>
@@ -9499,7 +9507,7 @@
           <a:srgbClr val="000000"/>
         </a:buClr>
         <a:buFont typeface="Arial"/>
-        <a:defRPr b="0" i="0" sz="1400" u="none" cap="none" strike="noStrike">
+        <a:defRPr b="0" i="0" spc="0" sz="1400" u="none" cap="none" strike="noStrike">
           <a:solidFill>
             <a:srgbClr val="000000"/>
           </a:solidFill>
@@ -9523,7 +9531,7 @@
           <a:srgbClr val="000000"/>
         </a:buClr>
         <a:buFont typeface="Arial"/>
-        <a:defRPr b="0" i="0" sz="1400" u="none" cap="none" strike="noStrike">
+        <a:defRPr b="0" i="0" spc="0" sz="1400" u="none" cap="none" strike="noStrike">
           <a:solidFill>
             <a:srgbClr val="000000"/>
           </a:solidFill>
@@ -9547,7 +9555,7 @@
           <a:srgbClr val="000000"/>
         </a:buClr>
         <a:buFont typeface="Arial"/>
-        <a:defRPr b="0" i="0" sz="1400" u="none" cap="none" strike="noStrike">
+        <a:defRPr b="0" i="0" spc="0" sz="1400" u="none" cap="none" strike="noStrike">
           <a:solidFill>
             <a:srgbClr val="000000"/>
           </a:solidFill>
@@ -9571,7 +9579,7 @@
           <a:srgbClr val="000000"/>
         </a:buClr>
         <a:buFont typeface="Arial"/>
-        <a:defRPr b="0" i="0" sz="1400" u="none" cap="none" strike="noStrike">
+        <a:defRPr b="0" i="0" spc="0" sz="1400" u="none" cap="none" strike="noStrike">
           <a:solidFill>
             <a:srgbClr val="000000"/>
           </a:solidFill>
@@ -9595,7 +9603,7 @@
           <a:srgbClr val="000000"/>
         </a:buClr>
         <a:buFont typeface="Arial"/>
-        <a:defRPr b="0" i="0" sz="1400" u="none" cap="none" strike="noStrike">
+        <a:defRPr b="0" i="0" spc="0" sz="1400" u="none" cap="none" strike="noStrike">
           <a:solidFill>
             <a:srgbClr val="000000"/>
           </a:solidFill>
@@ -9619,7 +9627,7 @@
           <a:srgbClr val="000000"/>
         </a:buClr>
         <a:buFont typeface="Arial"/>
-        <a:defRPr b="0" i="0" sz="1400" u="none" cap="none" strike="noStrike">
+        <a:defRPr b="0" i="0" spc="0" sz="1400" u="none" cap="none" strike="noStrike">
           <a:solidFill>
             <a:srgbClr val="000000"/>
           </a:solidFill>
@@ -9643,7 +9651,7 @@
           <a:srgbClr val="000000"/>
         </a:buClr>
         <a:buFont typeface="Arial"/>
-        <a:defRPr b="0" i="0" sz="1400" u="none" cap="none" strike="noStrike">
+        <a:defRPr b="0" i="0" spc="0" sz="1400" u="none" cap="none" strike="noStrike">
           <a:solidFill>
             <a:srgbClr val="000000"/>
           </a:solidFill>
@@ -9667,7 +9675,7 @@
           <a:srgbClr val="000000"/>
         </a:buClr>
         <a:buFont typeface="Arial"/>
-        <a:defRPr b="0" i="0" sz="1400" u="none" cap="none" strike="noStrike">
+        <a:defRPr b="0" i="0" spc="0" sz="1400" u="none" cap="none" strike="noStrike">
           <a:solidFill>
             <a:srgbClr val="000000"/>
           </a:solidFill>
@@ -9704,7 +9712,7 @@
           <a:srgbClr val="000000"/>
         </a:buClr>
         <a:buFont typeface="Arial"/>
-        <a:defRPr b="0" i="0" sz="1400" u="none" cap="none" strike="noStrike">
+        <a:defRPr b="0" i="0" spc="0" sz="1400" u="none" cap="none" strike="noStrike">
           <a:solidFill>
             <a:srgbClr val="000000"/>
           </a:solidFill>
@@ -9728,7 +9736,7 @@
           <a:srgbClr val="000000"/>
         </a:buClr>
         <a:buFont typeface="Arial"/>
-        <a:defRPr b="0" i="0" sz="1400" u="none" cap="none" strike="noStrike">
+        <a:defRPr b="0" i="0" spc="0" sz="1400" u="none" cap="none" strike="noStrike">
           <a:solidFill>
             <a:srgbClr val="000000"/>
           </a:solidFill>
@@ -9752,7 +9760,7 @@
           <a:srgbClr val="000000"/>
         </a:buClr>
         <a:buFont typeface="Arial"/>
-        <a:defRPr b="0" i="0" sz="1400" u="none" cap="none" strike="noStrike">
+        <a:defRPr b="0" i="0" spc="0" sz="1400" u="none" cap="none" strike="noStrike">
           <a:solidFill>
             <a:srgbClr val="000000"/>
           </a:solidFill>
@@ -9776,7 +9784,7 @@
           <a:srgbClr val="000000"/>
         </a:buClr>
         <a:buFont typeface="Arial"/>
-        <a:defRPr b="0" i="0" sz="1400" u="none" cap="none" strike="noStrike">
+        <a:defRPr b="0" i="0" spc="0" sz="1400" u="none" cap="none" strike="noStrike">
           <a:solidFill>
             <a:srgbClr val="000000"/>
           </a:solidFill>
@@ -9800,7 +9808,7 @@
           <a:srgbClr val="000000"/>
         </a:buClr>
         <a:buFont typeface="Arial"/>
-        <a:defRPr b="0" i="0" sz="1400" u="none" cap="none" strike="noStrike">
+        <a:defRPr b="0" i="0" spc="0" sz="1400" u="none" cap="none" strike="noStrike">
           <a:solidFill>
             <a:srgbClr val="000000"/>
           </a:solidFill>
@@ -9824,7 +9832,7 @@
           <a:srgbClr val="000000"/>
         </a:buClr>
         <a:buFont typeface="Arial"/>
-        <a:defRPr b="0" i="0" sz="1400" u="none" cap="none" strike="noStrike">
+        <a:defRPr b="0" i="0" spc="0" sz="1400" u="none" cap="none" strike="noStrike">
           <a:solidFill>
             <a:srgbClr val="000000"/>
           </a:solidFill>
@@ -9848,7 +9856,7 @@
           <a:srgbClr val="000000"/>
         </a:buClr>
         <a:buFont typeface="Arial"/>
-        <a:defRPr b="0" i="0" sz="1400" u="none" cap="none" strike="noStrike">
+        <a:defRPr b="0" i="0" spc="0" sz="1400" u="none" cap="none" strike="noStrike">
           <a:solidFill>
             <a:srgbClr val="000000"/>
           </a:solidFill>
@@ -9872,7 +9880,7 @@
           <a:srgbClr val="000000"/>
         </a:buClr>
         <a:buFont typeface="Arial"/>
-        <a:defRPr b="0" i="0" sz="1400" u="none" cap="none" strike="noStrike">
+        <a:defRPr b="0" i="0" spc="0" sz="1400" u="none" cap="none" strike="noStrike">
           <a:solidFill>
             <a:srgbClr val="000000"/>
           </a:solidFill>
@@ -9896,7 +9904,7 @@
           <a:srgbClr val="000000"/>
         </a:buClr>
         <a:buFont typeface="Arial"/>
-        <a:defRPr b="0" i="0" sz="1400" u="none" cap="none" strike="noStrike">
+        <a:defRPr b="0" i="0" spc="0" sz="1400" u="none" cap="none" strike="noStrike">
           <a:solidFill>
             <a:srgbClr val="000000"/>
           </a:solidFill>
@@ -10527,7 +10535,7 @@
           <a:srgbClr val="000000"/>
         </a:buClr>
         <a:buFont typeface="Arial"/>
-        <a:defRPr b="0" i="0" sz="1400" u="none" cap="none" strike="noStrike">
+        <a:defRPr b="0" i="0" spc="0" sz="1400" u="none" cap="none" strike="noStrike">
           <a:solidFill>
             <a:srgbClr val="000000"/>
           </a:solidFill>
@@ -10551,7 +10559,7 @@
           <a:srgbClr val="000000"/>
         </a:buClr>
         <a:buFont typeface="Arial"/>
-        <a:defRPr b="0" i="0" sz="1400" u="none" cap="none" strike="noStrike">
+        <a:defRPr b="0" i="0" spc="0" sz="1400" u="none" cap="none" strike="noStrike">
           <a:solidFill>
             <a:srgbClr val="000000"/>
           </a:solidFill>
@@ -10575,7 +10583,7 @@
           <a:srgbClr val="000000"/>
         </a:buClr>
         <a:buFont typeface="Arial"/>
-        <a:defRPr b="0" i="0" sz="1400" u="none" cap="none" strike="noStrike">
+        <a:defRPr b="0" i="0" spc="0" sz="1400" u="none" cap="none" strike="noStrike">
           <a:solidFill>
             <a:srgbClr val="000000"/>
           </a:solidFill>
@@ -10599,7 +10607,7 @@
           <a:srgbClr val="000000"/>
         </a:buClr>
         <a:buFont typeface="Arial"/>
-        <a:defRPr b="0" i="0" sz="1400" u="none" cap="none" strike="noStrike">
+        <a:defRPr b="0" i="0" spc="0" sz="1400" u="none" cap="none" strike="noStrike">
           <a:solidFill>
             <a:srgbClr val="000000"/>
           </a:solidFill>
@@ -10623,7 +10631,7 @@
           <a:srgbClr val="000000"/>
         </a:buClr>
         <a:buFont typeface="Arial"/>
-        <a:defRPr b="0" i="0" sz="1400" u="none" cap="none" strike="noStrike">
+        <a:defRPr b="0" i="0" spc="0" sz="1400" u="none" cap="none" strike="noStrike">
           <a:solidFill>
             <a:srgbClr val="000000"/>
           </a:solidFill>
@@ -10647,7 +10655,7 @@
           <a:srgbClr val="000000"/>
         </a:buClr>
         <a:buFont typeface="Arial"/>
-        <a:defRPr b="0" i="0" sz="1400" u="none" cap="none" strike="noStrike">
+        <a:defRPr b="0" i="0" spc="0" sz="1400" u="none" cap="none" strike="noStrike">
           <a:solidFill>
             <a:srgbClr val="000000"/>
           </a:solidFill>
@@ -10671,7 +10679,7 @@
           <a:srgbClr val="000000"/>
         </a:buClr>
         <a:buFont typeface="Arial"/>
-        <a:defRPr b="0" i="0" sz="1400" u="none" cap="none" strike="noStrike">
+        <a:defRPr b="0" i="0" spc="0" sz="1400" u="none" cap="none" strike="noStrike">
           <a:solidFill>
             <a:srgbClr val="000000"/>
           </a:solidFill>
@@ -10695,7 +10703,7 @@
           <a:srgbClr val="000000"/>
         </a:buClr>
         <a:buFont typeface="Arial"/>
-        <a:defRPr b="0" i="0" sz="1400" u="none" cap="none" strike="noStrike">
+        <a:defRPr b="0" i="0" spc="0" sz="1400" u="none" cap="none" strike="noStrike">
           <a:solidFill>
             <a:srgbClr val="000000"/>
           </a:solidFill>
@@ -10719,7 +10727,7 @@
           <a:srgbClr val="000000"/>
         </a:buClr>
         <a:buFont typeface="Arial"/>
-        <a:defRPr b="0" i="0" sz="1400" u="none" cap="none" strike="noStrike">
+        <a:defRPr b="0" i="0" spc="0" sz="1400" u="none" cap="none" strike="noStrike">
           <a:solidFill>
             <a:srgbClr val="000000"/>
           </a:solidFill>
@@ -10756,7 +10764,7 @@
           <a:srgbClr val="000000"/>
         </a:buClr>
         <a:buFont typeface="Arial"/>
-        <a:defRPr b="0" i="0" sz="1400" u="none" cap="none" strike="noStrike">
+        <a:defRPr b="0" i="0" spc="0" sz="1400" u="none" cap="none" strike="noStrike">
           <a:solidFill>
             <a:srgbClr val="000000"/>
           </a:solidFill>
@@ -10780,7 +10788,7 @@
           <a:srgbClr val="000000"/>
         </a:buClr>
         <a:buFont typeface="Arial"/>
-        <a:defRPr b="0" i="0" sz="1400" u="none" cap="none" strike="noStrike">
+        <a:defRPr b="0" i="0" spc="0" sz="1400" u="none" cap="none" strike="noStrike">
           <a:solidFill>
             <a:srgbClr val="000000"/>
           </a:solidFill>
@@ -10804,7 +10812,7 @@
           <a:srgbClr val="000000"/>
         </a:buClr>
         <a:buFont typeface="Arial"/>
-        <a:defRPr b="0" i="0" sz="1400" u="none" cap="none" strike="noStrike">
+        <a:defRPr b="0" i="0" spc="0" sz="1400" u="none" cap="none" strike="noStrike">
           <a:solidFill>
             <a:srgbClr val="000000"/>
           </a:solidFill>
@@ -10828,7 +10836,7 @@
           <a:srgbClr val="000000"/>
         </a:buClr>
         <a:buFont typeface="Arial"/>
-        <a:defRPr b="0" i="0" sz="1400" u="none" cap="none" strike="noStrike">
+        <a:defRPr b="0" i="0" spc="0" sz="1400" u="none" cap="none" strike="noStrike">
           <a:solidFill>
             <a:srgbClr val="000000"/>
           </a:solidFill>
@@ -10852,7 +10860,7 @@
           <a:srgbClr val="000000"/>
         </a:buClr>
         <a:buFont typeface="Arial"/>
-        <a:defRPr b="0" i="0" sz="1400" u="none" cap="none" strike="noStrike">
+        <a:defRPr b="0" i="0" spc="0" sz="1400" u="none" cap="none" strike="noStrike">
           <a:solidFill>
             <a:srgbClr val="000000"/>
           </a:solidFill>
@@ -10876,7 +10884,7 @@
           <a:srgbClr val="000000"/>
         </a:buClr>
         <a:buFont typeface="Arial"/>
-        <a:defRPr b="0" i="0" sz="1400" u="none" cap="none" strike="noStrike">
+        <a:defRPr b="0" i="0" spc="0" sz="1400" u="none" cap="none" strike="noStrike">
           <a:solidFill>
             <a:srgbClr val="000000"/>
           </a:solidFill>
@@ -10900,7 +10908,7 @@
           <a:srgbClr val="000000"/>
         </a:buClr>
         <a:buFont typeface="Arial"/>
-        <a:defRPr b="0" i="0" sz="1400" u="none" cap="none" strike="noStrike">
+        <a:defRPr b="0" i="0" spc="0" sz="1400" u="none" cap="none" strike="noStrike">
           <a:solidFill>
             <a:srgbClr val="000000"/>
           </a:solidFill>
@@ -10924,7 +10932,7 @@
           <a:srgbClr val="000000"/>
         </a:buClr>
         <a:buFont typeface="Arial"/>
-        <a:defRPr b="0" i="0" sz="1400" u="none" cap="none" strike="noStrike">
+        <a:defRPr b="0" i="0" spc="0" sz="1400" u="none" cap="none" strike="noStrike">
           <a:solidFill>
             <a:srgbClr val="000000"/>
           </a:solidFill>
@@ -10948,7 +10956,7 @@
           <a:srgbClr val="000000"/>
         </a:buClr>
         <a:buFont typeface="Arial"/>
-        <a:defRPr b="0" i="0" sz="1400" u="none" cap="none" strike="noStrike">
+        <a:defRPr b="0" i="0" spc="0" sz="1400" u="none" cap="none" strike="noStrike">
           <a:solidFill>
             <a:srgbClr val="000000"/>
           </a:solidFill>
@@ -10985,7 +10993,7 @@
           <a:srgbClr val="000000"/>
         </a:buClr>
         <a:buFont typeface="Arial"/>
-        <a:defRPr b="0" i="0" sz="1400" u="none" cap="none" strike="noStrike">
+        <a:defRPr b="0" i="0" spc="0" sz="1400" u="none" cap="none" strike="noStrike">
           <a:solidFill>
             <a:srgbClr val="000000"/>
           </a:solidFill>
@@ -11009,7 +11017,7 @@
           <a:srgbClr val="000000"/>
         </a:buClr>
         <a:buFont typeface="Arial"/>
-        <a:defRPr b="0" i="0" sz="1400" u="none" cap="none" strike="noStrike">
+        <a:defRPr b="0" i="0" spc="0" sz="1400" u="none" cap="none" strike="noStrike">
           <a:solidFill>
             <a:srgbClr val="000000"/>
           </a:solidFill>
@@ -11033,7 +11041,7 @@
           <a:srgbClr val="000000"/>
         </a:buClr>
         <a:buFont typeface="Arial"/>
-        <a:defRPr b="0" i="0" sz="1400" u="none" cap="none" strike="noStrike">
+        <a:defRPr b="0" i="0" spc="0" sz="1400" u="none" cap="none" strike="noStrike">
           <a:solidFill>
             <a:srgbClr val="000000"/>
           </a:solidFill>
@@ -11057,7 +11065,7 @@
           <a:srgbClr val="000000"/>
         </a:buClr>
         <a:buFont typeface="Arial"/>
-        <a:defRPr b="0" i="0" sz="1400" u="none" cap="none" strike="noStrike">
+        <a:defRPr b="0" i="0" spc="0" sz="1400" u="none" cap="none" strike="noStrike">
           <a:solidFill>
             <a:srgbClr val="000000"/>
           </a:solidFill>
@@ -11081,7 +11089,7 @@
           <a:srgbClr val="000000"/>
         </a:buClr>
         <a:buFont typeface="Arial"/>
-        <a:defRPr b="0" i="0" sz="1400" u="none" cap="none" strike="noStrike">
+        <a:defRPr b="0" i="0" spc="0" sz="1400" u="none" cap="none" strike="noStrike">
           <a:solidFill>
             <a:srgbClr val="000000"/>
           </a:solidFill>
@@ -11105,7 +11113,7 @@
           <a:srgbClr val="000000"/>
         </a:buClr>
         <a:buFont typeface="Arial"/>
-        <a:defRPr b="0" i="0" sz="1400" u="none" cap="none" strike="noStrike">
+        <a:defRPr b="0" i="0" spc="0" sz="1400" u="none" cap="none" strike="noStrike">
           <a:solidFill>
             <a:srgbClr val="000000"/>
           </a:solidFill>
@@ -11129,7 +11137,7 @@
           <a:srgbClr val="000000"/>
         </a:buClr>
         <a:buFont typeface="Arial"/>
-        <a:defRPr b="0" i="0" sz="1400" u="none" cap="none" strike="noStrike">
+        <a:defRPr b="0" i="0" spc="0" sz="1400" u="none" cap="none" strike="noStrike">
           <a:solidFill>
             <a:srgbClr val="000000"/>
           </a:solidFill>
@@ -11153,7 +11161,7 @@
           <a:srgbClr val="000000"/>
         </a:buClr>
         <a:buFont typeface="Arial"/>
-        <a:defRPr b="0" i="0" sz="1400" u="none" cap="none" strike="noStrike">
+        <a:defRPr b="0" i="0" spc="0" sz="1400" u="none" cap="none" strike="noStrike">
           <a:solidFill>
             <a:srgbClr val="000000"/>
           </a:solidFill>
@@ -11177,7 +11185,7 @@
           <a:srgbClr val="000000"/>
         </a:buClr>
         <a:buFont typeface="Arial"/>
-        <a:defRPr b="0" i="0" sz="1400" u="none" cap="none" strike="noStrike">
+        <a:defRPr b="0" i="0" spc="0" sz="1400" u="none" cap="none" strike="noStrike">
           <a:solidFill>
             <a:srgbClr val="000000"/>
           </a:solidFill>
@@ -11467,7 +11475,7 @@
             <a:tbl>
               <a:tblPr>
                 <a:noFill/>
-                <a:tableStyleId>{B8C49189-0626-4E27-B65A-3A5F64F235E2}</a:tableStyleId>
+                <a:tableStyleId>{5539C85E-9174-4036-B62D-4DF2D476FB3C}</a:tableStyleId>
               </a:tblPr>
               <a:tblGrid>
                 <a:gridCol w="1432550"/>
@@ -13390,7 +13398,7 @@
             <a:tbl>
               <a:tblPr>
                 <a:noFill/>
-                <a:tableStyleId>{B8C49189-0626-4E27-B65A-3A5F64F235E2}</a:tableStyleId>
+                <a:tableStyleId>{5539C85E-9174-4036-B62D-4DF2D476FB3C}</a:tableStyleId>
               </a:tblPr>
               <a:tblGrid>
                 <a:gridCol w="1432550"/>
@@ -16578,6 +16586,23 @@
             </a:pPr>
             <a:r>
               <a:rPr lang="en"/>
+              <a:t>Scrum and AMOS</a:t>
+            </a:r>
+            <a:endParaRPr/>
+          </a:p>
+          <a:p>
+            <a:pPr indent="-342900" lvl="0" marL="457200" rtl="0" algn="l">
+              <a:spcBef>
+                <a:spcPts val="0"/>
+              </a:spcBef>
+              <a:spcAft>
+                <a:spcPts val="0"/>
+              </a:spcAft>
+              <a:buSzPts val="1800"/>
+              <a:buChar char="●"/>
+            </a:pPr>
+            <a:r>
+              <a:rPr lang="en"/>
               <a:t>Build process review</a:t>
             </a:r>
             <a:endParaRPr/>
@@ -18769,8 +18794,8 @@
         </p:nvSpPr>
         <p:spPr>
           <a:xfrm>
-            <a:off x="0" y="4233672"/>
-            <a:ext cx="9144000" cy="914400"/>
+            <a:off x="0" y="4233675"/>
+            <a:ext cx="7315200" cy="914400"/>
           </a:xfrm>
           <a:prstGeom prst="rect">
             <a:avLst/>
@@ -18852,18 +18877,10 @@
               <a:buNone/>
             </a:pPr>
             <a:fld id="{00000000-1234-1234-1234-123412341234}" type="slidenum">
-              <a:rPr lang="en">
-                <a:solidFill>
-                  <a:schemeClr val="dk1"/>
-                </a:solidFill>
-              </a:rPr>
+              <a:rPr lang="en"/>
               <a:t>‹#›</a:t>
             </a:fld>
-            <a:endParaRPr>
-              <a:solidFill>
-                <a:schemeClr val="dk1"/>
-              </a:solidFill>
-            </a:endParaRPr>
+            <a:endParaRPr/>
           </a:p>
           <a:p>
             <a:pPr indent="0" lvl="0" marL="0" rtl="0" algn="r">
@@ -18885,10 +18902,18 @@
               <a:t>https://oss.cs.fau.de</a:t>
             </a:r>
             <a:r>
-              <a:rPr b="0" lang="en" sz="900"/>
+              <a:rPr b="0" lang="en" sz="900">
+                <a:solidFill>
+                  <a:schemeClr val="dk2"/>
+                </a:solidFill>
+              </a:rPr>
               <a:t> </a:t>
             </a:r>
-            <a:endParaRPr/>
+            <a:endParaRPr>
+              <a:solidFill>
+                <a:schemeClr val="dk2"/>
+              </a:solidFill>
+            </a:endParaRPr>
           </a:p>
         </p:txBody>
       </p:sp>
@@ -19621,7 +19646,7 @@
             </a:pPr>
             <a:r>
               <a:rPr lang="en"/>
-              <a:t>Information Index</a:t>
+              <a:t>Course Schedule</a:t>
             </a:r>
             <a:endParaRPr/>
           </a:p>
@@ -19661,27 +19686,6 @@
             </a:pPr>
             <a:r>
               <a:rPr lang="en"/>
-              <a:t>I</a:t>
-            </a:r>
-            <a:r>
-              <a:rPr lang="en"/>
-              <a:t>nformation index</a:t>
-            </a:r>
-            <a:endParaRPr/>
-          </a:p>
-          <a:p>
-            <a:pPr indent="-342900" lvl="0" marL="457200" rtl="0" algn="l">
-              <a:spcBef>
-                <a:spcPts val="1200"/>
-              </a:spcBef>
-              <a:spcAft>
-                <a:spcPts val="0"/>
-              </a:spcAft>
-              <a:buSzPts val="1800"/>
-              <a:buChar char="●"/>
-            </a:pPr>
-            <a:r>
-              <a:rPr lang="en"/>
               <a:t>See </a:t>
             </a:r>
             <a:r>
@@ -19693,26 +19697,6 @@
               </a:rPr>
               <a:t>https://amos.uni1.de</a:t>
             </a:r>
-            <a:r>
-              <a:rPr lang="en"/>
-              <a:t>   </a:t>
-            </a:r>
-            <a:endParaRPr/>
-          </a:p>
-          <a:p>
-            <a:pPr indent="0" lvl="0" marL="0" rtl="0" algn="l">
-              <a:spcBef>
-                <a:spcPts val="1200"/>
-              </a:spcBef>
-              <a:spcAft>
-                <a:spcPts val="0"/>
-              </a:spcAft>
-              <a:buNone/>
-            </a:pPr>
-            <a:r>
-              <a:rPr lang="en"/>
-              <a:t>Course schedule</a:t>
-            </a:r>
             <a:endParaRPr/>
           </a:p>
           <a:p>
@@ -19728,7 +19712,7 @@
             </a:pPr>
             <a:r>
               <a:rPr lang="en"/>
-              <a:t>See Schedule tab on information index</a:t>
+              <a:t>Make sure you are on the right tab</a:t>
             </a:r>
             <a:endParaRPr/>
           </a:p>
@@ -21827,7 +21811,7 @@
             </a:pPr>
             <a:r>
               <a:rPr lang="en"/>
-              <a:t>Zero Downtime Linux Updates with Weber</a:t>
+              <a:t>iteratec - Legacy Migrator</a:t>
             </a:r>
             <a:endParaRPr/>
           </a:p>
@@ -21844,7 +21828,7 @@
             </a:pPr>
             <a:r>
               <a:rPr lang="en"/>
-              <a:t>Automated Thematic Analysis with N.I.M.</a:t>
+              <a:t>Bosch - Engineering Knowledge Advisor</a:t>
             </a:r>
             <a:endParaRPr/>
           </a:p>
@@ -21861,7 +21845,7 @@
             </a:pPr>
             <a:r>
               <a:rPr lang="en"/>
-              <a:t>AIlixir Intelligence with Zink (startup)</a:t>
+              <a:t>AIlixir - Patient Journey Matcher</a:t>
             </a:r>
             <a:endParaRPr/>
           </a:p>
@@ -21878,7 +21862,7 @@
             </a:pPr>
             <a:r>
               <a:rPr lang="en"/>
-              <a:t>TaskOrbit Conversational Agent with Meisterwerk</a:t>
+              <a:t>Wisdom Bridge AI - ODOS</a:t>
             </a:r>
             <a:endParaRPr/>
           </a:p>
@@ -22110,22 +22094,20 @@
             <a:tbl>
               <a:tblPr>
                 <a:noFill/>
-                <a:tableStyleId>{B8C49189-0626-4E27-B65A-3A5F64F235E2}</a:tableStyleId>
+                <a:tableStyleId>{5539C85E-9174-4036-B62D-4DF2D476FB3C}</a:tableStyleId>
               </a:tblPr>
               <a:tblGrid>
-                <a:gridCol w="859550"/>
-                <a:gridCol w="859550"/>
-                <a:gridCol w="859550"/>
-                <a:gridCol w="859550"/>
-                <a:gridCol w="859550"/>
-                <a:gridCol w="859550"/>
-                <a:gridCol w="859550"/>
-                <a:gridCol w="859550"/>
-                <a:gridCol w="859550"/>
-                <a:gridCol w="859550"/>
+                <a:gridCol w="1074425"/>
+                <a:gridCol w="1074425"/>
+                <a:gridCol w="1074425"/>
+                <a:gridCol w="1074425"/>
+                <a:gridCol w="1074425"/>
+                <a:gridCol w="1074425"/>
+                <a:gridCol w="1074425"/>
+                <a:gridCol w="1074425"/>
               </a:tblGrid>
-              <a:tr h="457200">
-                <a:tc gridSpan="6">
+              <a:tr h="522525">
+                <a:tc gridSpan="4">
                   <a:txBody>
                     <a:bodyPr/>
                     <a:lstStyle/>
@@ -22196,8 +22178,6 @@
                     </a:solidFill>
                   </a:tcPr>
                 </a:tc>
-                <a:tc hMerge="1"/>
-                <a:tc hMerge="1"/>
                 <a:tc hMerge="1"/>
                 <a:tc hMerge="1"/>
                 <a:tc hMerge="1"/>
@@ -22276,7 +22256,291 @@
                 <a:tc hMerge="1"/>
                 <a:tc hMerge="1"/>
               </a:tr>
-              <a:tr h="457200">
+              <a:tr h="522525">
+                <a:tc>
+                  <a:txBody>
+                    <a:bodyPr/>
+                    <a:lstStyle/>
+                    <a:p>
+                      <a:pPr indent="0" lvl="0" marL="0" rtl="0" algn="ctr">
+                        <a:spcBef>
+                          <a:spcPts val="0"/>
+                        </a:spcBef>
+                        <a:spcAft>
+                          <a:spcPts val="0"/>
+                        </a:spcAft>
+                        <a:buNone/>
+                      </a:pPr>
+                      <a:r>
+                        <a:rPr b="1" lang="en">
+                          <a:solidFill>
+                            <a:schemeClr val="lt1"/>
+                          </a:solidFill>
+                        </a:rPr>
+                        <a:t>3</a:t>
+                      </a:r>
+                      <a:endParaRPr b="1">
+                        <a:solidFill>
+                          <a:schemeClr val="lt1"/>
+                        </a:solidFill>
+                      </a:endParaRPr>
+                    </a:p>
+                  </a:txBody>
+                  <a:tcPr marT="91425" marB="91425" marR="91425" marL="91425" anchor="ctr">
+                    <a:lnL cap="flat" cmpd="sng" w="38100">
+                      <a:solidFill>
+                        <a:schemeClr val="lt1"/>
+                      </a:solidFill>
+                      <a:prstDash val="solid"/>
+                      <a:round/>
+                      <a:headEnd len="sm" w="sm" type="none"/>
+                      <a:tailEnd len="sm" w="sm" type="none"/>
+                    </a:lnL>
+                    <a:lnR cap="flat" cmpd="sng" w="38100">
+                      <a:solidFill>
+                        <a:schemeClr val="lt1"/>
+                      </a:solidFill>
+                      <a:prstDash val="solid"/>
+                      <a:round/>
+                      <a:headEnd len="sm" w="sm" type="none"/>
+                      <a:tailEnd len="sm" w="sm" type="none"/>
+                    </a:lnR>
+                    <a:lnT cap="flat" cmpd="sng" w="38100">
+                      <a:solidFill>
+                        <a:schemeClr val="lt1"/>
+                      </a:solidFill>
+                      <a:prstDash val="solid"/>
+                      <a:round/>
+                      <a:headEnd len="sm" w="sm" type="none"/>
+                      <a:tailEnd len="sm" w="sm" type="none"/>
+                    </a:lnT>
+                    <a:lnB cap="flat" cmpd="sng" w="38100">
+                      <a:solidFill>
+                        <a:schemeClr val="lt1"/>
+                      </a:solidFill>
+                      <a:prstDash val="solid"/>
+                      <a:round/>
+                      <a:headEnd len="sm" w="sm" type="none"/>
+                      <a:tailEnd len="sm" w="sm" type="none"/>
+                    </a:lnB>
+                    <a:solidFill>
+                      <a:schemeClr val="lt2"/>
+                    </a:solidFill>
+                  </a:tcPr>
+                </a:tc>
+                <a:tc>
+                  <a:txBody>
+                    <a:bodyPr/>
+                    <a:lstStyle/>
+                    <a:p>
+                      <a:pPr indent="0" lvl="0" marL="0" rtl="0" algn="ctr">
+                        <a:spcBef>
+                          <a:spcPts val="0"/>
+                        </a:spcBef>
+                        <a:spcAft>
+                          <a:spcPts val="0"/>
+                        </a:spcAft>
+                        <a:buNone/>
+                      </a:pPr>
+                      <a:r>
+                        <a:rPr b="1" lang="en">
+                          <a:solidFill>
+                            <a:schemeClr val="lt1"/>
+                          </a:solidFill>
+                        </a:rPr>
+                        <a:t>4</a:t>
+                      </a:r>
+                      <a:endParaRPr b="1">
+                        <a:solidFill>
+                          <a:schemeClr val="lt1"/>
+                        </a:solidFill>
+                      </a:endParaRPr>
+                    </a:p>
+                  </a:txBody>
+                  <a:tcPr marT="91425" marB="91425" marR="91425" marL="91425" anchor="ctr">
+                    <a:lnL cap="flat" cmpd="sng" w="38100">
+                      <a:solidFill>
+                        <a:schemeClr val="lt1"/>
+                      </a:solidFill>
+                      <a:prstDash val="solid"/>
+                      <a:round/>
+                      <a:headEnd len="sm" w="sm" type="none"/>
+                      <a:tailEnd len="sm" w="sm" type="none"/>
+                    </a:lnL>
+                    <a:lnR cap="flat" cmpd="sng" w="38100">
+                      <a:solidFill>
+                        <a:schemeClr val="lt1"/>
+                      </a:solidFill>
+                      <a:prstDash val="solid"/>
+                      <a:round/>
+                      <a:headEnd len="sm" w="sm" type="none"/>
+                      <a:tailEnd len="sm" w="sm" type="none"/>
+                    </a:lnR>
+                    <a:lnT cap="flat" cmpd="sng" w="38100">
+                      <a:solidFill>
+                        <a:schemeClr val="lt1"/>
+                      </a:solidFill>
+                      <a:prstDash val="solid"/>
+                      <a:round/>
+                      <a:headEnd len="sm" w="sm" type="none"/>
+                      <a:tailEnd len="sm" w="sm" type="none"/>
+                    </a:lnT>
+                    <a:lnB cap="flat" cmpd="sng" w="38100">
+                      <a:solidFill>
+                        <a:schemeClr val="lt1"/>
+                      </a:solidFill>
+                      <a:prstDash val="solid"/>
+                      <a:round/>
+                      <a:headEnd len="sm" w="sm" type="none"/>
+                      <a:tailEnd len="sm" w="sm" type="none"/>
+                    </a:lnB>
+                    <a:solidFill>
+                      <a:schemeClr val="lt2"/>
+                    </a:solidFill>
+                  </a:tcPr>
+                </a:tc>
+                <a:tc>
+                  <a:txBody>
+                    <a:bodyPr/>
+                    <a:lstStyle/>
+                    <a:p>
+                      <a:pPr indent="0" lvl="0" marL="0" rtl="0" algn="ctr">
+                        <a:spcBef>
+                          <a:spcPts val="0"/>
+                        </a:spcBef>
+                        <a:spcAft>
+                          <a:spcPts val="0"/>
+                        </a:spcAft>
+                        <a:buNone/>
+                      </a:pPr>
+                      <a:r>
+                        <a:rPr b="1" lang="en">
+                          <a:solidFill>
+                            <a:schemeClr val="lt1"/>
+                          </a:solidFill>
+                        </a:rPr>
+                        <a:t>5</a:t>
+                      </a:r>
+                      <a:endParaRPr b="1">
+                        <a:solidFill>
+                          <a:schemeClr val="lt1"/>
+                        </a:solidFill>
+                      </a:endParaRPr>
+                    </a:p>
+                  </a:txBody>
+                  <a:tcPr marT="91425" marB="91425" marR="91425" marL="91425" anchor="ctr">
+                    <a:lnL cap="flat" cmpd="sng" w="38100">
+                      <a:solidFill>
+                        <a:schemeClr val="lt1"/>
+                      </a:solidFill>
+                      <a:prstDash val="solid"/>
+                      <a:round/>
+                      <a:headEnd len="sm" w="sm" type="none"/>
+                      <a:tailEnd len="sm" w="sm" type="none"/>
+                    </a:lnL>
+                    <a:lnR cap="flat" cmpd="sng" w="38100">
+                      <a:solidFill>
+                        <a:schemeClr val="lt1"/>
+                      </a:solidFill>
+                      <a:prstDash val="solid"/>
+                      <a:round/>
+                      <a:headEnd len="sm" w="sm" type="none"/>
+                      <a:tailEnd len="sm" w="sm" type="none"/>
+                    </a:lnR>
+                    <a:lnT cap="flat" cmpd="sng" w="38100">
+                      <a:solidFill>
+                        <a:schemeClr val="lt1"/>
+                      </a:solidFill>
+                      <a:prstDash val="solid"/>
+                      <a:round/>
+                      <a:headEnd len="sm" w="sm" type="none"/>
+                      <a:tailEnd len="sm" w="sm" type="none"/>
+                    </a:lnT>
+                    <a:lnB cap="flat" cmpd="sng" w="38100">
+                      <a:solidFill>
+                        <a:schemeClr val="lt1"/>
+                      </a:solidFill>
+                      <a:prstDash val="solid"/>
+                      <a:round/>
+                      <a:headEnd len="sm" w="sm" type="none"/>
+                      <a:tailEnd len="sm" w="sm" type="none"/>
+                    </a:lnB>
+                    <a:solidFill>
+                      <a:schemeClr val="lt2"/>
+                    </a:solidFill>
+                  </a:tcPr>
+                </a:tc>
+                <a:tc>
+                  <a:txBody>
+                    <a:bodyPr/>
+                    <a:lstStyle/>
+                    <a:p>
+                      <a:pPr indent="0" lvl="0" marL="0" rtl="0" algn="ctr">
+                        <a:spcBef>
+                          <a:spcPts val="0"/>
+                        </a:spcBef>
+                        <a:spcAft>
+                          <a:spcPts val="0"/>
+                        </a:spcAft>
+                        <a:buNone/>
+                      </a:pPr>
+                      <a:r>
+                        <a:rPr b="1" lang="en">
+                          <a:solidFill>
+                            <a:schemeClr val="lt1"/>
+                          </a:solidFill>
+                        </a:rPr>
+                        <a:t>6</a:t>
+                      </a:r>
+                      <a:endParaRPr b="1">
+                        <a:solidFill>
+                          <a:schemeClr val="lt1"/>
+                        </a:solidFill>
+                      </a:endParaRPr>
+                    </a:p>
+                  </a:txBody>
+                  <a:tcPr marT="91425" marB="91425" marR="91425" marL="91425" anchor="ctr">
+                    <a:lnL cap="flat" cmpd="sng" w="38100">
+                      <a:solidFill>
+                        <a:schemeClr val="lt1"/>
+                      </a:solidFill>
+                      <a:prstDash val="solid"/>
+                      <a:round/>
+                      <a:headEnd len="sm" w="sm" type="none"/>
+                      <a:tailEnd len="sm" w="sm" type="none"/>
+                    </a:lnL>
+                    <a:lnR cap="flat" cmpd="sng" w="38100">
+                      <a:solidFill>
+                        <a:schemeClr val="lt1"/>
+                      </a:solidFill>
+                      <a:prstDash val="solid"/>
+                      <a:round/>
+                      <a:headEnd len="sm" w="sm" type="none"/>
+                      <a:tailEnd len="sm" w="sm" type="none"/>
+                    </a:lnR>
+                    <a:lnT cap="flat" cmpd="sng" w="38100">
+                      <a:solidFill>
+                        <a:schemeClr val="lt1"/>
+                      </a:solidFill>
+                      <a:prstDash val="solid"/>
+                      <a:round/>
+                      <a:headEnd len="sm" w="sm" type="none"/>
+                      <a:tailEnd len="sm" w="sm" type="none"/>
+                    </a:lnT>
+                    <a:lnB cap="flat" cmpd="sng" w="38100">
+                      <a:solidFill>
+                        <a:schemeClr val="lt1"/>
+                      </a:solidFill>
+                      <a:prstDash val="solid"/>
+                      <a:round/>
+                      <a:headEnd len="sm" w="sm" type="none"/>
+                      <a:tailEnd len="sm" w="sm" type="none"/>
+                    </a:lnB>
+                    <a:solidFill>
+                      <a:schemeClr val="lt2"/>
+                    </a:solidFill>
+                  </a:tcPr>
+                </a:tc>
                 <a:tc>
                   <a:txBody>
                     <a:bodyPr/>
@@ -22561,566 +22825,8 @@
                     </a:solidFill>
                   </a:tcPr>
                 </a:tc>
-                <a:tc>
-                  <a:txBody>
-                    <a:bodyPr/>
-                    <a:lstStyle/>
-                    <a:p>
-                      <a:pPr indent="0" lvl="0" marL="0" rtl="0" algn="ctr">
-                        <a:spcBef>
-                          <a:spcPts val="0"/>
-                        </a:spcBef>
-                        <a:spcAft>
-                          <a:spcPts val="0"/>
-                        </a:spcAft>
-                        <a:buNone/>
-                      </a:pPr>
-                      <a:r>
-                        <a:rPr b="1" lang="en">
-                          <a:solidFill>
-                            <a:schemeClr val="lt1"/>
-                          </a:solidFill>
-                        </a:rPr>
-                        <a:t>5</a:t>
-                      </a:r>
-                      <a:endParaRPr b="1">
-                        <a:solidFill>
-                          <a:schemeClr val="lt1"/>
-                        </a:solidFill>
-                      </a:endParaRPr>
-                    </a:p>
-                  </a:txBody>
-                  <a:tcPr marT="91425" marB="91425" marR="91425" marL="91425" anchor="ctr">
-                    <a:lnL cap="flat" cmpd="sng" w="38100">
-                      <a:solidFill>
-                        <a:schemeClr val="lt1"/>
-                      </a:solidFill>
-                      <a:prstDash val="solid"/>
-                      <a:round/>
-                      <a:headEnd len="sm" w="sm" type="none"/>
-                      <a:tailEnd len="sm" w="sm" type="none"/>
-                    </a:lnL>
-                    <a:lnR cap="flat" cmpd="sng" w="38100">
-                      <a:solidFill>
-                        <a:schemeClr val="lt1"/>
-                      </a:solidFill>
-                      <a:prstDash val="solid"/>
-                      <a:round/>
-                      <a:headEnd len="sm" w="sm" type="none"/>
-                      <a:tailEnd len="sm" w="sm" type="none"/>
-                    </a:lnR>
-                    <a:lnT cap="flat" cmpd="sng" w="38100">
-                      <a:solidFill>
-                        <a:schemeClr val="lt1"/>
-                      </a:solidFill>
-                      <a:prstDash val="solid"/>
-                      <a:round/>
-                      <a:headEnd len="sm" w="sm" type="none"/>
-                      <a:tailEnd len="sm" w="sm" type="none"/>
-                    </a:lnT>
-                    <a:lnB cap="flat" cmpd="sng" w="38100">
-                      <a:solidFill>
-                        <a:schemeClr val="lt1"/>
-                      </a:solidFill>
-                      <a:prstDash val="solid"/>
-                      <a:round/>
-                      <a:headEnd len="sm" w="sm" type="none"/>
-                      <a:tailEnd len="sm" w="sm" type="none"/>
-                    </a:lnB>
-                    <a:solidFill>
-                      <a:schemeClr val="lt2"/>
-                    </a:solidFill>
-                  </a:tcPr>
-                </a:tc>
-                <a:tc>
-                  <a:txBody>
-                    <a:bodyPr/>
-                    <a:lstStyle/>
-                    <a:p>
-                      <a:pPr indent="0" lvl="0" marL="0" rtl="0" algn="ctr">
-                        <a:spcBef>
-                          <a:spcPts val="0"/>
-                        </a:spcBef>
-                        <a:spcAft>
-                          <a:spcPts val="0"/>
-                        </a:spcAft>
-                        <a:buNone/>
-                      </a:pPr>
-                      <a:r>
-                        <a:rPr b="1" lang="en">
-                          <a:solidFill>
-                            <a:schemeClr val="lt1"/>
-                          </a:solidFill>
-                        </a:rPr>
-                        <a:t>6</a:t>
-                      </a:r>
-                      <a:endParaRPr b="1">
-                        <a:solidFill>
-                          <a:schemeClr val="lt1"/>
-                        </a:solidFill>
-                      </a:endParaRPr>
-                    </a:p>
-                  </a:txBody>
-                  <a:tcPr marT="91425" marB="91425" marR="91425" marL="91425" anchor="ctr">
-                    <a:lnL cap="flat" cmpd="sng" w="38100">
-                      <a:solidFill>
-                        <a:schemeClr val="lt1"/>
-                      </a:solidFill>
-                      <a:prstDash val="solid"/>
-                      <a:round/>
-                      <a:headEnd len="sm" w="sm" type="none"/>
-                      <a:tailEnd len="sm" w="sm" type="none"/>
-                    </a:lnL>
-                    <a:lnR cap="flat" cmpd="sng" w="38100">
-                      <a:solidFill>
-                        <a:schemeClr val="lt1"/>
-                      </a:solidFill>
-                      <a:prstDash val="solid"/>
-                      <a:round/>
-                      <a:headEnd len="sm" w="sm" type="none"/>
-                      <a:tailEnd len="sm" w="sm" type="none"/>
-                    </a:lnR>
-                    <a:lnT cap="flat" cmpd="sng" w="38100">
-                      <a:solidFill>
-                        <a:schemeClr val="lt1"/>
-                      </a:solidFill>
-                      <a:prstDash val="solid"/>
-                      <a:round/>
-                      <a:headEnd len="sm" w="sm" type="none"/>
-                      <a:tailEnd len="sm" w="sm" type="none"/>
-                    </a:lnT>
-                    <a:lnB cap="flat" cmpd="sng" w="38100">
-                      <a:solidFill>
-                        <a:schemeClr val="lt1"/>
-                      </a:solidFill>
-                      <a:prstDash val="solid"/>
-                      <a:round/>
-                      <a:headEnd len="sm" w="sm" type="none"/>
-                      <a:tailEnd len="sm" w="sm" type="none"/>
-                    </a:lnB>
-                    <a:solidFill>
-                      <a:schemeClr val="lt2"/>
-                    </a:solidFill>
-                  </a:tcPr>
-                </a:tc>
-                <a:tc>
-                  <a:txBody>
-                    <a:bodyPr/>
-                    <a:lstStyle/>
-                    <a:p>
-                      <a:pPr indent="0" lvl="0" marL="0" rtl="0" algn="ctr">
-                        <a:spcBef>
-                          <a:spcPts val="0"/>
-                        </a:spcBef>
-                        <a:spcAft>
-                          <a:spcPts val="0"/>
-                        </a:spcAft>
-                        <a:buNone/>
-                      </a:pPr>
-                      <a:r>
-                        <a:rPr b="1" lang="en">
-                          <a:solidFill>
-                            <a:schemeClr val="lt1"/>
-                          </a:solidFill>
-                        </a:rPr>
-                        <a:t>1</a:t>
-                      </a:r>
-                      <a:endParaRPr b="1">
-                        <a:solidFill>
-                          <a:schemeClr val="lt1"/>
-                        </a:solidFill>
-                      </a:endParaRPr>
-                    </a:p>
-                  </a:txBody>
-                  <a:tcPr marT="91425" marB="91425" marR="91425" marL="91425" anchor="ctr">
-                    <a:lnL cap="flat" cmpd="sng" w="38100">
-                      <a:solidFill>
-                        <a:schemeClr val="lt1"/>
-                      </a:solidFill>
-                      <a:prstDash val="solid"/>
-                      <a:round/>
-                      <a:headEnd len="sm" w="sm" type="none"/>
-                      <a:tailEnd len="sm" w="sm" type="none"/>
-                    </a:lnL>
-                    <a:lnR cap="flat" cmpd="sng" w="38100">
-                      <a:solidFill>
-                        <a:schemeClr val="lt1"/>
-                      </a:solidFill>
-                      <a:prstDash val="solid"/>
-                      <a:round/>
-                      <a:headEnd len="sm" w="sm" type="none"/>
-                      <a:tailEnd len="sm" w="sm" type="none"/>
-                    </a:lnR>
-                    <a:lnT cap="flat" cmpd="sng" w="38100">
-                      <a:solidFill>
-                        <a:schemeClr val="lt1"/>
-                      </a:solidFill>
-                      <a:prstDash val="solid"/>
-                      <a:round/>
-                      <a:headEnd len="sm" w="sm" type="none"/>
-                      <a:tailEnd len="sm" w="sm" type="none"/>
-                    </a:lnT>
-                    <a:lnB cap="flat" cmpd="sng" w="38100">
-                      <a:solidFill>
-                        <a:schemeClr val="lt1"/>
-                      </a:solidFill>
-                      <a:prstDash val="solid"/>
-                      <a:round/>
-                      <a:headEnd len="sm" w="sm" type="none"/>
-                      <a:tailEnd len="sm" w="sm" type="none"/>
-                    </a:lnB>
-                    <a:solidFill>
-                      <a:schemeClr val="lt2"/>
-                    </a:solidFill>
-                  </a:tcPr>
-                </a:tc>
-                <a:tc>
-                  <a:txBody>
-                    <a:bodyPr/>
-                    <a:lstStyle/>
-                    <a:p>
-                      <a:pPr indent="0" lvl="0" marL="0" rtl="0" algn="ctr">
-                        <a:spcBef>
-                          <a:spcPts val="0"/>
-                        </a:spcBef>
-                        <a:spcAft>
-                          <a:spcPts val="0"/>
-                        </a:spcAft>
-                        <a:buNone/>
-                      </a:pPr>
-                      <a:r>
-                        <a:rPr b="1" lang="en">
-                          <a:solidFill>
-                            <a:schemeClr val="lt1"/>
-                          </a:solidFill>
-                        </a:rPr>
-                        <a:t>2</a:t>
-                      </a:r>
-                      <a:endParaRPr b="1">
-                        <a:solidFill>
-                          <a:schemeClr val="lt1"/>
-                        </a:solidFill>
-                      </a:endParaRPr>
-                    </a:p>
-                  </a:txBody>
-                  <a:tcPr marT="91425" marB="91425" marR="91425" marL="91425" anchor="ctr">
-                    <a:lnL cap="flat" cmpd="sng" w="38100">
-                      <a:solidFill>
-                        <a:schemeClr val="lt1"/>
-                      </a:solidFill>
-                      <a:prstDash val="solid"/>
-                      <a:round/>
-                      <a:headEnd len="sm" w="sm" type="none"/>
-                      <a:tailEnd len="sm" w="sm" type="none"/>
-                    </a:lnL>
-                    <a:lnR cap="flat" cmpd="sng" w="38100">
-                      <a:solidFill>
-                        <a:schemeClr val="lt1"/>
-                      </a:solidFill>
-                      <a:prstDash val="solid"/>
-                      <a:round/>
-                      <a:headEnd len="sm" w="sm" type="none"/>
-                      <a:tailEnd len="sm" w="sm" type="none"/>
-                    </a:lnR>
-                    <a:lnT cap="flat" cmpd="sng" w="38100">
-                      <a:solidFill>
-                        <a:schemeClr val="lt1"/>
-                      </a:solidFill>
-                      <a:prstDash val="solid"/>
-                      <a:round/>
-                      <a:headEnd len="sm" w="sm" type="none"/>
-                      <a:tailEnd len="sm" w="sm" type="none"/>
-                    </a:lnT>
-                    <a:lnB cap="flat" cmpd="sng" w="38100">
-                      <a:solidFill>
-                        <a:schemeClr val="lt1"/>
-                      </a:solidFill>
-                      <a:prstDash val="solid"/>
-                      <a:round/>
-                      <a:headEnd len="sm" w="sm" type="none"/>
-                      <a:tailEnd len="sm" w="sm" type="none"/>
-                    </a:lnB>
-                    <a:solidFill>
-                      <a:schemeClr val="lt2"/>
-                    </a:solidFill>
-                  </a:tcPr>
-                </a:tc>
-                <a:tc>
-                  <a:txBody>
-                    <a:bodyPr/>
-                    <a:lstStyle/>
-                    <a:p>
-                      <a:pPr indent="0" lvl="0" marL="0" rtl="0" algn="ctr">
-                        <a:spcBef>
-                          <a:spcPts val="0"/>
-                        </a:spcBef>
-                        <a:spcAft>
-                          <a:spcPts val="0"/>
-                        </a:spcAft>
-                        <a:buNone/>
-                      </a:pPr>
-                      <a:r>
-                        <a:rPr b="1" lang="en">
-                          <a:solidFill>
-                            <a:schemeClr val="lt1"/>
-                          </a:solidFill>
-                        </a:rPr>
-                        <a:t>3</a:t>
-                      </a:r>
-                      <a:endParaRPr b="1">
-                        <a:solidFill>
-                          <a:schemeClr val="lt1"/>
-                        </a:solidFill>
-                      </a:endParaRPr>
-                    </a:p>
-                  </a:txBody>
-                  <a:tcPr marT="91425" marB="91425" marR="91425" marL="91425" anchor="ctr">
-                    <a:lnL cap="flat" cmpd="sng" w="38100">
-                      <a:solidFill>
-                        <a:schemeClr val="lt1"/>
-                      </a:solidFill>
-                      <a:prstDash val="solid"/>
-                      <a:round/>
-                      <a:headEnd len="sm" w="sm" type="none"/>
-                      <a:tailEnd len="sm" w="sm" type="none"/>
-                    </a:lnL>
-                    <a:lnR cap="flat" cmpd="sng" w="38100">
-                      <a:solidFill>
-                        <a:schemeClr val="lt1"/>
-                      </a:solidFill>
-                      <a:prstDash val="solid"/>
-                      <a:round/>
-                      <a:headEnd len="sm" w="sm" type="none"/>
-                      <a:tailEnd len="sm" w="sm" type="none"/>
-                    </a:lnR>
-                    <a:lnT cap="flat" cmpd="sng" w="38100">
-                      <a:solidFill>
-                        <a:schemeClr val="lt1"/>
-                      </a:solidFill>
-                      <a:prstDash val="solid"/>
-                      <a:round/>
-                      <a:headEnd len="sm" w="sm" type="none"/>
-                      <a:tailEnd len="sm" w="sm" type="none"/>
-                    </a:lnT>
-                    <a:lnB cap="flat" cmpd="sng" w="38100">
-                      <a:solidFill>
-                        <a:schemeClr val="lt1"/>
-                      </a:solidFill>
-                      <a:prstDash val="solid"/>
-                      <a:round/>
-                      <a:headEnd len="sm" w="sm" type="none"/>
-                      <a:tailEnd len="sm" w="sm" type="none"/>
-                    </a:lnB>
-                    <a:solidFill>
-                      <a:schemeClr val="lt2"/>
-                    </a:solidFill>
-                  </a:tcPr>
-                </a:tc>
-                <a:tc>
-                  <a:txBody>
-                    <a:bodyPr/>
-                    <a:lstStyle/>
-                    <a:p>
-                      <a:pPr indent="0" lvl="0" marL="0" rtl="0" algn="ctr">
-                        <a:spcBef>
-                          <a:spcPts val="0"/>
-                        </a:spcBef>
-                        <a:spcAft>
-                          <a:spcPts val="0"/>
-                        </a:spcAft>
-                        <a:buNone/>
-                      </a:pPr>
-                      <a:r>
-                        <a:rPr b="1" lang="en">
-                          <a:solidFill>
-                            <a:schemeClr val="lt1"/>
-                          </a:solidFill>
-                        </a:rPr>
-                        <a:t>4</a:t>
-                      </a:r>
-                      <a:endParaRPr b="1">
-                        <a:solidFill>
-                          <a:schemeClr val="lt1"/>
-                        </a:solidFill>
-                      </a:endParaRPr>
-                    </a:p>
-                  </a:txBody>
-                  <a:tcPr marT="91425" marB="91425" marR="91425" marL="91425" anchor="ctr">
-                    <a:lnL cap="flat" cmpd="sng" w="38100">
-                      <a:solidFill>
-                        <a:schemeClr val="lt1"/>
-                      </a:solidFill>
-                      <a:prstDash val="solid"/>
-                      <a:round/>
-                      <a:headEnd len="sm" w="sm" type="none"/>
-                      <a:tailEnd len="sm" w="sm" type="none"/>
-                    </a:lnL>
-                    <a:lnR cap="flat" cmpd="sng" w="38100">
-                      <a:solidFill>
-                        <a:schemeClr val="lt1"/>
-                      </a:solidFill>
-                      <a:prstDash val="solid"/>
-                      <a:round/>
-                      <a:headEnd len="sm" w="sm" type="none"/>
-                      <a:tailEnd len="sm" w="sm" type="none"/>
-                    </a:lnR>
-                    <a:lnT cap="flat" cmpd="sng" w="38100">
-                      <a:solidFill>
-                        <a:schemeClr val="lt1"/>
-                      </a:solidFill>
-                      <a:prstDash val="solid"/>
-                      <a:round/>
-                      <a:headEnd len="sm" w="sm" type="none"/>
-                      <a:tailEnd len="sm" w="sm" type="none"/>
-                    </a:lnT>
-                    <a:lnB cap="flat" cmpd="sng" w="38100">
-                      <a:solidFill>
-                        <a:schemeClr val="lt1"/>
-                      </a:solidFill>
-                      <a:prstDash val="solid"/>
-                      <a:round/>
-                      <a:headEnd len="sm" w="sm" type="none"/>
-                      <a:tailEnd len="sm" w="sm" type="none"/>
-                    </a:lnB>
-                    <a:solidFill>
-                      <a:schemeClr val="lt2"/>
-                    </a:solidFill>
-                  </a:tcPr>
-                </a:tc>
               </a:tr>
-              <a:tr h="457200">
-                <a:tc>
-                  <a:txBody>
-                    <a:bodyPr/>
-                    <a:lstStyle/>
-                    <a:p>
-                      <a:pPr indent="0" lvl="0" marL="0" rtl="0" algn="ctr">
-                        <a:spcBef>
-                          <a:spcPts val="0"/>
-                        </a:spcBef>
-                        <a:spcAft>
-                          <a:spcPts val="0"/>
-                        </a:spcAft>
-                        <a:buNone/>
-                      </a:pPr>
-                      <a:r>
-                        <a:t/>
-                      </a:r>
-                      <a:endParaRPr b="1">
-                        <a:solidFill>
-                          <a:schemeClr val="lt1"/>
-                        </a:solidFill>
-                      </a:endParaRPr>
-                    </a:p>
-                  </a:txBody>
-                  <a:tcPr marT="91425" marB="91425" marR="91425" marL="91425" anchor="ctr">
-                    <a:lnL cap="flat" cmpd="sng" w="38100">
-                      <a:solidFill>
-                        <a:schemeClr val="lt1"/>
-                      </a:solidFill>
-                      <a:prstDash val="solid"/>
-                      <a:round/>
-                      <a:headEnd len="sm" w="sm" type="none"/>
-                      <a:tailEnd len="sm" w="sm" type="none"/>
-                    </a:lnL>
-                    <a:lnR cap="flat" cmpd="sng" w="38100">
-                      <a:solidFill>
-                        <a:schemeClr val="lt1"/>
-                      </a:solidFill>
-                      <a:prstDash val="solid"/>
-                      <a:round/>
-                      <a:headEnd len="sm" w="sm" type="none"/>
-                      <a:tailEnd len="sm" w="sm" type="none"/>
-                    </a:lnR>
-                    <a:lnT cap="flat" cmpd="sng" w="38100">
-                      <a:solidFill>
-                        <a:schemeClr val="lt1"/>
-                      </a:solidFill>
-                      <a:prstDash val="solid"/>
-                      <a:round/>
-                      <a:headEnd len="sm" w="sm" type="none"/>
-                      <a:tailEnd len="sm" w="sm" type="none"/>
-                    </a:lnT>
-                    <a:lnB cap="flat" cmpd="sng" w="38100">
-                      <a:solidFill>
-                        <a:schemeClr val="lt1"/>
-                      </a:solidFill>
-                      <a:prstDash val="solid"/>
-                      <a:round/>
-                      <a:headEnd len="sm" w="sm" type="none"/>
-                      <a:tailEnd len="sm" w="sm" type="none"/>
-                    </a:lnB>
-                    <a:solidFill>
-                      <a:schemeClr val="accent1"/>
-                    </a:solidFill>
-                  </a:tcPr>
-                </a:tc>
-                <a:tc>
-                  <a:txBody>
-                    <a:bodyPr/>
-                    <a:lstStyle/>
-                    <a:p>
-                      <a:pPr indent="0" lvl="0" marL="0" rtl="0" algn="ctr">
-                        <a:spcBef>
-                          <a:spcPts val="0"/>
-                        </a:spcBef>
-                        <a:spcAft>
-                          <a:spcPts val="0"/>
-                        </a:spcAft>
-                        <a:buNone/>
-                      </a:pPr>
-                      <a:r>
-                        <a:t/>
-                      </a:r>
-                      <a:endParaRPr b="1">
-                        <a:solidFill>
-                          <a:schemeClr val="lt1"/>
-                        </a:solidFill>
-                      </a:endParaRPr>
-                    </a:p>
-                  </a:txBody>
-                  <a:tcPr marT="91425" marB="91425" marR="91425" marL="91425" anchor="ctr">
-                    <a:lnL cap="flat" cmpd="sng" w="38100">
-                      <a:solidFill>
-                        <a:schemeClr val="lt1"/>
-                      </a:solidFill>
-                      <a:prstDash val="solid"/>
-                      <a:round/>
-                      <a:headEnd len="sm" w="sm" type="none"/>
-                      <a:tailEnd len="sm" w="sm" type="none"/>
-                    </a:lnL>
-                    <a:lnR cap="flat" cmpd="sng" w="38100">
-                      <a:solidFill>
-                        <a:schemeClr val="lt1"/>
-                      </a:solidFill>
-                      <a:prstDash val="solid"/>
-                      <a:round/>
-                      <a:headEnd len="sm" w="sm" type="none"/>
-                      <a:tailEnd len="sm" w="sm" type="none"/>
-                    </a:lnR>
-                    <a:lnT cap="flat" cmpd="sng" w="38100">
-                      <a:solidFill>
-                        <a:schemeClr val="lt1"/>
-                      </a:solidFill>
-                      <a:prstDash val="solid"/>
-                      <a:round/>
-                      <a:headEnd len="sm" w="sm" type="none"/>
-                      <a:tailEnd len="sm" w="sm" type="none"/>
-                    </a:lnT>
-                    <a:lnB cap="flat" cmpd="sng" w="38100">
-                      <a:solidFill>
-                        <a:schemeClr val="lt1"/>
-                      </a:solidFill>
-                      <a:prstDash val="solid"/>
-                      <a:round/>
-                      <a:headEnd len="sm" w="sm" type="none"/>
-                      <a:tailEnd len="sm" w="sm" type="none"/>
-                    </a:lnB>
-                    <a:solidFill>
-                      <a:schemeClr val="accent1"/>
-                    </a:solidFill>
-                  </a:tcPr>
-                </a:tc>
+              <a:tr h="522525">
                 <a:tc>
                   <a:txBody>
                     <a:bodyPr/>
@@ -23395,73 +23101,7 @@
                     </a:solidFill>
                   </a:tcPr>
                 </a:tc>
-                <a:tc>
-                  <a:txBody>
-                    <a:bodyPr/>
-                    <a:lstStyle/>
-                    <a:p>
-                      <a:pPr indent="0" lvl="0" marL="0" rtl="0" algn="ctr">
-                        <a:spcBef>
-                          <a:spcPts val="0"/>
-                        </a:spcBef>
-                        <a:spcAft>
-                          <a:spcPts val="0"/>
-                        </a:spcAft>
-                        <a:buNone/>
-                      </a:pPr>
-                      <a:r>
-                        <a:t/>
-                      </a:r>
-                      <a:endParaRPr b="1">
-                        <a:solidFill>
-                          <a:schemeClr val="lt1"/>
-                        </a:solidFill>
-                      </a:endParaRPr>
-                    </a:p>
-                  </a:txBody>
-                  <a:tcPr marT="91425" marB="91425" marR="91425" marL="91425" anchor="ctr">
-                    <a:lnL cap="flat" cmpd="sng" w="38100">
-                      <a:solidFill>
-                        <a:schemeClr val="lt1"/>
-                      </a:solidFill>
-                      <a:prstDash val="solid"/>
-                      <a:round/>
-                      <a:headEnd len="sm" w="sm" type="none"/>
-                      <a:tailEnd len="sm" w="sm" type="none"/>
-                    </a:lnL>
-                    <a:lnR cap="flat" cmpd="sng" w="38100">
-                      <a:solidFill>
-                        <a:schemeClr val="lt1"/>
-                      </a:solidFill>
-                      <a:prstDash val="solid"/>
-                      <a:round/>
-                      <a:headEnd len="sm" w="sm" type="none"/>
-                      <a:tailEnd len="sm" w="sm" type="none"/>
-                    </a:lnR>
-                    <a:lnT cap="flat" cmpd="sng" w="38100">
-                      <a:solidFill>
-                        <a:schemeClr val="lt1"/>
-                      </a:solidFill>
-                      <a:prstDash val="solid"/>
-                      <a:round/>
-                      <a:headEnd len="sm" w="sm" type="none"/>
-                      <a:tailEnd len="sm" w="sm" type="none"/>
-                    </a:lnT>
-                    <a:lnB cap="flat" cmpd="sng" w="38100">
-                      <a:solidFill>
-                        <a:schemeClr val="lt1"/>
-                      </a:solidFill>
-                      <a:prstDash val="solid"/>
-                      <a:round/>
-                      <a:headEnd len="sm" w="sm" type="none"/>
-                      <a:tailEnd len="sm" w="sm" type="none"/>
-                    </a:lnB>
-                    <a:solidFill>
-                      <a:schemeClr val="accent1"/>
-                    </a:solidFill>
-                  </a:tcPr>
-                </a:tc>
-                <a:tc>
+                <a:tc gridSpan="4">
                   <a:txBody>
                     <a:bodyPr/>
                     <a:lstStyle/>
@@ -23532,282 +23172,11 @@
                     </a:solidFill>
                   </a:tcPr>
                 </a:tc>
-                <a:tc>
-                  <a:txBody>
-                    <a:bodyPr/>
-                    <a:lstStyle/>
-                    <a:p>
-                      <a:pPr indent="0" lvl="0" marL="0" rtl="0" algn="ctr">
-                        <a:spcBef>
-                          <a:spcPts val="0"/>
-                        </a:spcBef>
-                        <a:spcAft>
-                          <a:spcPts val="0"/>
-                        </a:spcAft>
-                        <a:buNone/>
-                      </a:pPr>
-                      <a:r>
-                        <a:rPr b="1" lang="en">
-                          <a:solidFill>
-                            <a:schemeClr val="lt1"/>
-                          </a:solidFill>
-                        </a:rPr>
-                        <a:t>AMOS</a:t>
-                      </a:r>
-                      <a:endParaRPr b="1">
-                        <a:solidFill>
-                          <a:schemeClr val="lt1"/>
-                        </a:solidFill>
-                      </a:endParaRPr>
-                    </a:p>
-                  </a:txBody>
-                  <a:tcPr marT="91425" marB="91425" marR="91425" marL="91425" anchor="ctr">
-                    <a:lnL cap="flat" cmpd="sng" w="38100">
-                      <a:solidFill>
-                        <a:schemeClr val="lt1"/>
-                      </a:solidFill>
-                      <a:prstDash val="solid"/>
-                      <a:round/>
-                      <a:headEnd len="sm" w="sm" type="none"/>
-                      <a:tailEnd len="sm" w="sm" type="none"/>
-                    </a:lnL>
-                    <a:lnR cap="flat" cmpd="sng" w="38100">
-                      <a:solidFill>
-                        <a:schemeClr val="lt1"/>
-                      </a:solidFill>
-                      <a:prstDash val="solid"/>
-                      <a:round/>
-                      <a:headEnd len="sm" w="sm" type="none"/>
-                      <a:tailEnd len="sm" w="sm" type="none"/>
-                    </a:lnR>
-                    <a:lnT cap="flat" cmpd="sng" w="38100">
-                      <a:solidFill>
-                        <a:schemeClr val="lt1"/>
-                      </a:solidFill>
-                      <a:prstDash val="solid"/>
-                      <a:round/>
-                      <a:headEnd len="sm" w="sm" type="none"/>
-                      <a:tailEnd len="sm" w="sm" type="none"/>
-                    </a:lnT>
-                    <a:lnB cap="flat" cmpd="sng" w="38100">
-                      <a:solidFill>
-                        <a:schemeClr val="lt1"/>
-                      </a:solidFill>
-                      <a:prstDash val="solid"/>
-                      <a:round/>
-                      <a:headEnd len="sm" w="sm" type="none"/>
-                      <a:tailEnd len="sm" w="sm" type="none"/>
-                    </a:lnB>
-                    <a:solidFill>
-                      <a:schemeClr val="accent6"/>
-                    </a:solidFill>
-                  </a:tcPr>
-                </a:tc>
-                <a:tc rowSpan="5">
-                  <a:txBody>
-                    <a:bodyPr/>
-                    <a:lstStyle/>
-                    <a:p>
-                      <a:pPr indent="0" lvl="0" marL="0" rtl="0" algn="ctr">
-                        <a:spcBef>
-                          <a:spcPts val="0"/>
-                        </a:spcBef>
-                        <a:spcAft>
-                          <a:spcPts val="0"/>
-                        </a:spcAft>
-                        <a:buNone/>
-                      </a:pPr>
-                      <a:r>
-                        <a:rPr b="1" lang="en">
-                          <a:solidFill>
-                            <a:schemeClr val="lt1"/>
-                          </a:solidFill>
-                        </a:rPr>
-                        <a:t>MATH</a:t>
-                      </a:r>
-                      <a:endParaRPr b="1">
-                        <a:solidFill>
-                          <a:schemeClr val="lt1"/>
-                        </a:solidFill>
-                      </a:endParaRPr>
-                    </a:p>
-                  </a:txBody>
-                  <a:tcPr marT="91425" marB="91425" marR="91425" marL="91425" anchor="ctr">
-                    <a:lnL cap="flat" cmpd="sng" w="38100">
-                      <a:solidFill>
-                        <a:schemeClr val="lt1"/>
-                      </a:solidFill>
-                      <a:prstDash val="solid"/>
-                      <a:round/>
-                      <a:headEnd len="sm" w="sm" type="none"/>
-                      <a:tailEnd len="sm" w="sm" type="none"/>
-                    </a:lnL>
-                    <a:lnR cap="flat" cmpd="sng" w="38100">
-                      <a:solidFill>
-                        <a:schemeClr val="lt1"/>
-                      </a:solidFill>
-                      <a:prstDash val="solid"/>
-                      <a:round/>
-                      <a:headEnd len="sm" w="sm" type="none"/>
-                      <a:tailEnd len="sm" w="sm" type="none"/>
-                    </a:lnR>
-                    <a:lnT cap="flat" cmpd="sng" w="38100">
-                      <a:solidFill>
-                        <a:schemeClr val="lt1"/>
-                      </a:solidFill>
-                      <a:prstDash val="solid"/>
-                      <a:round/>
-                      <a:headEnd len="sm" w="sm" type="none"/>
-                      <a:tailEnd len="sm" w="sm" type="none"/>
-                    </a:lnT>
-                    <a:lnB cap="flat" cmpd="sng" w="38100">
-                      <a:solidFill>
-                        <a:schemeClr val="lt1"/>
-                      </a:solidFill>
-                      <a:prstDash val="solid"/>
-                      <a:round/>
-                      <a:headEnd len="sm" w="sm" type="none"/>
-                      <a:tailEnd len="sm" w="sm" type="none"/>
-                    </a:lnB>
-                    <a:solidFill>
-                      <a:schemeClr val="dk2"/>
-                    </a:solidFill>
-                  </a:tcPr>
-                </a:tc>
+                <a:tc hMerge="1"/>
+                <a:tc hMerge="1"/>
+                <a:tc hMerge="1"/>
               </a:tr>
-              <a:tr h="457200">
-                <a:tc>
-                  <a:txBody>
-                    <a:bodyPr/>
-                    <a:lstStyle/>
-                    <a:p>
-                      <a:pPr indent="0" lvl="0" marL="0" rtl="0" algn="ctr">
-                        <a:spcBef>
-                          <a:spcPts val="0"/>
-                        </a:spcBef>
-                        <a:spcAft>
-                          <a:spcPts val="0"/>
-                        </a:spcAft>
-                        <a:buNone/>
-                      </a:pPr>
-                      <a:r>
-                        <a:t/>
-                      </a:r>
-                      <a:endParaRPr b="1">
-                        <a:solidFill>
-                          <a:schemeClr val="lt1"/>
-                        </a:solidFill>
-                      </a:endParaRPr>
-                    </a:p>
-                  </a:txBody>
-                  <a:tcPr marT="91425" marB="91425" marR="91425" marL="91425" anchor="ctr">
-                    <a:lnL cap="flat" cmpd="sng" w="38100">
-                      <a:solidFill>
-                        <a:schemeClr val="lt1"/>
-                      </a:solidFill>
-                      <a:prstDash val="solid"/>
-                      <a:round/>
-                      <a:headEnd len="sm" w="sm" type="none"/>
-                      <a:tailEnd len="sm" w="sm" type="none"/>
-                    </a:lnL>
-                    <a:lnR cap="flat" cmpd="sng" w="38100">
-                      <a:solidFill>
-                        <a:schemeClr val="lt1"/>
-                      </a:solidFill>
-                      <a:prstDash val="solid"/>
-                      <a:round/>
-                      <a:headEnd len="sm" w="sm" type="none"/>
-                      <a:tailEnd len="sm" w="sm" type="none"/>
-                    </a:lnR>
-                    <a:lnT cap="flat" cmpd="sng" w="38100">
-                      <a:solidFill>
-                        <a:schemeClr val="lt1"/>
-                      </a:solidFill>
-                      <a:prstDash val="solid"/>
-                      <a:round/>
-                      <a:headEnd len="sm" w="sm" type="none"/>
-                      <a:tailEnd len="sm" w="sm" type="none"/>
-                    </a:lnT>
-                    <a:lnB cap="flat" cmpd="sng" w="38100">
-                      <a:solidFill>
-                        <a:schemeClr val="lt1"/>
-                      </a:solidFill>
-                      <a:prstDash val="solid"/>
-                      <a:round/>
-                      <a:headEnd len="sm" w="sm" type="none"/>
-                      <a:tailEnd len="sm" w="sm" type="none"/>
-                    </a:lnB>
-                    <a:solidFill>
-                      <a:schemeClr val="lt1"/>
-                    </a:solidFill>
-                  </a:tcPr>
-                </a:tc>
-                <a:tc>
-                  <a:txBody>
-                    <a:bodyPr/>
-                    <a:lstStyle/>
-                    <a:p>
-                      <a:pPr indent="0" lvl="0" marL="0" rtl="0" algn="ctr">
-                        <a:spcBef>
-                          <a:spcPts val="0"/>
-                        </a:spcBef>
-                        <a:spcAft>
-                          <a:spcPts val="0"/>
-                        </a:spcAft>
-                        <a:buNone/>
-                      </a:pPr>
-                      <a:r>
-                        <a:t/>
-                      </a:r>
-                      <a:endParaRPr b="1">
-                        <a:solidFill>
-                          <a:schemeClr val="lt1"/>
-                        </a:solidFill>
-                      </a:endParaRPr>
-                    </a:p>
-                  </a:txBody>
-                  <a:tcPr marT="91425" marB="91425" marR="91425" marL="91425" anchor="ctr">
-                    <a:lnL cap="flat" cmpd="sng" w="38100">
-                      <a:solidFill>
-                        <a:schemeClr val="lt1"/>
-                      </a:solidFill>
-                      <a:prstDash val="solid"/>
-                      <a:round/>
-                      <a:headEnd len="sm" w="sm" type="none"/>
-                      <a:tailEnd len="sm" w="sm" type="none"/>
-                    </a:lnL>
-                    <a:lnR cap="flat" cmpd="sng" w="38100">
-                      <a:solidFill>
-                        <a:schemeClr val="lt1"/>
-                      </a:solidFill>
-                      <a:prstDash val="solid"/>
-                      <a:round/>
-                      <a:headEnd len="sm" w="sm" type="none"/>
-                      <a:tailEnd len="sm" w="sm" type="none"/>
-                    </a:lnR>
-                    <a:lnT cap="flat" cmpd="sng" w="38100">
-                      <a:solidFill>
-                        <a:schemeClr val="lt1"/>
-                      </a:solidFill>
-                      <a:prstDash val="solid"/>
-                      <a:round/>
-                      <a:headEnd len="sm" w="sm" type="none"/>
-                      <a:tailEnd len="sm" w="sm" type="none"/>
-                    </a:lnT>
-                    <a:lnB cap="flat" cmpd="sng" w="38100">
-                      <a:solidFill>
-                        <a:schemeClr val="lt1"/>
-                      </a:solidFill>
-                      <a:prstDash val="solid"/>
-                      <a:round/>
-                      <a:headEnd len="sm" w="sm" type="none"/>
-                      <a:tailEnd len="sm" w="sm" type="none"/>
-                    </a:lnB>
-                    <a:solidFill>
-                      <a:schemeClr val="lt1"/>
-                    </a:solidFill>
-                  </a:tcPr>
-                </a:tc>
+              <a:tr h="522525">
                 <a:tc>
                   <a:txBody>
                     <a:bodyPr/>
@@ -24082,73 +23451,7 @@
                     </a:solidFill>
                   </a:tcPr>
                 </a:tc>
-                <a:tc>
-                  <a:txBody>
-                    <a:bodyPr/>
-                    <a:lstStyle/>
-                    <a:p>
-                      <a:pPr indent="0" lvl="0" marL="0" rtl="0" algn="ctr">
-                        <a:spcBef>
-                          <a:spcPts val="0"/>
-                        </a:spcBef>
-                        <a:spcAft>
-                          <a:spcPts val="0"/>
-                        </a:spcAft>
-                        <a:buNone/>
-                      </a:pPr>
-                      <a:r>
-                        <a:t/>
-                      </a:r>
-                      <a:endParaRPr b="1">
-                        <a:solidFill>
-                          <a:schemeClr val="lt1"/>
-                        </a:solidFill>
-                      </a:endParaRPr>
-                    </a:p>
-                  </a:txBody>
-                  <a:tcPr marT="91425" marB="91425" marR="91425" marL="91425" anchor="ctr">
-                    <a:lnL cap="flat" cmpd="sng" w="38100">
-                      <a:solidFill>
-                        <a:schemeClr val="lt1"/>
-                      </a:solidFill>
-                      <a:prstDash val="solid"/>
-                      <a:round/>
-                      <a:headEnd len="sm" w="sm" type="none"/>
-                      <a:tailEnd len="sm" w="sm" type="none"/>
-                    </a:lnL>
-                    <a:lnR cap="flat" cmpd="sng" w="38100">
-                      <a:solidFill>
-                        <a:schemeClr val="lt1"/>
-                      </a:solidFill>
-                      <a:prstDash val="solid"/>
-                      <a:round/>
-                      <a:headEnd len="sm" w="sm" type="none"/>
-                      <a:tailEnd len="sm" w="sm" type="none"/>
-                    </a:lnR>
-                    <a:lnT cap="flat" cmpd="sng" w="38100">
-                      <a:solidFill>
-                        <a:schemeClr val="lt1"/>
-                      </a:solidFill>
-                      <a:prstDash val="solid"/>
-                      <a:round/>
-                      <a:headEnd len="sm" w="sm" type="none"/>
-                      <a:tailEnd len="sm" w="sm" type="none"/>
-                    </a:lnT>
-                    <a:lnB cap="flat" cmpd="sng" w="38100">
-                      <a:solidFill>
-                        <a:schemeClr val="lt1"/>
-                      </a:solidFill>
-                      <a:prstDash val="solid"/>
-                      <a:round/>
-                      <a:headEnd len="sm" w="sm" type="none"/>
-                      <a:tailEnd len="sm" w="sm" type="none"/>
-                    </a:lnB>
-                    <a:solidFill>
-                      <a:schemeClr val="lt1"/>
-                    </a:solidFill>
-                  </a:tcPr>
-                </a:tc>
-                <a:tc>
+                <a:tc gridSpan="4">
                   <a:txBody>
                     <a:bodyPr/>
                     <a:lstStyle/>
@@ -24219,80 +23522,11 @@
                     </a:solidFill>
                   </a:tcPr>
                 </a:tc>
-                <a:tc>
-                  <a:txBody>
-                    <a:bodyPr/>
-                    <a:lstStyle/>
-                    <a:p>
-                      <a:pPr indent="0" lvl="0" marL="0" rtl="0" algn="ctr">
-                        <a:spcBef>
-                          <a:spcPts val="0"/>
-                        </a:spcBef>
-                        <a:spcAft>
-                          <a:spcPts val="0"/>
-                        </a:spcAft>
-                        <a:buNone/>
-                      </a:pPr>
-                      <a:r>
-                        <a:rPr b="1" lang="en">
-                          <a:solidFill>
-                            <a:schemeClr val="lt1"/>
-                          </a:solidFill>
-                        </a:rPr>
-                        <a:t>COACH</a:t>
-                      </a:r>
-                      <a:endParaRPr b="1">
-                        <a:solidFill>
-                          <a:schemeClr val="lt1"/>
-                        </a:solidFill>
-                      </a:endParaRPr>
-                    </a:p>
-                  </a:txBody>
-                  <a:tcPr marT="91425" marB="91425" marR="91425" marL="91425" anchor="ctr">
-                    <a:lnL cap="flat" cmpd="sng" w="38100">
-                      <a:solidFill>
-                        <a:schemeClr val="lt1"/>
-                      </a:solidFill>
-                      <a:prstDash val="solid"/>
-                      <a:round/>
-                      <a:headEnd len="sm" w="sm" type="none"/>
-                      <a:tailEnd len="sm" w="sm" type="none"/>
-                    </a:lnL>
-                    <a:lnR cap="flat" cmpd="sng" w="38100">
-                      <a:solidFill>
-                        <a:schemeClr val="lt1"/>
-                      </a:solidFill>
-                      <a:prstDash val="solid"/>
-                      <a:round/>
-                      <a:headEnd len="sm" w="sm" type="none"/>
-                      <a:tailEnd len="sm" w="sm" type="none"/>
-                    </a:lnR>
-                    <a:lnT cap="flat" cmpd="sng" w="38100">
-                      <a:solidFill>
-                        <a:schemeClr val="lt1"/>
-                      </a:solidFill>
-                      <a:prstDash val="solid"/>
-                      <a:round/>
-                      <a:headEnd len="sm" w="sm" type="none"/>
-                      <a:tailEnd len="sm" w="sm" type="none"/>
-                    </a:lnT>
-                    <a:lnB cap="flat" cmpd="sng" w="38100">
-                      <a:solidFill>
-                        <a:schemeClr val="lt1"/>
-                      </a:solidFill>
-                      <a:prstDash val="solid"/>
-                      <a:round/>
-                      <a:headEnd len="sm" w="sm" type="none"/>
-                      <a:tailEnd len="sm" w="sm" type="none"/>
-                    </a:lnB>
-                    <a:solidFill>
-                      <a:schemeClr val="accent4"/>
-                    </a:solidFill>
-                  </a:tcPr>
-                </a:tc>
-                <a:tc vMerge="1"/>
+                <a:tc hMerge="1"/>
+                <a:tc hMerge="1"/>
+                <a:tc hMerge="1"/>
               </a:tr>
-              <a:tr h="457200">
+              <a:tr h="522525">
                 <a:tc>
                   <a:txBody>
                     <a:bodyPr/>
@@ -24417,6 +23651,426 @@
                     </a:solidFill>
                   </a:tcPr>
                 </a:tc>
+                <a:tc gridSpan="2">
+                  <a:txBody>
+                    <a:bodyPr/>
+                    <a:lstStyle/>
+                    <a:p>
+                      <a:pPr indent="0" lvl="0" marL="0" rtl="0" algn="ctr">
+                        <a:spcBef>
+                          <a:spcPts val="0"/>
+                        </a:spcBef>
+                        <a:spcAft>
+                          <a:spcPts val="0"/>
+                        </a:spcAft>
+                        <a:buNone/>
+                      </a:pPr>
+                      <a:r>
+                        <a:rPr b="1" lang="en">
+                          <a:solidFill>
+                            <a:schemeClr val="lt1"/>
+                          </a:solidFill>
+                        </a:rPr>
+                        <a:t>Seminar (SEMI)</a:t>
+                      </a:r>
+                      <a:endParaRPr b="1">
+                        <a:solidFill>
+                          <a:schemeClr val="lt1"/>
+                        </a:solidFill>
+                      </a:endParaRPr>
+                    </a:p>
+                  </a:txBody>
+                  <a:tcPr marT="91425" marB="91425" marR="91425" marL="91425" anchor="ctr">
+                    <a:lnL cap="flat" cmpd="sng" w="38100">
+                      <a:solidFill>
+                        <a:schemeClr val="lt1"/>
+                      </a:solidFill>
+                      <a:prstDash val="solid"/>
+                      <a:round/>
+                      <a:headEnd len="sm" w="sm" type="none"/>
+                      <a:tailEnd len="sm" w="sm" type="none"/>
+                    </a:lnL>
+                    <a:lnR cap="flat" cmpd="sng" w="38100">
+                      <a:solidFill>
+                        <a:schemeClr val="lt1"/>
+                      </a:solidFill>
+                      <a:prstDash val="solid"/>
+                      <a:round/>
+                      <a:headEnd len="sm" w="sm" type="none"/>
+                      <a:tailEnd len="sm" w="sm" type="none"/>
+                    </a:lnR>
+                    <a:lnT cap="flat" cmpd="sng" w="38100">
+                      <a:solidFill>
+                        <a:schemeClr val="lt1"/>
+                      </a:solidFill>
+                      <a:prstDash val="solid"/>
+                      <a:round/>
+                      <a:headEnd len="sm" w="sm" type="none"/>
+                      <a:tailEnd len="sm" w="sm" type="none"/>
+                    </a:lnT>
+                    <a:lnB cap="flat" cmpd="sng" w="38100">
+                      <a:solidFill>
+                        <a:schemeClr val="lt1"/>
+                      </a:solidFill>
+                      <a:prstDash val="solid"/>
+                      <a:round/>
+                      <a:headEnd len="sm" w="sm" type="none"/>
+                      <a:tailEnd len="sm" w="sm" type="none"/>
+                    </a:lnB>
+                    <a:solidFill>
+                      <a:schemeClr val="lt2"/>
+                    </a:solidFill>
+                  </a:tcPr>
+                </a:tc>
+                <a:tc hMerge="1"/>
+                <a:tc gridSpan="4">
+                  <a:txBody>
+                    <a:bodyPr/>
+                    <a:lstStyle/>
+                    <a:p>
+                      <a:pPr indent="0" lvl="0" marL="0" rtl="0" algn="ctr">
+                        <a:spcBef>
+                          <a:spcPts val="0"/>
+                        </a:spcBef>
+                        <a:spcAft>
+                          <a:spcPts val="0"/>
+                        </a:spcAft>
+                        <a:buNone/>
+                      </a:pPr>
+                      <a:r>
+                        <a:rPr b="1" lang="en">
+                          <a:solidFill>
+                            <a:schemeClr val="lt1"/>
+                          </a:solidFill>
+                        </a:rPr>
+                        <a:t>Seminar (SEMI / ASES)</a:t>
+                      </a:r>
+                      <a:endParaRPr b="1">
+                        <a:solidFill>
+                          <a:schemeClr val="lt1"/>
+                        </a:solidFill>
+                      </a:endParaRPr>
+                    </a:p>
+                  </a:txBody>
+                  <a:tcPr marT="0" marB="0" marR="91425" marL="91425" anchor="ctr">
+                    <a:lnL cap="flat" cmpd="sng" w="38100">
+                      <a:solidFill>
+                        <a:schemeClr val="lt1"/>
+                      </a:solidFill>
+                      <a:prstDash val="solid"/>
+                      <a:round/>
+                      <a:headEnd len="sm" w="sm" type="none"/>
+                      <a:tailEnd len="sm" w="sm" type="none"/>
+                    </a:lnL>
+                    <a:lnR cap="flat" cmpd="sng" w="38100">
+                      <a:solidFill>
+                        <a:schemeClr val="lt1"/>
+                      </a:solidFill>
+                      <a:prstDash val="solid"/>
+                      <a:round/>
+                      <a:headEnd len="sm" w="sm" type="none"/>
+                      <a:tailEnd len="sm" w="sm" type="none"/>
+                    </a:lnR>
+                    <a:lnT cap="flat" cmpd="sng" w="38100">
+                      <a:solidFill>
+                        <a:schemeClr val="lt1"/>
+                      </a:solidFill>
+                      <a:prstDash val="solid"/>
+                      <a:round/>
+                      <a:headEnd len="sm" w="sm" type="none"/>
+                      <a:tailEnd len="sm" w="sm" type="none"/>
+                    </a:lnT>
+                    <a:lnB cap="flat" cmpd="sng" w="38100">
+                      <a:solidFill>
+                        <a:schemeClr val="lt1"/>
+                      </a:solidFill>
+                      <a:prstDash val="solid"/>
+                      <a:round/>
+                      <a:headEnd len="sm" w="sm" type="none"/>
+                      <a:tailEnd len="sm" w="sm" type="none"/>
+                    </a:lnB>
+                    <a:solidFill>
+                      <a:schemeClr val="lt2"/>
+                    </a:solidFill>
+                  </a:tcPr>
+                </a:tc>
+                <a:tc hMerge="1"/>
+                <a:tc hMerge="1"/>
+                <a:tc hMerge="1"/>
+              </a:tr>
+              <a:tr h="522525">
+                <a:tc>
+                  <a:txBody>
+                    <a:bodyPr/>
+                    <a:lstStyle/>
+                    <a:p>
+                      <a:pPr indent="0" lvl="0" marL="0" rtl="0" algn="ctr">
+                        <a:spcBef>
+                          <a:spcPts val="0"/>
+                        </a:spcBef>
+                        <a:spcAft>
+                          <a:spcPts val="0"/>
+                        </a:spcAft>
+                        <a:buNone/>
+                      </a:pPr>
+                      <a:r>
+                        <a:t/>
+                      </a:r>
+                      <a:endParaRPr/>
+                    </a:p>
+                  </a:txBody>
+                  <a:tcPr marT="91425" marB="91425" marR="91425" marL="91425" anchor="ctr">
+                    <a:lnL cap="flat" cmpd="sng" w="38100">
+                      <a:solidFill>
+                        <a:schemeClr val="lt1"/>
+                      </a:solidFill>
+                      <a:prstDash val="solid"/>
+                      <a:round/>
+                      <a:headEnd len="sm" w="sm" type="none"/>
+                      <a:tailEnd len="sm" w="sm" type="none"/>
+                    </a:lnL>
+                    <a:lnR cap="flat" cmpd="sng" w="38100">
+                      <a:solidFill>
+                        <a:schemeClr val="lt1"/>
+                      </a:solidFill>
+                      <a:prstDash val="solid"/>
+                      <a:round/>
+                      <a:headEnd len="sm" w="sm" type="none"/>
+                      <a:tailEnd len="sm" w="sm" type="none"/>
+                    </a:lnR>
+                    <a:lnT cap="flat" cmpd="sng" w="38100">
+                      <a:solidFill>
+                        <a:schemeClr val="lt1"/>
+                      </a:solidFill>
+                      <a:prstDash val="solid"/>
+                      <a:round/>
+                      <a:headEnd len="sm" w="sm" type="none"/>
+                      <a:tailEnd len="sm" w="sm" type="none"/>
+                    </a:lnT>
+                    <a:lnB cap="flat" cmpd="sng" w="38100">
+                      <a:solidFill>
+                        <a:schemeClr val="lt1"/>
+                      </a:solidFill>
+                      <a:prstDash val="solid"/>
+                      <a:round/>
+                      <a:headEnd len="sm" w="sm" type="none"/>
+                      <a:tailEnd len="sm" w="sm" type="none"/>
+                    </a:lnB>
+                    <a:solidFill>
+                      <a:schemeClr val="lt1"/>
+                    </a:solidFill>
+                  </a:tcPr>
+                </a:tc>
+                <a:tc>
+                  <a:txBody>
+                    <a:bodyPr/>
+                    <a:lstStyle/>
+                    <a:p>
+                      <a:pPr indent="0" lvl="0" marL="0" rtl="0" algn="ctr">
+                        <a:spcBef>
+                          <a:spcPts val="0"/>
+                        </a:spcBef>
+                        <a:spcAft>
+                          <a:spcPts val="0"/>
+                        </a:spcAft>
+                        <a:buNone/>
+                      </a:pPr>
+                      <a:r>
+                        <a:t/>
+                      </a:r>
+                      <a:endParaRPr/>
+                    </a:p>
+                  </a:txBody>
+                  <a:tcPr marT="91425" marB="91425" marR="91425" marL="91425" anchor="ctr">
+                    <a:lnL cap="flat" cmpd="sng" w="38100">
+                      <a:solidFill>
+                        <a:schemeClr val="lt1"/>
+                      </a:solidFill>
+                      <a:prstDash val="solid"/>
+                      <a:round/>
+                      <a:headEnd len="sm" w="sm" type="none"/>
+                      <a:tailEnd len="sm" w="sm" type="none"/>
+                    </a:lnL>
+                    <a:lnR cap="flat" cmpd="sng" w="38100">
+                      <a:solidFill>
+                        <a:schemeClr val="lt1"/>
+                      </a:solidFill>
+                      <a:prstDash val="solid"/>
+                      <a:round/>
+                      <a:headEnd len="sm" w="sm" type="none"/>
+                      <a:tailEnd len="sm" w="sm" type="none"/>
+                    </a:lnR>
+                    <a:lnT cap="flat" cmpd="sng" w="38100">
+                      <a:solidFill>
+                        <a:schemeClr val="lt1"/>
+                      </a:solidFill>
+                      <a:prstDash val="solid"/>
+                      <a:round/>
+                      <a:headEnd len="sm" w="sm" type="none"/>
+                      <a:tailEnd len="sm" w="sm" type="none"/>
+                    </a:lnT>
+                    <a:lnB cap="flat" cmpd="sng" w="38100">
+                      <a:solidFill>
+                        <a:schemeClr val="lt1"/>
+                      </a:solidFill>
+                      <a:prstDash val="solid"/>
+                      <a:round/>
+                      <a:headEnd len="sm" w="sm" type="none"/>
+                      <a:tailEnd len="sm" w="sm" type="none"/>
+                    </a:lnB>
+                    <a:solidFill>
+                      <a:schemeClr val="lt1"/>
+                    </a:solidFill>
+                  </a:tcPr>
+                </a:tc>
+                <a:tc gridSpan="2">
+                  <a:txBody>
+                    <a:bodyPr/>
+                    <a:lstStyle/>
+                    <a:p>
+                      <a:pPr indent="0" lvl="0" marL="0" rtl="0" algn="ctr">
+                        <a:spcBef>
+                          <a:spcPts val="0"/>
+                        </a:spcBef>
+                        <a:spcAft>
+                          <a:spcPts val="0"/>
+                        </a:spcAft>
+                        <a:buNone/>
+                      </a:pPr>
+                      <a:r>
+                        <a:rPr b="1" lang="en">
+                          <a:solidFill>
+                            <a:schemeClr val="lt1"/>
+                          </a:solidFill>
+                        </a:rPr>
+                        <a:t>Praktikum (PRAK)</a:t>
+                      </a:r>
+                      <a:endParaRPr b="1">
+                        <a:solidFill>
+                          <a:schemeClr val="lt1"/>
+                        </a:solidFill>
+                      </a:endParaRPr>
+                    </a:p>
+                  </a:txBody>
+                  <a:tcPr marT="91425" marB="91425" marR="91425" marL="91425" anchor="ctr">
+                    <a:lnL cap="flat" cmpd="sng" w="38100">
+                      <a:solidFill>
+                        <a:schemeClr val="lt1"/>
+                      </a:solidFill>
+                      <a:prstDash val="solid"/>
+                      <a:round/>
+                      <a:headEnd len="sm" w="sm" type="none"/>
+                      <a:tailEnd len="sm" w="sm" type="none"/>
+                    </a:lnL>
+                    <a:lnR cap="flat" cmpd="sng" w="38100">
+                      <a:solidFill>
+                        <a:schemeClr val="lt1"/>
+                      </a:solidFill>
+                      <a:prstDash val="solid"/>
+                      <a:round/>
+                      <a:headEnd len="sm" w="sm" type="none"/>
+                      <a:tailEnd len="sm" w="sm" type="none"/>
+                    </a:lnR>
+                    <a:lnT cap="flat" cmpd="sng" w="38100">
+                      <a:solidFill>
+                        <a:schemeClr val="lt1"/>
+                      </a:solidFill>
+                      <a:prstDash val="solid"/>
+                      <a:round/>
+                      <a:headEnd len="sm" w="sm" type="none"/>
+                      <a:tailEnd len="sm" w="sm" type="none"/>
+                    </a:lnT>
+                    <a:lnB cap="flat" cmpd="sng" w="38100">
+                      <a:solidFill>
+                        <a:schemeClr val="lt1"/>
+                      </a:solidFill>
+                      <a:prstDash val="solid"/>
+                      <a:round/>
+                      <a:headEnd len="sm" w="sm" type="none"/>
+                      <a:tailEnd len="sm" w="sm" type="none"/>
+                    </a:lnB>
+                    <a:solidFill>
+                      <a:schemeClr val="lt2"/>
+                    </a:solidFill>
+                  </a:tcPr>
+                </a:tc>
+                <a:tc hMerge="1"/>
+                <a:tc gridSpan="4">
+                  <a:txBody>
+                    <a:bodyPr/>
+                    <a:lstStyle/>
+                    <a:p>
+                      <a:pPr indent="0" lvl="0" marL="0" rtl="0" algn="ctr">
+                        <a:spcBef>
+                          <a:spcPts val="0"/>
+                        </a:spcBef>
+                        <a:spcAft>
+                          <a:spcPts val="0"/>
+                        </a:spcAft>
+                        <a:buNone/>
+                      </a:pPr>
+                      <a:r>
+                        <a:rPr b="1" lang="en">
+                          <a:solidFill>
+                            <a:schemeClr val="lt1"/>
+                          </a:solidFill>
+                        </a:rPr>
+                        <a:t>Project (PROJ / ASEP)</a:t>
+                      </a:r>
+                      <a:endParaRPr b="1">
+                        <a:solidFill>
+                          <a:schemeClr val="lt1"/>
+                        </a:solidFill>
+                      </a:endParaRPr>
+                    </a:p>
+                  </a:txBody>
+                  <a:tcPr marT="0" marB="0" marR="91425" marL="91425" anchor="ctr">
+                    <a:lnL cap="flat" cmpd="sng" w="38100">
+                      <a:solidFill>
+                        <a:schemeClr val="lt1"/>
+                      </a:solidFill>
+                      <a:prstDash val="solid"/>
+                      <a:round/>
+                      <a:headEnd len="sm" w="sm" type="none"/>
+                      <a:tailEnd len="sm" w="sm" type="none"/>
+                    </a:lnL>
+                    <a:lnR cap="flat" cmpd="sng" w="38100">
+                      <a:solidFill>
+                        <a:schemeClr val="lt1"/>
+                      </a:solidFill>
+                      <a:prstDash val="solid"/>
+                      <a:round/>
+                      <a:headEnd len="sm" w="sm" type="none"/>
+                      <a:tailEnd len="sm" w="sm" type="none"/>
+                    </a:lnR>
+                    <a:lnT cap="flat" cmpd="sng" w="38100">
+                      <a:solidFill>
+                        <a:schemeClr val="lt1"/>
+                      </a:solidFill>
+                      <a:prstDash val="solid"/>
+                      <a:round/>
+                      <a:headEnd len="sm" w="sm" type="none"/>
+                      <a:tailEnd len="sm" w="sm" type="none"/>
+                    </a:lnT>
+                    <a:lnB cap="flat" cmpd="sng" w="38100">
+                      <a:solidFill>
+                        <a:schemeClr val="lt1"/>
+                      </a:solidFill>
+                      <a:prstDash val="solid"/>
+                      <a:round/>
+                      <a:headEnd len="sm" w="sm" type="none"/>
+                      <a:tailEnd len="sm" w="sm" type="none"/>
+                    </a:lnB>
+                    <a:solidFill>
+                      <a:schemeClr val="lt2"/>
+                    </a:solidFill>
+                  </a:tcPr>
+                </a:tc>
+                <a:tc hMerge="1"/>
+                <a:tc hMerge="1"/>
+                <a:tc hMerge="1"/>
+              </a:tr>
+              <a:tr h="522525">
                 <a:tc>
                   <a:txBody>
                     <a:bodyPr/>
@@ -24541,7 +24195,7 @@
                     </a:solidFill>
                   </a:tcPr>
                 </a:tc>
-                <a:tc>
+                <a:tc gridSpan="2">
                   <a:txBody>
                     <a:bodyPr/>
                     <a:lstStyle/>
@@ -24561,7 +24215,7 @@
                             <a:schemeClr val="lt1"/>
                           </a:solidFill>
                         </a:rPr>
-                        <a:t>SEMI</a:t>
+                        <a:t>BATH + KOLL</a:t>
                       </a:r>
                       <a:endParaRPr b="1">
                         <a:solidFill>
@@ -24612,7 +24266,8 @@
                     </a:solidFill>
                   </a:tcPr>
                 </a:tc>
-                <a:tc>
+                <a:tc hMerge="1"/>
+                <a:tc gridSpan="4">
                   <a:txBody>
                     <a:bodyPr/>
                     <a:lstStyle/>
@@ -24632,7 +24287,7 @@
                             <a:schemeClr val="lt1"/>
                           </a:solidFill>
                         </a:rPr>
-                        <a:t>SEMI</a:t>
+                        <a:t>MATH + KOLL</a:t>
                       </a:r>
                       <a:endParaRPr b="1">
                         <a:solidFill>
@@ -24683,2068 +24338,9 @@
                     </a:solidFill>
                   </a:tcPr>
                 </a:tc>
-                <a:tc>
-                  <a:txBody>
-                    <a:bodyPr/>
-                    <a:lstStyle/>
-                    <a:p>
-                      <a:pPr indent="0" lvl="0" marL="0" rtl="0" algn="ctr">
-                        <a:spcBef>
-                          <a:spcPts val="0"/>
-                        </a:spcBef>
-                        <a:spcAft>
-                          <a:spcPts val="0"/>
-                        </a:spcAft>
-                        <a:buNone/>
-                      </a:pPr>
-                      <a:r>
-                        <a:rPr b="1" lang="en">
-                          <a:solidFill>
-                            <a:schemeClr val="lt1"/>
-                          </a:solidFill>
-                        </a:rPr>
-                        <a:t>SEMI</a:t>
-                      </a:r>
-                      <a:endParaRPr b="1">
-                        <a:solidFill>
-                          <a:schemeClr val="lt1"/>
-                        </a:solidFill>
-                      </a:endParaRPr>
-                    </a:p>
-                  </a:txBody>
-                  <a:tcPr marT="91425" marB="91425" marR="91425" marL="91425" anchor="ctr">
-                    <a:lnL cap="flat" cmpd="sng" w="38100">
-                      <a:solidFill>
-                        <a:schemeClr val="lt1"/>
-                      </a:solidFill>
-                      <a:prstDash val="solid"/>
-                      <a:round/>
-                      <a:headEnd len="sm" w="sm" type="none"/>
-                      <a:tailEnd len="sm" w="sm" type="none"/>
-                    </a:lnL>
-                    <a:lnR cap="flat" cmpd="sng" w="38100">
-                      <a:solidFill>
-                        <a:schemeClr val="lt1"/>
-                      </a:solidFill>
-                      <a:prstDash val="solid"/>
-                      <a:round/>
-                      <a:headEnd len="sm" w="sm" type="none"/>
-                      <a:tailEnd len="sm" w="sm" type="none"/>
-                    </a:lnR>
-                    <a:lnT cap="flat" cmpd="sng" w="38100">
-                      <a:solidFill>
-                        <a:schemeClr val="lt1"/>
-                      </a:solidFill>
-                      <a:prstDash val="solid"/>
-                      <a:round/>
-                      <a:headEnd len="sm" w="sm" type="none"/>
-                      <a:tailEnd len="sm" w="sm" type="none"/>
-                    </a:lnT>
-                    <a:lnB cap="flat" cmpd="sng" w="38100">
-                      <a:solidFill>
-                        <a:schemeClr val="lt1"/>
-                      </a:solidFill>
-                      <a:prstDash val="solid"/>
-                      <a:round/>
-                      <a:headEnd len="sm" w="sm" type="none"/>
-                      <a:tailEnd len="sm" w="sm" type="none"/>
-                    </a:lnB>
-                    <a:solidFill>
-                      <a:schemeClr val="dk2"/>
-                    </a:solidFill>
-                  </a:tcPr>
-                </a:tc>
-                <a:tc>
-                  <a:txBody>
-                    <a:bodyPr/>
-                    <a:lstStyle/>
-                    <a:p>
-                      <a:pPr indent="0" lvl="0" marL="0" rtl="0" algn="ctr">
-                        <a:spcBef>
-                          <a:spcPts val="0"/>
-                        </a:spcBef>
-                        <a:spcAft>
-                          <a:spcPts val="0"/>
-                        </a:spcAft>
-                        <a:buNone/>
-                      </a:pPr>
-                      <a:r>
-                        <a:rPr b="1" lang="en">
-                          <a:solidFill>
-                            <a:schemeClr val="lt1"/>
-                          </a:solidFill>
-                        </a:rPr>
-                        <a:t>SEMI</a:t>
-                      </a:r>
-                      <a:endParaRPr b="1">
-                        <a:solidFill>
-                          <a:schemeClr val="lt1"/>
-                        </a:solidFill>
-                      </a:endParaRPr>
-                    </a:p>
-                  </a:txBody>
-                  <a:tcPr marT="91425" marB="91425" marR="91425" marL="91425" anchor="ctr">
-                    <a:lnL cap="flat" cmpd="sng" w="38100">
-                      <a:solidFill>
-                        <a:schemeClr val="lt1"/>
-                      </a:solidFill>
-                      <a:prstDash val="solid"/>
-                      <a:round/>
-                      <a:headEnd len="sm" w="sm" type="none"/>
-                      <a:tailEnd len="sm" w="sm" type="none"/>
-                    </a:lnL>
-                    <a:lnR cap="flat" cmpd="sng" w="38100">
-                      <a:solidFill>
-                        <a:schemeClr val="lt1"/>
-                      </a:solidFill>
-                      <a:prstDash val="solid"/>
-                      <a:round/>
-                      <a:headEnd len="sm" w="sm" type="none"/>
-                      <a:tailEnd len="sm" w="sm" type="none"/>
-                    </a:lnR>
-                    <a:lnT cap="flat" cmpd="sng" w="38100">
-                      <a:solidFill>
-                        <a:schemeClr val="lt1"/>
-                      </a:solidFill>
-                      <a:prstDash val="solid"/>
-                      <a:round/>
-                      <a:headEnd len="sm" w="sm" type="none"/>
-                      <a:tailEnd len="sm" w="sm" type="none"/>
-                    </a:lnT>
-                    <a:lnB cap="flat" cmpd="sng" w="38100">
-                      <a:solidFill>
-                        <a:schemeClr val="lt1"/>
-                      </a:solidFill>
-                      <a:prstDash val="solid"/>
-                      <a:round/>
-                      <a:headEnd len="sm" w="sm" type="none"/>
-                      <a:tailEnd len="sm" w="sm" type="none"/>
-                    </a:lnB>
-                    <a:solidFill>
-                      <a:schemeClr val="dk2"/>
-                    </a:solidFill>
-                  </a:tcPr>
-                </a:tc>
-                <a:tc>
-                  <a:txBody>
-                    <a:bodyPr/>
-                    <a:lstStyle/>
-                    <a:p>
-                      <a:pPr indent="0" lvl="0" marL="0" rtl="0" algn="ctr">
-                        <a:spcBef>
-                          <a:spcPts val="0"/>
-                        </a:spcBef>
-                        <a:spcAft>
-                          <a:spcPts val="0"/>
-                        </a:spcAft>
-                        <a:buNone/>
-                      </a:pPr>
-                      <a:r>
-                        <a:rPr b="1" lang="en">
-                          <a:solidFill>
-                            <a:schemeClr val="lt1"/>
-                          </a:solidFill>
-                        </a:rPr>
-                        <a:t>SEMI</a:t>
-                      </a:r>
-                      <a:endParaRPr b="1">
-                        <a:solidFill>
-                          <a:schemeClr val="lt1"/>
-                        </a:solidFill>
-                      </a:endParaRPr>
-                    </a:p>
-                  </a:txBody>
-                  <a:tcPr marT="91425" marB="91425" marR="91425" marL="91425" anchor="ctr">
-                    <a:lnL cap="flat" cmpd="sng" w="38100">
-                      <a:solidFill>
-                        <a:schemeClr val="lt1"/>
-                      </a:solidFill>
-                      <a:prstDash val="solid"/>
-                      <a:round/>
-                      <a:headEnd len="sm" w="sm" type="none"/>
-                      <a:tailEnd len="sm" w="sm" type="none"/>
-                    </a:lnL>
-                    <a:lnR cap="flat" cmpd="sng" w="38100">
-                      <a:solidFill>
-                        <a:schemeClr val="lt1"/>
-                      </a:solidFill>
-                      <a:prstDash val="solid"/>
-                      <a:round/>
-                      <a:headEnd len="sm" w="sm" type="none"/>
-                      <a:tailEnd len="sm" w="sm" type="none"/>
-                    </a:lnR>
-                    <a:lnT cap="flat" cmpd="sng" w="38100">
-                      <a:solidFill>
-                        <a:schemeClr val="lt1"/>
-                      </a:solidFill>
-                      <a:prstDash val="solid"/>
-                      <a:round/>
-                      <a:headEnd len="sm" w="sm" type="none"/>
-                      <a:tailEnd len="sm" w="sm" type="none"/>
-                    </a:lnT>
-                    <a:lnB cap="flat" cmpd="sng" w="38100">
-                      <a:solidFill>
-                        <a:schemeClr val="lt1"/>
-                      </a:solidFill>
-                      <a:prstDash val="solid"/>
-                      <a:round/>
-                      <a:headEnd len="sm" w="sm" type="none"/>
-                      <a:tailEnd len="sm" w="sm" type="none"/>
-                    </a:lnB>
-                    <a:solidFill>
-                      <a:schemeClr val="dk2"/>
-                    </a:solidFill>
-                  </a:tcPr>
-                </a:tc>
-                <a:tc vMerge="1"/>
-              </a:tr>
-              <a:tr h="457200">
-                <a:tc>
-                  <a:txBody>
-                    <a:bodyPr/>
-                    <a:lstStyle/>
-                    <a:p>
-                      <a:pPr indent="0" lvl="0" marL="0" rtl="0" algn="ctr">
-                        <a:spcBef>
-                          <a:spcPts val="0"/>
-                        </a:spcBef>
-                        <a:spcAft>
-                          <a:spcPts val="0"/>
-                        </a:spcAft>
-                        <a:buNone/>
-                      </a:pPr>
-                      <a:r>
-                        <a:t/>
-                      </a:r>
-                      <a:endParaRPr/>
-                    </a:p>
-                  </a:txBody>
-                  <a:tcPr marT="91425" marB="91425" marR="91425" marL="91425" anchor="ctr">
-                    <a:lnL cap="flat" cmpd="sng" w="38100">
-                      <a:solidFill>
-                        <a:schemeClr val="lt1"/>
-                      </a:solidFill>
-                      <a:prstDash val="solid"/>
-                      <a:round/>
-                      <a:headEnd len="sm" w="sm" type="none"/>
-                      <a:tailEnd len="sm" w="sm" type="none"/>
-                    </a:lnL>
-                    <a:lnR cap="flat" cmpd="sng" w="38100">
-                      <a:solidFill>
-                        <a:schemeClr val="lt1"/>
-                      </a:solidFill>
-                      <a:prstDash val="solid"/>
-                      <a:round/>
-                      <a:headEnd len="sm" w="sm" type="none"/>
-                      <a:tailEnd len="sm" w="sm" type="none"/>
-                    </a:lnR>
-                    <a:lnT cap="flat" cmpd="sng" w="38100">
-                      <a:solidFill>
-                        <a:schemeClr val="lt1"/>
-                      </a:solidFill>
-                      <a:prstDash val="solid"/>
-                      <a:round/>
-                      <a:headEnd len="sm" w="sm" type="none"/>
-                      <a:tailEnd len="sm" w="sm" type="none"/>
-                    </a:lnT>
-                    <a:lnB cap="flat" cmpd="sng" w="38100">
-                      <a:solidFill>
-                        <a:schemeClr val="lt1"/>
-                      </a:solidFill>
-                      <a:prstDash val="solid"/>
-                      <a:round/>
-                      <a:headEnd len="sm" w="sm" type="none"/>
-                      <a:tailEnd len="sm" w="sm" type="none"/>
-                    </a:lnB>
-                    <a:solidFill>
-                      <a:schemeClr val="lt1"/>
-                    </a:solidFill>
-                  </a:tcPr>
-                </a:tc>
-                <a:tc>
-                  <a:txBody>
-                    <a:bodyPr/>
-                    <a:lstStyle/>
-                    <a:p>
-                      <a:pPr indent="0" lvl="0" marL="0" rtl="0" algn="ctr">
-                        <a:spcBef>
-                          <a:spcPts val="0"/>
-                        </a:spcBef>
-                        <a:spcAft>
-                          <a:spcPts val="0"/>
-                        </a:spcAft>
-                        <a:buNone/>
-                      </a:pPr>
-                      <a:r>
-                        <a:t/>
-                      </a:r>
-                      <a:endParaRPr/>
-                    </a:p>
-                  </a:txBody>
-                  <a:tcPr marT="91425" marB="91425" marR="91425" marL="91425" anchor="ctr">
-                    <a:lnL cap="flat" cmpd="sng" w="38100">
-                      <a:solidFill>
-                        <a:schemeClr val="lt1"/>
-                      </a:solidFill>
-                      <a:prstDash val="solid"/>
-                      <a:round/>
-                      <a:headEnd len="sm" w="sm" type="none"/>
-                      <a:tailEnd len="sm" w="sm" type="none"/>
-                    </a:lnL>
-                    <a:lnR cap="flat" cmpd="sng" w="38100">
-                      <a:solidFill>
-                        <a:schemeClr val="lt1"/>
-                      </a:solidFill>
-                      <a:prstDash val="solid"/>
-                      <a:round/>
-                      <a:headEnd len="sm" w="sm" type="none"/>
-                      <a:tailEnd len="sm" w="sm" type="none"/>
-                    </a:lnR>
-                    <a:lnT cap="flat" cmpd="sng" w="38100">
-                      <a:solidFill>
-                        <a:schemeClr val="lt1"/>
-                      </a:solidFill>
-                      <a:prstDash val="solid"/>
-                      <a:round/>
-                      <a:headEnd len="sm" w="sm" type="none"/>
-                      <a:tailEnd len="sm" w="sm" type="none"/>
-                    </a:lnT>
-                    <a:lnB cap="flat" cmpd="sng" w="38100">
-                      <a:solidFill>
-                        <a:schemeClr val="lt1"/>
-                      </a:solidFill>
-                      <a:prstDash val="solid"/>
-                      <a:round/>
-                      <a:headEnd len="sm" w="sm" type="none"/>
-                      <a:tailEnd len="sm" w="sm" type="none"/>
-                    </a:lnB>
-                    <a:solidFill>
-                      <a:schemeClr val="lt1"/>
-                    </a:solidFill>
-                  </a:tcPr>
-                </a:tc>
-                <a:tc>
-                  <a:txBody>
-                    <a:bodyPr/>
-                    <a:lstStyle/>
-                    <a:p>
-                      <a:pPr indent="0" lvl="0" marL="0" rtl="0" algn="ctr">
-                        <a:spcBef>
-                          <a:spcPts val="0"/>
-                        </a:spcBef>
-                        <a:spcAft>
-                          <a:spcPts val="0"/>
-                        </a:spcAft>
-                        <a:buNone/>
-                      </a:pPr>
-                      <a:r>
-                        <a:t/>
-                      </a:r>
-                      <a:endParaRPr/>
-                    </a:p>
-                  </a:txBody>
-                  <a:tcPr marT="91425" marB="91425" marR="91425" marL="91425" anchor="ctr">
-                    <a:lnL cap="flat" cmpd="sng" w="38100">
-                      <a:solidFill>
-                        <a:schemeClr val="lt1"/>
-                      </a:solidFill>
-                      <a:prstDash val="solid"/>
-                      <a:round/>
-                      <a:headEnd len="sm" w="sm" type="none"/>
-                      <a:tailEnd len="sm" w="sm" type="none"/>
-                    </a:lnL>
-                    <a:lnR cap="flat" cmpd="sng" w="38100">
-                      <a:solidFill>
-                        <a:schemeClr val="lt1"/>
-                      </a:solidFill>
-                      <a:prstDash val="solid"/>
-                      <a:round/>
-                      <a:headEnd len="sm" w="sm" type="none"/>
-                      <a:tailEnd len="sm" w="sm" type="none"/>
-                    </a:lnR>
-                    <a:lnT cap="flat" cmpd="sng" w="38100">
-                      <a:solidFill>
-                        <a:schemeClr val="lt1"/>
-                      </a:solidFill>
-                      <a:prstDash val="solid"/>
-                      <a:round/>
-                      <a:headEnd len="sm" w="sm" type="none"/>
-                      <a:tailEnd len="sm" w="sm" type="none"/>
-                    </a:lnT>
-                    <a:lnB cap="flat" cmpd="sng" w="38100">
-                      <a:solidFill>
-                        <a:schemeClr val="lt1"/>
-                      </a:solidFill>
-                      <a:prstDash val="solid"/>
-                      <a:round/>
-                      <a:headEnd len="sm" w="sm" type="none"/>
-                      <a:tailEnd len="sm" w="sm" type="none"/>
-                    </a:lnB>
-                    <a:solidFill>
-                      <a:schemeClr val="lt1"/>
-                    </a:solidFill>
-                  </a:tcPr>
-                </a:tc>
-                <a:tc>
-                  <a:txBody>
-                    <a:bodyPr/>
-                    <a:lstStyle/>
-                    <a:p>
-                      <a:pPr indent="0" lvl="0" marL="0" rtl="0" algn="ctr">
-                        <a:spcBef>
-                          <a:spcPts val="0"/>
-                        </a:spcBef>
-                        <a:spcAft>
-                          <a:spcPts val="0"/>
-                        </a:spcAft>
-                        <a:buNone/>
-                      </a:pPr>
-                      <a:r>
-                        <a:t/>
-                      </a:r>
-                      <a:endParaRPr/>
-                    </a:p>
-                  </a:txBody>
-                  <a:tcPr marT="91425" marB="91425" marR="91425" marL="91425" anchor="ctr">
-                    <a:lnL cap="flat" cmpd="sng" w="38100">
-                      <a:solidFill>
-                        <a:schemeClr val="lt1"/>
-                      </a:solidFill>
-                      <a:prstDash val="solid"/>
-                      <a:round/>
-                      <a:headEnd len="sm" w="sm" type="none"/>
-                      <a:tailEnd len="sm" w="sm" type="none"/>
-                    </a:lnL>
-                    <a:lnR cap="flat" cmpd="sng" w="38100">
-                      <a:solidFill>
-                        <a:schemeClr val="lt1"/>
-                      </a:solidFill>
-                      <a:prstDash val="solid"/>
-                      <a:round/>
-                      <a:headEnd len="sm" w="sm" type="none"/>
-                      <a:tailEnd len="sm" w="sm" type="none"/>
-                    </a:lnR>
-                    <a:lnT cap="flat" cmpd="sng" w="38100">
-                      <a:solidFill>
-                        <a:schemeClr val="lt1"/>
-                      </a:solidFill>
-                      <a:prstDash val="solid"/>
-                      <a:round/>
-                      <a:headEnd len="sm" w="sm" type="none"/>
-                      <a:tailEnd len="sm" w="sm" type="none"/>
-                    </a:lnT>
-                    <a:lnB cap="flat" cmpd="sng" w="38100">
-                      <a:solidFill>
-                        <a:schemeClr val="lt1"/>
-                      </a:solidFill>
-                      <a:prstDash val="solid"/>
-                      <a:round/>
-                      <a:headEnd len="sm" w="sm" type="none"/>
-                      <a:tailEnd len="sm" w="sm" type="none"/>
-                    </a:lnB>
-                    <a:solidFill>
-                      <a:schemeClr val="lt1"/>
-                    </a:solidFill>
-                  </a:tcPr>
-                </a:tc>
-                <a:tc>
-                  <a:txBody>
-                    <a:bodyPr/>
-                    <a:lstStyle/>
-                    <a:p>
-                      <a:pPr indent="0" lvl="0" marL="0" rtl="0" algn="ctr">
-                        <a:spcBef>
-                          <a:spcPts val="0"/>
-                        </a:spcBef>
-                        <a:spcAft>
-                          <a:spcPts val="0"/>
-                        </a:spcAft>
-                        <a:buNone/>
-                      </a:pPr>
-                      <a:r>
-                        <a:rPr b="1" lang="en">
-                          <a:solidFill>
-                            <a:schemeClr val="lt1"/>
-                          </a:solidFill>
-                        </a:rPr>
-                        <a:t>PRAK</a:t>
-                      </a:r>
-                      <a:endParaRPr b="1">
-                        <a:solidFill>
-                          <a:schemeClr val="lt1"/>
-                        </a:solidFill>
-                      </a:endParaRPr>
-                    </a:p>
-                  </a:txBody>
-                  <a:tcPr marT="91425" marB="91425" marR="91425" marL="91425" anchor="ctr">
-                    <a:lnL cap="flat" cmpd="sng" w="38100">
-                      <a:solidFill>
-                        <a:schemeClr val="lt1"/>
-                      </a:solidFill>
-                      <a:prstDash val="solid"/>
-                      <a:round/>
-                      <a:headEnd len="sm" w="sm" type="none"/>
-                      <a:tailEnd len="sm" w="sm" type="none"/>
-                    </a:lnL>
-                    <a:lnR cap="flat" cmpd="sng" w="38100">
-                      <a:solidFill>
-                        <a:schemeClr val="lt1"/>
-                      </a:solidFill>
-                      <a:prstDash val="solid"/>
-                      <a:round/>
-                      <a:headEnd len="sm" w="sm" type="none"/>
-                      <a:tailEnd len="sm" w="sm" type="none"/>
-                    </a:lnR>
-                    <a:lnT cap="flat" cmpd="sng" w="38100">
-                      <a:solidFill>
-                        <a:schemeClr val="lt1"/>
-                      </a:solidFill>
-                      <a:prstDash val="solid"/>
-                      <a:round/>
-                      <a:headEnd len="sm" w="sm" type="none"/>
-                      <a:tailEnd len="sm" w="sm" type="none"/>
-                    </a:lnT>
-                    <a:lnB cap="flat" cmpd="sng" w="38100">
-                      <a:solidFill>
-                        <a:schemeClr val="lt1"/>
-                      </a:solidFill>
-                      <a:prstDash val="solid"/>
-                      <a:round/>
-                      <a:headEnd len="sm" w="sm" type="none"/>
-                      <a:tailEnd len="sm" w="sm" type="none"/>
-                    </a:lnB>
-                    <a:solidFill>
-                      <a:schemeClr val="dk2"/>
-                    </a:solidFill>
-                  </a:tcPr>
-                </a:tc>
-                <a:tc>
-                  <a:txBody>
-                    <a:bodyPr/>
-                    <a:lstStyle/>
-                    <a:p>
-                      <a:pPr indent="0" lvl="0" marL="0" rtl="0" algn="ctr">
-                        <a:spcBef>
-                          <a:spcPts val="0"/>
-                        </a:spcBef>
-                        <a:spcAft>
-                          <a:spcPts val="0"/>
-                        </a:spcAft>
-                        <a:buNone/>
-                      </a:pPr>
-                      <a:r>
-                        <a:rPr b="1" lang="en">
-                          <a:solidFill>
-                            <a:schemeClr val="lt1"/>
-                          </a:solidFill>
-                        </a:rPr>
-                        <a:t>PRAK</a:t>
-                      </a:r>
-                      <a:endParaRPr b="1">
-                        <a:solidFill>
-                          <a:schemeClr val="lt1"/>
-                        </a:solidFill>
-                      </a:endParaRPr>
-                    </a:p>
-                  </a:txBody>
-                  <a:tcPr marT="91425" marB="91425" marR="91425" marL="91425" anchor="ctr">
-                    <a:lnL cap="flat" cmpd="sng" w="38100">
-                      <a:solidFill>
-                        <a:schemeClr val="lt1"/>
-                      </a:solidFill>
-                      <a:prstDash val="solid"/>
-                      <a:round/>
-                      <a:headEnd len="sm" w="sm" type="none"/>
-                      <a:tailEnd len="sm" w="sm" type="none"/>
-                    </a:lnL>
-                    <a:lnR cap="flat" cmpd="sng" w="38100">
-                      <a:solidFill>
-                        <a:schemeClr val="lt1"/>
-                      </a:solidFill>
-                      <a:prstDash val="solid"/>
-                      <a:round/>
-                      <a:headEnd len="sm" w="sm" type="none"/>
-                      <a:tailEnd len="sm" w="sm" type="none"/>
-                    </a:lnR>
-                    <a:lnT cap="flat" cmpd="sng" w="38100">
-                      <a:solidFill>
-                        <a:schemeClr val="lt1"/>
-                      </a:solidFill>
-                      <a:prstDash val="solid"/>
-                      <a:round/>
-                      <a:headEnd len="sm" w="sm" type="none"/>
-                      <a:tailEnd len="sm" w="sm" type="none"/>
-                    </a:lnT>
-                    <a:lnB cap="flat" cmpd="sng" w="38100">
-                      <a:solidFill>
-                        <a:schemeClr val="lt1"/>
-                      </a:solidFill>
-                      <a:prstDash val="solid"/>
-                      <a:round/>
-                      <a:headEnd len="sm" w="sm" type="none"/>
-                      <a:tailEnd len="sm" w="sm" type="none"/>
-                    </a:lnB>
-                    <a:solidFill>
-                      <a:schemeClr val="dk2"/>
-                    </a:solidFill>
-                  </a:tcPr>
-                </a:tc>
-                <a:tc>
-                  <a:txBody>
-                    <a:bodyPr/>
-                    <a:lstStyle/>
-                    <a:p>
-                      <a:pPr indent="0" lvl="0" marL="0" rtl="0" algn="ctr">
-                        <a:spcBef>
-                          <a:spcPts val="0"/>
-                        </a:spcBef>
-                        <a:spcAft>
-                          <a:spcPts val="0"/>
-                        </a:spcAft>
-                        <a:buNone/>
-                      </a:pPr>
-                      <a:r>
-                        <a:rPr b="1" lang="en">
-                          <a:solidFill>
-                            <a:schemeClr val="lt1"/>
-                          </a:solidFill>
-                        </a:rPr>
-                        <a:t>PRAK</a:t>
-                      </a:r>
-                      <a:endParaRPr b="1">
-                        <a:solidFill>
-                          <a:schemeClr val="lt1"/>
-                        </a:solidFill>
-                      </a:endParaRPr>
-                    </a:p>
-                  </a:txBody>
-                  <a:tcPr marT="91425" marB="91425" marR="91425" marL="91425" anchor="ctr">
-                    <a:lnL cap="flat" cmpd="sng" w="38100">
-                      <a:solidFill>
-                        <a:schemeClr val="lt1"/>
-                      </a:solidFill>
-                      <a:prstDash val="solid"/>
-                      <a:round/>
-                      <a:headEnd len="sm" w="sm" type="none"/>
-                      <a:tailEnd len="sm" w="sm" type="none"/>
-                    </a:lnL>
-                    <a:lnR cap="flat" cmpd="sng" w="38100">
-                      <a:solidFill>
-                        <a:schemeClr val="lt1"/>
-                      </a:solidFill>
-                      <a:prstDash val="solid"/>
-                      <a:round/>
-                      <a:headEnd len="sm" w="sm" type="none"/>
-                      <a:tailEnd len="sm" w="sm" type="none"/>
-                    </a:lnR>
-                    <a:lnT cap="flat" cmpd="sng" w="38100">
-                      <a:solidFill>
-                        <a:schemeClr val="lt1"/>
-                      </a:solidFill>
-                      <a:prstDash val="solid"/>
-                      <a:round/>
-                      <a:headEnd len="sm" w="sm" type="none"/>
-                      <a:tailEnd len="sm" w="sm" type="none"/>
-                    </a:lnT>
-                    <a:lnB cap="flat" cmpd="sng" w="38100">
-                      <a:solidFill>
-                        <a:schemeClr val="lt1"/>
-                      </a:solidFill>
-                      <a:prstDash val="solid"/>
-                      <a:round/>
-                      <a:headEnd len="sm" w="sm" type="none"/>
-                      <a:tailEnd len="sm" w="sm" type="none"/>
-                    </a:lnB>
-                    <a:solidFill>
-                      <a:schemeClr val="dk2"/>
-                    </a:solidFill>
-                  </a:tcPr>
-                </a:tc>
-                <a:tc>
-                  <a:txBody>
-                    <a:bodyPr/>
-                    <a:lstStyle/>
-                    <a:p>
-                      <a:pPr indent="0" lvl="0" marL="0" rtl="0" algn="ctr">
-                        <a:spcBef>
-                          <a:spcPts val="0"/>
-                        </a:spcBef>
-                        <a:spcAft>
-                          <a:spcPts val="0"/>
-                        </a:spcAft>
-                        <a:buNone/>
-                      </a:pPr>
-                      <a:r>
-                        <a:rPr b="1" lang="en">
-                          <a:solidFill>
-                            <a:schemeClr val="lt1"/>
-                          </a:solidFill>
-                        </a:rPr>
-                        <a:t>PRAK</a:t>
-                      </a:r>
-                      <a:endParaRPr b="1">
-                        <a:solidFill>
-                          <a:schemeClr val="lt1"/>
-                        </a:solidFill>
-                      </a:endParaRPr>
-                    </a:p>
-                  </a:txBody>
-                  <a:tcPr marT="91425" marB="91425" marR="91425" marL="91425" anchor="ctr">
-                    <a:lnL cap="flat" cmpd="sng" w="38100">
-                      <a:solidFill>
-                        <a:schemeClr val="lt1"/>
-                      </a:solidFill>
-                      <a:prstDash val="solid"/>
-                      <a:round/>
-                      <a:headEnd len="sm" w="sm" type="none"/>
-                      <a:tailEnd len="sm" w="sm" type="none"/>
-                    </a:lnL>
-                    <a:lnR cap="flat" cmpd="sng" w="38100">
-                      <a:solidFill>
-                        <a:schemeClr val="lt1"/>
-                      </a:solidFill>
-                      <a:prstDash val="solid"/>
-                      <a:round/>
-                      <a:headEnd len="sm" w="sm" type="none"/>
-                      <a:tailEnd len="sm" w="sm" type="none"/>
-                    </a:lnR>
-                    <a:lnT cap="flat" cmpd="sng" w="38100">
-                      <a:solidFill>
-                        <a:schemeClr val="lt1"/>
-                      </a:solidFill>
-                      <a:prstDash val="solid"/>
-                      <a:round/>
-                      <a:headEnd len="sm" w="sm" type="none"/>
-                      <a:tailEnd len="sm" w="sm" type="none"/>
-                    </a:lnT>
-                    <a:lnB cap="flat" cmpd="sng" w="38100">
-                      <a:solidFill>
-                        <a:schemeClr val="lt1"/>
-                      </a:solidFill>
-                      <a:prstDash val="solid"/>
-                      <a:round/>
-                      <a:headEnd len="sm" w="sm" type="none"/>
-                      <a:tailEnd len="sm" w="sm" type="none"/>
-                    </a:lnB>
-                    <a:solidFill>
-                      <a:schemeClr val="dk2"/>
-                    </a:solidFill>
-                  </a:tcPr>
-                </a:tc>
-                <a:tc>
-                  <a:txBody>
-                    <a:bodyPr/>
-                    <a:lstStyle/>
-                    <a:p>
-                      <a:pPr indent="0" lvl="0" marL="0" rtl="0" algn="ctr">
-                        <a:spcBef>
-                          <a:spcPts val="0"/>
-                        </a:spcBef>
-                        <a:spcAft>
-                          <a:spcPts val="0"/>
-                        </a:spcAft>
-                        <a:buNone/>
-                      </a:pPr>
-                      <a:r>
-                        <a:rPr b="1" lang="en">
-                          <a:solidFill>
-                            <a:schemeClr val="lt1"/>
-                          </a:solidFill>
-                        </a:rPr>
-                        <a:t>PRAK</a:t>
-                      </a:r>
-                      <a:endParaRPr b="1">
-                        <a:solidFill>
-                          <a:schemeClr val="lt1"/>
-                        </a:solidFill>
-                      </a:endParaRPr>
-                    </a:p>
-                  </a:txBody>
-                  <a:tcPr marT="91425" marB="91425" marR="91425" marL="91425" anchor="ctr">
-                    <a:lnL cap="flat" cmpd="sng" w="38100">
-                      <a:solidFill>
-                        <a:schemeClr val="lt1"/>
-                      </a:solidFill>
-                      <a:prstDash val="solid"/>
-                      <a:round/>
-                      <a:headEnd len="sm" w="sm" type="none"/>
-                      <a:tailEnd len="sm" w="sm" type="none"/>
-                    </a:lnL>
-                    <a:lnR cap="flat" cmpd="sng" w="38100">
-                      <a:solidFill>
-                        <a:schemeClr val="lt1"/>
-                      </a:solidFill>
-                      <a:prstDash val="solid"/>
-                      <a:round/>
-                      <a:headEnd len="sm" w="sm" type="none"/>
-                      <a:tailEnd len="sm" w="sm" type="none"/>
-                    </a:lnR>
-                    <a:lnT cap="flat" cmpd="sng" w="38100">
-                      <a:solidFill>
-                        <a:schemeClr val="lt1"/>
-                      </a:solidFill>
-                      <a:prstDash val="solid"/>
-                      <a:round/>
-                      <a:headEnd len="sm" w="sm" type="none"/>
-                      <a:tailEnd len="sm" w="sm" type="none"/>
-                    </a:lnT>
-                    <a:lnB cap="flat" cmpd="sng" w="38100">
-                      <a:solidFill>
-                        <a:schemeClr val="lt1"/>
-                      </a:solidFill>
-                      <a:prstDash val="solid"/>
-                      <a:round/>
-                      <a:headEnd len="sm" w="sm" type="none"/>
-                      <a:tailEnd len="sm" w="sm" type="none"/>
-                    </a:lnB>
-                    <a:solidFill>
-                      <a:schemeClr val="dk2"/>
-                    </a:solidFill>
-                  </a:tcPr>
-                </a:tc>
-                <a:tc vMerge="1"/>
-              </a:tr>
-              <a:tr h="457200">
-                <a:tc>
-                  <a:txBody>
-                    <a:bodyPr/>
-                    <a:lstStyle/>
-                    <a:p>
-                      <a:pPr indent="0" lvl="0" marL="0" rtl="0" algn="ctr">
-                        <a:spcBef>
-                          <a:spcPts val="0"/>
-                        </a:spcBef>
-                        <a:spcAft>
-                          <a:spcPts val="0"/>
-                        </a:spcAft>
-                        <a:buNone/>
-                      </a:pPr>
-                      <a:r>
-                        <a:t/>
-                      </a:r>
-                      <a:endParaRPr/>
-                    </a:p>
-                  </a:txBody>
-                  <a:tcPr marT="91425" marB="91425" marR="91425" marL="91425" anchor="ctr">
-                    <a:lnL cap="flat" cmpd="sng" w="38100">
-                      <a:solidFill>
-                        <a:schemeClr val="lt1"/>
-                      </a:solidFill>
-                      <a:prstDash val="solid"/>
-                      <a:round/>
-                      <a:headEnd len="sm" w="sm" type="none"/>
-                      <a:tailEnd len="sm" w="sm" type="none"/>
-                    </a:lnL>
-                    <a:lnR cap="flat" cmpd="sng" w="38100">
-                      <a:solidFill>
-                        <a:schemeClr val="lt1"/>
-                      </a:solidFill>
-                      <a:prstDash val="solid"/>
-                      <a:round/>
-                      <a:headEnd len="sm" w="sm" type="none"/>
-                      <a:tailEnd len="sm" w="sm" type="none"/>
-                    </a:lnR>
-                    <a:lnT cap="flat" cmpd="sng" w="38100">
-                      <a:solidFill>
-                        <a:schemeClr val="lt1"/>
-                      </a:solidFill>
-                      <a:prstDash val="solid"/>
-                      <a:round/>
-                      <a:headEnd len="sm" w="sm" type="none"/>
-                      <a:tailEnd len="sm" w="sm" type="none"/>
-                    </a:lnT>
-                    <a:lnB cap="flat" cmpd="sng" w="38100">
-                      <a:solidFill>
-                        <a:schemeClr val="lt1"/>
-                      </a:solidFill>
-                      <a:prstDash val="solid"/>
-                      <a:round/>
-                      <a:headEnd len="sm" w="sm" type="none"/>
-                      <a:tailEnd len="sm" w="sm" type="none"/>
-                    </a:lnB>
-                    <a:solidFill>
-                      <a:schemeClr val="accent1"/>
-                    </a:solidFill>
-                  </a:tcPr>
-                </a:tc>
-                <a:tc>
-                  <a:txBody>
-                    <a:bodyPr/>
-                    <a:lstStyle/>
-                    <a:p>
-                      <a:pPr indent="0" lvl="0" marL="0" rtl="0" algn="ctr">
-                        <a:spcBef>
-                          <a:spcPts val="0"/>
-                        </a:spcBef>
-                        <a:spcAft>
-                          <a:spcPts val="0"/>
-                        </a:spcAft>
-                        <a:buNone/>
-                      </a:pPr>
-                      <a:r>
-                        <a:t/>
-                      </a:r>
-                      <a:endParaRPr/>
-                    </a:p>
-                  </a:txBody>
-                  <a:tcPr marT="91425" marB="91425" marR="91425" marL="91425" anchor="ctr">
-                    <a:lnL cap="flat" cmpd="sng" w="38100">
-                      <a:solidFill>
-                        <a:schemeClr val="lt1"/>
-                      </a:solidFill>
-                      <a:prstDash val="solid"/>
-                      <a:round/>
-                      <a:headEnd len="sm" w="sm" type="none"/>
-                      <a:tailEnd len="sm" w="sm" type="none"/>
-                    </a:lnL>
-                    <a:lnR cap="flat" cmpd="sng" w="38100">
-                      <a:solidFill>
-                        <a:schemeClr val="lt1"/>
-                      </a:solidFill>
-                      <a:prstDash val="solid"/>
-                      <a:round/>
-                      <a:headEnd len="sm" w="sm" type="none"/>
-                      <a:tailEnd len="sm" w="sm" type="none"/>
-                    </a:lnR>
-                    <a:lnT cap="flat" cmpd="sng" w="38100">
-                      <a:solidFill>
-                        <a:schemeClr val="lt1"/>
-                      </a:solidFill>
-                      <a:prstDash val="solid"/>
-                      <a:round/>
-                      <a:headEnd len="sm" w="sm" type="none"/>
-                      <a:tailEnd len="sm" w="sm" type="none"/>
-                    </a:lnT>
-                    <a:lnB cap="flat" cmpd="sng" w="38100">
-                      <a:solidFill>
-                        <a:schemeClr val="lt1"/>
-                      </a:solidFill>
-                      <a:prstDash val="solid"/>
-                      <a:round/>
-                      <a:headEnd len="sm" w="sm" type="none"/>
-                      <a:tailEnd len="sm" w="sm" type="none"/>
-                    </a:lnB>
-                    <a:solidFill>
-                      <a:schemeClr val="accent1"/>
-                    </a:solidFill>
-                  </a:tcPr>
-                </a:tc>
-                <a:tc>
-                  <a:txBody>
-                    <a:bodyPr/>
-                    <a:lstStyle/>
-                    <a:p>
-                      <a:pPr indent="0" lvl="0" marL="0" rtl="0" algn="ctr">
-                        <a:spcBef>
-                          <a:spcPts val="0"/>
-                        </a:spcBef>
-                        <a:spcAft>
-                          <a:spcPts val="0"/>
-                        </a:spcAft>
-                        <a:buNone/>
-                      </a:pPr>
-                      <a:r>
-                        <a:t/>
-                      </a:r>
-                      <a:endParaRPr/>
-                    </a:p>
-                  </a:txBody>
-                  <a:tcPr marT="91425" marB="91425" marR="91425" marL="91425" anchor="ctr">
-                    <a:lnL cap="flat" cmpd="sng" w="38100">
-                      <a:solidFill>
-                        <a:schemeClr val="lt1"/>
-                      </a:solidFill>
-                      <a:prstDash val="solid"/>
-                      <a:round/>
-                      <a:headEnd len="sm" w="sm" type="none"/>
-                      <a:tailEnd len="sm" w="sm" type="none"/>
-                    </a:lnL>
-                    <a:lnR cap="flat" cmpd="sng" w="38100">
-                      <a:solidFill>
-                        <a:schemeClr val="lt1"/>
-                      </a:solidFill>
-                      <a:prstDash val="solid"/>
-                      <a:round/>
-                      <a:headEnd len="sm" w="sm" type="none"/>
-                      <a:tailEnd len="sm" w="sm" type="none"/>
-                    </a:lnR>
-                    <a:lnT cap="flat" cmpd="sng" w="38100">
-                      <a:solidFill>
-                        <a:schemeClr val="lt1"/>
-                      </a:solidFill>
-                      <a:prstDash val="solid"/>
-                      <a:round/>
-                      <a:headEnd len="sm" w="sm" type="none"/>
-                      <a:tailEnd len="sm" w="sm" type="none"/>
-                    </a:lnT>
-                    <a:lnB cap="flat" cmpd="sng" w="38100">
-                      <a:solidFill>
-                        <a:schemeClr val="lt1"/>
-                      </a:solidFill>
-                      <a:prstDash val="solid"/>
-                      <a:round/>
-                      <a:headEnd len="sm" w="sm" type="none"/>
-                      <a:tailEnd len="sm" w="sm" type="none"/>
-                    </a:lnB>
-                    <a:solidFill>
-                      <a:schemeClr val="accent1"/>
-                    </a:solidFill>
-                  </a:tcPr>
-                </a:tc>
-                <a:tc>
-                  <a:txBody>
-                    <a:bodyPr/>
-                    <a:lstStyle/>
-                    <a:p>
-                      <a:pPr indent="0" lvl="0" marL="0" rtl="0" algn="ctr">
-                        <a:spcBef>
-                          <a:spcPts val="0"/>
-                        </a:spcBef>
-                        <a:spcAft>
-                          <a:spcPts val="0"/>
-                        </a:spcAft>
-                        <a:buNone/>
-                      </a:pPr>
-                      <a:r>
-                        <a:t/>
-                      </a:r>
-                      <a:endParaRPr/>
-                    </a:p>
-                  </a:txBody>
-                  <a:tcPr marT="91425" marB="91425" marR="91425" marL="91425" anchor="ctr">
-                    <a:lnL cap="flat" cmpd="sng" w="38100">
-                      <a:solidFill>
-                        <a:schemeClr val="lt1"/>
-                      </a:solidFill>
-                      <a:prstDash val="solid"/>
-                      <a:round/>
-                      <a:headEnd len="sm" w="sm" type="none"/>
-                      <a:tailEnd len="sm" w="sm" type="none"/>
-                    </a:lnL>
-                    <a:lnR cap="flat" cmpd="sng" w="38100">
-                      <a:solidFill>
-                        <a:schemeClr val="lt1"/>
-                      </a:solidFill>
-                      <a:prstDash val="solid"/>
-                      <a:round/>
-                      <a:headEnd len="sm" w="sm" type="none"/>
-                      <a:tailEnd len="sm" w="sm" type="none"/>
-                    </a:lnR>
-                    <a:lnT cap="flat" cmpd="sng" w="38100">
-                      <a:solidFill>
-                        <a:schemeClr val="lt1"/>
-                      </a:solidFill>
-                      <a:prstDash val="solid"/>
-                      <a:round/>
-                      <a:headEnd len="sm" w="sm" type="none"/>
-                      <a:tailEnd len="sm" w="sm" type="none"/>
-                    </a:lnT>
-                    <a:lnB cap="flat" cmpd="sng" w="38100">
-                      <a:solidFill>
-                        <a:schemeClr val="lt1"/>
-                      </a:solidFill>
-                      <a:prstDash val="solid"/>
-                      <a:round/>
-                      <a:headEnd len="sm" w="sm" type="none"/>
-                      <a:tailEnd len="sm" w="sm" type="none"/>
-                    </a:lnB>
-                    <a:solidFill>
-                      <a:schemeClr val="accent1"/>
-                    </a:solidFill>
-                  </a:tcPr>
-                </a:tc>
-                <a:tc>
-                  <a:txBody>
-                    <a:bodyPr/>
-                    <a:lstStyle/>
-                    <a:p>
-                      <a:pPr indent="0" lvl="0" marL="0" rtl="0" algn="ctr">
-                        <a:spcBef>
-                          <a:spcPts val="0"/>
-                        </a:spcBef>
-                        <a:spcAft>
-                          <a:spcPts val="0"/>
-                        </a:spcAft>
-                        <a:buNone/>
-                      </a:pPr>
-                      <a:r>
-                        <a:t/>
-                      </a:r>
-                      <a:endParaRPr b="1">
-                        <a:solidFill>
-                          <a:schemeClr val="lt1"/>
-                        </a:solidFill>
-                      </a:endParaRPr>
-                    </a:p>
-                  </a:txBody>
-                  <a:tcPr marT="91425" marB="91425" marR="91425" marL="91425" anchor="ctr">
-                    <a:lnL cap="flat" cmpd="sng" w="38100">
-                      <a:solidFill>
-                        <a:schemeClr val="lt1"/>
-                      </a:solidFill>
-                      <a:prstDash val="solid"/>
-                      <a:round/>
-                      <a:headEnd len="sm" w="sm" type="none"/>
-                      <a:tailEnd len="sm" w="sm" type="none"/>
-                    </a:lnL>
-                    <a:lnR cap="flat" cmpd="sng" w="38100">
-                      <a:solidFill>
-                        <a:schemeClr val="lt1"/>
-                      </a:solidFill>
-                      <a:prstDash val="solid"/>
-                      <a:round/>
-                      <a:headEnd len="sm" w="sm" type="none"/>
-                      <a:tailEnd len="sm" w="sm" type="none"/>
-                    </a:lnR>
-                    <a:lnT cap="flat" cmpd="sng" w="38100">
-                      <a:solidFill>
-                        <a:schemeClr val="lt1"/>
-                      </a:solidFill>
-                      <a:prstDash val="solid"/>
-                      <a:round/>
-                      <a:headEnd len="sm" w="sm" type="none"/>
-                      <a:tailEnd len="sm" w="sm" type="none"/>
-                    </a:lnT>
-                    <a:lnB cap="flat" cmpd="sng" w="38100">
-                      <a:solidFill>
-                        <a:schemeClr val="lt1"/>
-                      </a:solidFill>
-                      <a:prstDash val="solid"/>
-                      <a:round/>
-                      <a:headEnd len="sm" w="sm" type="none"/>
-                      <a:tailEnd len="sm" w="sm" type="none"/>
-                    </a:lnB>
-                    <a:solidFill>
-                      <a:schemeClr val="accent1"/>
-                    </a:solidFill>
-                  </a:tcPr>
-                </a:tc>
-                <a:tc>
-                  <a:txBody>
-                    <a:bodyPr/>
-                    <a:lstStyle/>
-                    <a:p>
-                      <a:pPr indent="0" lvl="0" marL="0" rtl="0" algn="ctr">
-                        <a:spcBef>
-                          <a:spcPts val="0"/>
-                        </a:spcBef>
-                        <a:spcAft>
-                          <a:spcPts val="0"/>
-                        </a:spcAft>
-                        <a:buNone/>
-                      </a:pPr>
-                      <a:r>
-                        <a:rPr b="1" lang="en">
-                          <a:solidFill>
-                            <a:schemeClr val="lt1"/>
-                          </a:solidFill>
-                        </a:rPr>
-                        <a:t>BATH</a:t>
-                      </a:r>
-                      <a:endParaRPr b="1">
-                        <a:solidFill>
-                          <a:schemeClr val="lt1"/>
-                        </a:solidFill>
-                      </a:endParaRPr>
-                    </a:p>
-                  </a:txBody>
-                  <a:tcPr marT="91425" marB="91425" marR="91425" marL="91425" anchor="ctr">
-                    <a:lnL cap="flat" cmpd="sng" w="38100">
-                      <a:solidFill>
-                        <a:schemeClr val="lt1"/>
-                      </a:solidFill>
-                      <a:prstDash val="solid"/>
-                      <a:round/>
-                      <a:headEnd len="sm" w="sm" type="none"/>
-                      <a:tailEnd len="sm" w="sm" type="none"/>
-                    </a:lnL>
-                    <a:lnR cap="flat" cmpd="sng" w="38100">
-                      <a:solidFill>
-                        <a:schemeClr val="lt1"/>
-                      </a:solidFill>
-                      <a:prstDash val="solid"/>
-                      <a:round/>
-                      <a:headEnd len="sm" w="sm" type="none"/>
-                      <a:tailEnd len="sm" w="sm" type="none"/>
-                    </a:lnR>
-                    <a:lnT cap="flat" cmpd="sng" w="38100">
-                      <a:solidFill>
-                        <a:schemeClr val="lt1"/>
-                      </a:solidFill>
-                      <a:prstDash val="solid"/>
-                      <a:round/>
-                      <a:headEnd len="sm" w="sm" type="none"/>
-                      <a:tailEnd len="sm" w="sm" type="none"/>
-                    </a:lnT>
-                    <a:lnB cap="flat" cmpd="sng" w="38100">
-                      <a:solidFill>
-                        <a:schemeClr val="lt1"/>
-                      </a:solidFill>
-                      <a:prstDash val="solid"/>
-                      <a:round/>
-                      <a:headEnd len="sm" w="sm" type="none"/>
-                      <a:tailEnd len="sm" w="sm" type="none"/>
-                    </a:lnB>
-                    <a:solidFill>
-                      <a:schemeClr val="dk2"/>
-                    </a:solidFill>
-                  </a:tcPr>
-                </a:tc>
-                <a:tc>
-                  <a:txBody>
-                    <a:bodyPr/>
-                    <a:lstStyle/>
-                    <a:p>
-                      <a:pPr indent="0" lvl="0" marL="0" rtl="0" algn="ctr">
-                        <a:spcBef>
-                          <a:spcPts val="0"/>
-                        </a:spcBef>
-                        <a:spcAft>
-                          <a:spcPts val="0"/>
-                        </a:spcAft>
-                        <a:buNone/>
-                      </a:pPr>
-                      <a:r>
-                        <a:t/>
-                      </a:r>
-                      <a:endParaRPr b="1">
-                        <a:solidFill>
-                          <a:schemeClr val="lt1"/>
-                        </a:solidFill>
-                      </a:endParaRPr>
-                    </a:p>
-                  </a:txBody>
-                  <a:tcPr marT="91425" marB="91425" marR="91425" marL="91425" anchor="ctr">
-                    <a:lnL cap="flat" cmpd="sng" w="38100">
-                      <a:solidFill>
-                        <a:schemeClr val="lt1"/>
-                      </a:solidFill>
-                      <a:prstDash val="solid"/>
-                      <a:round/>
-                      <a:headEnd len="sm" w="sm" type="none"/>
-                      <a:tailEnd len="sm" w="sm" type="none"/>
-                    </a:lnL>
-                    <a:lnR cap="flat" cmpd="sng" w="38100">
-                      <a:solidFill>
-                        <a:schemeClr val="lt1"/>
-                      </a:solidFill>
-                      <a:prstDash val="solid"/>
-                      <a:round/>
-                      <a:headEnd len="sm" w="sm" type="none"/>
-                      <a:tailEnd len="sm" w="sm" type="none"/>
-                    </a:lnR>
-                    <a:lnT cap="flat" cmpd="sng" w="38100">
-                      <a:solidFill>
-                        <a:schemeClr val="lt1"/>
-                      </a:solidFill>
-                      <a:prstDash val="solid"/>
-                      <a:round/>
-                      <a:headEnd len="sm" w="sm" type="none"/>
-                      <a:tailEnd len="sm" w="sm" type="none"/>
-                    </a:lnT>
-                    <a:lnB cap="flat" cmpd="sng" w="38100">
-                      <a:solidFill>
-                        <a:schemeClr val="lt1"/>
-                      </a:solidFill>
-                      <a:prstDash val="solid"/>
-                      <a:round/>
-                      <a:headEnd len="sm" w="sm" type="none"/>
-                      <a:tailEnd len="sm" w="sm" type="none"/>
-                    </a:lnB>
-                    <a:solidFill>
-                      <a:schemeClr val="accent1"/>
-                    </a:solidFill>
-                  </a:tcPr>
-                </a:tc>
-                <a:tc>
-                  <a:txBody>
-                    <a:bodyPr/>
-                    <a:lstStyle/>
-                    <a:p>
-                      <a:pPr indent="0" lvl="0" marL="0" rtl="0" algn="ctr">
-                        <a:spcBef>
-                          <a:spcPts val="0"/>
-                        </a:spcBef>
-                        <a:spcAft>
-                          <a:spcPts val="0"/>
-                        </a:spcAft>
-                        <a:buNone/>
-                      </a:pPr>
-                      <a:r>
-                        <a:t/>
-                      </a:r>
-                      <a:endParaRPr b="1">
-                        <a:solidFill>
-                          <a:schemeClr val="lt1"/>
-                        </a:solidFill>
-                      </a:endParaRPr>
-                    </a:p>
-                  </a:txBody>
-                  <a:tcPr marT="91425" marB="91425" marR="91425" marL="91425" anchor="ctr">
-                    <a:lnL cap="flat" cmpd="sng" w="38100">
-                      <a:solidFill>
-                        <a:schemeClr val="lt1"/>
-                      </a:solidFill>
-                      <a:prstDash val="solid"/>
-                      <a:round/>
-                      <a:headEnd len="sm" w="sm" type="none"/>
-                      <a:tailEnd len="sm" w="sm" type="none"/>
-                    </a:lnL>
-                    <a:lnR cap="flat" cmpd="sng" w="38100">
-                      <a:solidFill>
-                        <a:schemeClr val="lt1"/>
-                      </a:solidFill>
-                      <a:prstDash val="solid"/>
-                      <a:round/>
-                      <a:headEnd len="sm" w="sm" type="none"/>
-                      <a:tailEnd len="sm" w="sm" type="none"/>
-                    </a:lnR>
-                    <a:lnT cap="flat" cmpd="sng" w="38100">
-                      <a:solidFill>
-                        <a:schemeClr val="lt1"/>
-                      </a:solidFill>
-                      <a:prstDash val="solid"/>
-                      <a:round/>
-                      <a:headEnd len="sm" w="sm" type="none"/>
-                      <a:tailEnd len="sm" w="sm" type="none"/>
-                    </a:lnT>
-                    <a:lnB cap="flat" cmpd="sng" w="38100">
-                      <a:solidFill>
-                        <a:schemeClr val="lt1"/>
-                      </a:solidFill>
-                      <a:prstDash val="solid"/>
-                      <a:round/>
-                      <a:headEnd len="sm" w="sm" type="none"/>
-                      <a:tailEnd len="sm" w="sm" type="none"/>
-                    </a:lnB>
-                    <a:solidFill>
-                      <a:schemeClr val="accent1"/>
-                    </a:solidFill>
-                  </a:tcPr>
-                </a:tc>
-                <a:tc>
-                  <a:txBody>
-                    <a:bodyPr/>
-                    <a:lstStyle/>
-                    <a:p>
-                      <a:pPr indent="0" lvl="0" marL="0" rtl="0" algn="ctr">
-                        <a:spcBef>
-                          <a:spcPts val="0"/>
-                        </a:spcBef>
-                        <a:spcAft>
-                          <a:spcPts val="0"/>
-                        </a:spcAft>
-                        <a:buNone/>
-                      </a:pPr>
-                      <a:r>
-                        <a:t/>
-                      </a:r>
-                      <a:endParaRPr b="1">
-                        <a:solidFill>
-                          <a:schemeClr val="lt1"/>
-                        </a:solidFill>
-                      </a:endParaRPr>
-                    </a:p>
-                  </a:txBody>
-                  <a:tcPr marT="91425" marB="91425" marR="91425" marL="91425" anchor="ctr">
-                    <a:lnL cap="flat" cmpd="sng" w="38100">
-                      <a:solidFill>
-                        <a:schemeClr val="lt1"/>
-                      </a:solidFill>
-                      <a:prstDash val="solid"/>
-                      <a:round/>
-                      <a:headEnd len="sm" w="sm" type="none"/>
-                      <a:tailEnd len="sm" w="sm" type="none"/>
-                    </a:lnL>
-                    <a:lnR cap="flat" cmpd="sng" w="38100">
-                      <a:solidFill>
-                        <a:schemeClr val="lt1"/>
-                      </a:solidFill>
-                      <a:prstDash val="solid"/>
-                      <a:round/>
-                      <a:headEnd len="sm" w="sm" type="none"/>
-                      <a:tailEnd len="sm" w="sm" type="none"/>
-                    </a:lnR>
-                    <a:lnT cap="flat" cmpd="sng" w="38100">
-                      <a:solidFill>
-                        <a:schemeClr val="lt1"/>
-                      </a:solidFill>
-                      <a:prstDash val="solid"/>
-                      <a:round/>
-                      <a:headEnd len="sm" w="sm" type="none"/>
-                      <a:tailEnd len="sm" w="sm" type="none"/>
-                    </a:lnT>
-                    <a:lnB cap="flat" cmpd="sng" w="38100">
-                      <a:solidFill>
-                        <a:schemeClr val="lt1"/>
-                      </a:solidFill>
-                      <a:prstDash val="solid"/>
-                      <a:round/>
-                      <a:headEnd len="sm" w="sm" type="none"/>
-                      <a:tailEnd len="sm" w="sm" type="none"/>
-                    </a:lnB>
-                    <a:solidFill>
-                      <a:schemeClr val="accent1"/>
-                    </a:solidFill>
-                  </a:tcPr>
-                </a:tc>
-                <a:tc vMerge="1"/>
-              </a:tr>
-              <a:tr h="457200">
-                <a:tc>
-                  <a:txBody>
-                    <a:bodyPr/>
-                    <a:lstStyle/>
-                    <a:p>
-                      <a:pPr indent="0" lvl="0" marL="0" rtl="0" algn="ctr">
-                        <a:spcBef>
-                          <a:spcPts val="0"/>
-                        </a:spcBef>
-                        <a:spcAft>
-                          <a:spcPts val="0"/>
-                        </a:spcAft>
-                        <a:buNone/>
-                      </a:pPr>
-                      <a:r>
-                        <a:t/>
-                      </a:r>
-                      <a:endParaRPr/>
-                    </a:p>
-                  </a:txBody>
-                  <a:tcPr marT="91425" marB="91425" marR="91425" marL="91425" anchor="ctr">
-                    <a:lnL cap="flat" cmpd="sng" w="38100">
-                      <a:solidFill>
-                        <a:schemeClr val="lt1"/>
-                      </a:solidFill>
-                      <a:prstDash val="solid"/>
-                      <a:round/>
-                      <a:headEnd len="sm" w="sm" type="none"/>
-                      <a:tailEnd len="sm" w="sm" type="none"/>
-                    </a:lnL>
-                    <a:lnR cap="flat" cmpd="sng" w="38100">
-                      <a:solidFill>
-                        <a:schemeClr val="lt1"/>
-                      </a:solidFill>
-                      <a:prstDash val="solid"/>
-                      <a:round/>
-                      <a:headEnd len="sm" w="sm" type="none"/>
-                      <a:tailEnd len="sm" w="sm" type="none"/>
-                    </a:lnR>
-                    <a:lnT cap="flat" cmpd="sng" w="38100">
-                      <a:solidFill>
-                        <a:schemeClr val="lt1"/>
-                      </a:solidFill>
-                      <a:prstDash val="solid"/>
-                      <a:round/>
-                      <a:headEnd len="sm" w="sm" type="none"/>
-                      <a:tailEnd len="sm" w="sm" type="none"/>
-                    </a:lnT>
-                    <a:lnB cap="flat" cmpd="sng" w="38100">
-                      <a:solidFill>
-                        <a:schemeClr val="lt1"/>
-                      </a:solidFill>
-                      <a:prstDash val="solid"/>
-                      <a:round/>
-                      <a:headEnd len="sm" w="sm" type="none"/>
-                      <a:tailEnd len="sm" w="sm" type="none"/>
-                    </a:lnB>
-                    <a:solidFill>
-                      <a:schemeClr val="lt1"/>
-                    </a:solidFill>
-                  </a:tcPr>
-                </a:tc>
-                <a:tc>
-                  <a:txBody>
-                    <a:bodyPr/>
-                    <a:lstStyle/>
-                    <a:p>
-                      <a:pPr indent="0" lvl="0" marL="0" rtl="0" algn="ctr">
-                        <a:spcBef>
-                          <a:spcPts val="0"/>
-                        </a:spcBef>
-                        <a:spcAft>
-                          <a:spcPts val="0"/>
-                        </a:spcAft>
-                        <a:buNone/>
-                      </a:pPr>
-                      <a:r>
-                        <a:t/>
-                      </a:r>
-                      <a:endParaRPr/>
-                    </a:p>
-                  </a:txBody>
-                  <a:tcPr marT="91425" marB="91425" marR="91425" marL="91425" anchor="ctr">
-                    <a:lnL cap="flat" cmpd="sng" w="38100">
-                      <a:solidFill>
-                        <a:schemeClr val="lt1"/>
-                      </a:solidFill>
-                      <a:prstDash val="solid"/>
-                      <a:round/>
-                      <a:headEnd len="sm" w="sm" type="none"/>
-                      <a:tailEnd len="sm" w="sm" type="none"/>
-                    </a:lnL>
-                    <a:lnR cap="flat" cmpd="sng" w="38100">
-                      <a:solidFill>
-                        <a:schemeClr val="lt1"/>
-                      </a:solidFill>
-                      <a:prstDash val="solid"/>
-                      <a:round/>
-                      <a:headEnd len="sm" w="sm" type="none"/>
-                      <a:tailEnd len="sm" w="sm" type="none"/>
-                    </a:lnR>
-                    <a:lnT cap="flat" cmpd="sng" w="38100">
-                      <a:solidFill>
-                        <a:schemeClr val="lt1"/>
-                      </a:solidFill>
-                      <a:prstDash val="solid"/>
-                      <a:round/>
-                      <a:headEnd len="sm" w="sm" type="none"/>
-                      <a:tailEnd len="sm" w="sm" type="none"/>
-                    </a:lnT>
-                    <a:lnB cap="flat" cmpd="sng" w="38100">
-                      <a:solidFill>
-                        <a:schemeClr val="lt1"/>
-                      </a:solidFill>
-                      <a:prstDash val="solid"/>
-                      <a:round/>
-                      <a:headEnd len="sm" w="sm" type="none"/>
-                      <a:tailEnd len="sm" w="sm" type="none"/>
-                    </a:lnB>
-                    <a:solidFill>
-                      <a:schemeClr val="lt1"/>
-                    </a:solidFill>
-                  </a:tcPr>
-                </a:tc>
-                <a:tc>
-                  <a:txBody>
-                    <a:bodyPr/>
-                    <a:lstStyle/>
-                    <a:p>
-                      <a:pPr indent="0" lvl="0" marL="0" rtl="0" algn="ctr">
-                        <a:spcBef>
-                          <a:spcPts val="0"/>
-                        </a:spcBef>
-                        <a:spcAft>
-                          <a:spcPts val="0"/>
-                        </a:spcAft>
-                        <a:buNone/>
-                      </a:pPr>
-                      <a:r>
-                        <a:t/>
-                      </a:r>
-                      <a:endParaRPr/>
-                    </a:p>
-                  </a:txBody>
-                  <a:tcPr marT="91425" marB="91425" marR="91425" marL="91425" anchor="ctr">
-                    <a:lnL cap="flat" cmpd="sng" w="38100">
-                      <a:solidFill>
-                        <a:schemeClr val="lt1"/>
-                      </a:solidFill>
-                      <a:prstDash val="solid"/>
-                      <a:round/>
-                      <a:headEnd len="sm" w="sm" type="none"/>
-                      <a:tailEnd len="sm" w="sm" type="none"/>
-                    </a:lnL>
-                    <a:lnR cap="flat" cmpd="sng" w="38100">
-                      <a:solidFill>
-                        <a:schemeClr val="lt1"/>
-                      </a:solidFill>
-                      <a:prstDash val="solid"/>
-                      <a:round/>
-                      <a:headEnd len="sm" w="sm" type="none"/>
-                      <a:tailEnd len="sm" w="sm" type="none"/>
-                    </a:lnR>
-                    <a:lnT cap="flat" cmpd="sng" w="38100">
-                      <a:solidFill>
-                        <a:schemeClr val="lt1"/>
-                      </a:solidFill>
-                      <a:prstDash val="solid"/>
-                      <a:round/>
-                      <a:headEnd len="sm" w="sm" type="none"/>
-                      <a:tailEnd len="sm" w="sm" type="none"/>
-                    </a:lnT>
-                    <a:lnB cap="flat" cmpd="sng" w="38100">
-                      <a:solidFill>
-                        <a:schemeClr val="lt1"/>
-                      </a:solidFill>
-                      <a:prstDash val="solid"/>
-                      <a:round/>
-                      <a:headEnd len="sm" w="sm" type="none"/>
-                      <a:tailEnd len="sm" w="sm" type="none"/>
-                    </a:lnB>
-                    <a:solidFill>
-                      <a:schemeClr val="lt1"/>
-                    </a:solidFill>
-                  </a:tcPr>
-                </a:tc>
-                <a:tc>
-                  <a:txBody>
-                    <a:bodyPr/>
-                    <a:lstStyle/>
-                    <a:p>
-                      <a:pPr indent="0" lvl="0" marL="0" rtl="0" algn="ctr">
-                        <a:spcBef>
-                          <a:spcPts val="0"/>
-                        </a:spcBef>
-                        <a:spcAft>
-                          <a:spcPts val="0"/>
-                        </a:spcAft>
-                        <a:buNone/>
-                      </a:pPr>
-                      <a:r>
-                        <a:t/>
-                      </a:r>
-                      <a:endParaRPr/>
-                    </a:p>
-                  </a:txBody>
-                  <a:tcPr marT="91425" marB="91425" marR="91425" marL="91425" anchor="ctr">
-                    <a:lnL cap="flat" cmpd="sng" w="38100">
-                      <a:solidFill>
-                        <a:schemeClr val="lt1"/>
-                      </a:solidFill>
-                      <a:prstDash val="solid"/>
-                      <a:round/>
-                      <a:headEnd len="sm" w="sm" type="none"/>
-                      <a:tailEnd len="sm" w="sm" type="none"/>
-                    </a:lnL>
-                    <a:lnR cap="flat" cmpd="sng" w="38100">
-                      <a:solidFill>
-                        <a:schemeClr val="lt1"/>
-                      </a:solidFill>
-                      <a:prstDash val="solid"/>
-                      <a:round/>
-                      <a:headEnd len="sm" w="sm" type="none"/>
-                      <a:tailEnd len="sm" w="sm" type="none"/>
-                    </a:lnR>
-                    <a:lnT cap="flat" cmpd="sng" w="38100">
-                      <a:solidFill>
-                        <a:schemeClr val="lt1"/>
-                      </a:solidFill>
-                      <a:prstDash val="solid"/>
-                      <a:round/>
-                      <a:headEnd len="sm" w="sm" type="none"/>
-                      <a:tailEnd len="sm" w="sm" type="none"/>
-                    </a:lnT>
-                    <a:lnB cap="flat" cmpd="sng" w="38100">
-                      <a:solidFill>
-                        <a:schemeClr val="lt1"/>
-                      </a:solidFill>
-                      <a:prstDash val="solid"/>
-                      <a:round/>
-                      <a:headEnd len="sm" w="sm" type="none"/>
-                      <a:tailEnd len="sm" w="sm" type="none"/>
-                    </a:lnB>
-                    <a:solidFill>
-                      <a:schemeClr val="lt1"/>
-                    </a:solidFill>
-                  </a:tcPr>
-                </a:tc>
-                <a:tc>
-                  <a:txBody>
-                    <a:bodyPr/>
-                    <a:lstStyle/>
-                    <a:p>
-                      <a:pPr indent="0" lvl="0" marL="0" rtl="0" algn="ctr">
-                        <a:spcBef>
-                          <a:spcPts val="0"/>
-                        </a:spcBef>
-                        <a:spcAft>
-                          <a:spcPts val="0"/>
-                        </a:spcAft>
-                        <a:buNone/>
-                      </a:pPr>
-                      <a:r>
-                        <a:t/>
-                      </a:r>
-                      <a:endParaRPr b="1">
-                        <a:solidFill>
-                          <a:schemeClr val="lt1"/>
-                        </a:solidFill>
-                      </a:endParaRPr>
-                    </a:p>
-                  </a:txBody>
-                  <a:tcPr marT="91425" marB="91425" marR="91425" marL="91425" anchor="ctr">
-                    <a:lnL cap="flat" cmpd="sng" w="38100">
-                      <a:solidFill>
-                        <a:schemeClr val="lt1"/>
-                      </a:solidFill>
-                      <a:prstDash val="solid"/>
-                      <a:round/>
-                      <a:headEnd len="sm" w="sm" type="none"/>
-                      <a:tailEnd len="sm" w="sm" type="none"/>
-                    </a:lnL>
-                    <a:lnR cap="flat" cmpd="sng" w="38100">
-                      <a:solidFill>
-                        <a:schemeClr val="lt1"/>
-                      </a:solidFill>
-                      <a:prstDash val="solid"/>
-                      <a:round/>
-                      <a:headEnd len="sm" w="sm" type="none"/>
-                      <a:tailEnd len="sm" w="sm" type="none"/>
-                    </a:lnR>
-                    <a:lnT cap="flat" cmpd="sng" w="38100">
-                      <a:solidFill>
-                        <a:schemeClr val="lt1"/>
-                      </a:solidFill>
-                      <a:prstDash val="solid"/>
-                      <a:round/>
-                      <a:headEnd len="sm" w="sm" type="none"/>
-                      <a:tailEnd len="sm" w="sm" type="none"/>
-                    </a:lnT>
-                    <a:lnB cap="flat" cmpd="sng" w="38100">
-                      <a:solidFill>
-                        <a:schemeClr val="lt1"/>
-                      </a:solidFill>
-                      <a:prstDash val="solid"/>
-                      <a:round/>
-                      <a:headEnd len="sm" w="sm" type="none"/>
-                      <a:tailEnd len="sm" w="sm" type="none"/>
-                    </a:lnB>
-                    <a:solidFill>
-                      <a:schemeClr val="lt1"/>
-                    </a:solidFill>
-                  </a:tcPr>
-                </a:tc>
-                <a:tc>
-                  <a:txBody>
-                    <a:bodyPr/>
-                    <a:lstStyle/>
-                    <a:p>
-                      <a:pPr indent="0" lvl="0" marL="0" rtl="0" algn="ctr">
-                        <a:spcBef>
-                          <a:spcPts val="0"/>
-                        </a:spcBef>
-                        <a:spcAft>
-                          <a:spcPts val="0"/>
-                        </a:spcAft>
-                        <a:buNone/>
-                      </a:pPr>
-                      <a:r>
-                        <a:rPr b="1" lang="en">
-                          <a:solidFill>
-                            <a:schemeClr val="lt1"/>
-                          </a:solidFill>
-                        </a:rPr>
-                        <a:t>KOLL</a:t>
-                      </a:r>
-                      <a:endParaRPr b="1">
-                        <a:solidFill>
-                          <a:schemeClr val="lt1"/>
-                        </a:solidFill>
-                      </a:endParaRPr>
-                    </a:p>
-                  </a:txBody>
-                  <a:tcPr marT="91425" marB="91425" marR="91425" marL="91425" anchor="ctr">
-                    <a:lnL cap="flat" cmpd="sng" w="38100">
-                      <a:solidFill>
-                        <a:schemeClr val="lt1"/>
-                      </a:solidFill>
-                      <a:prstDash val="solid"/>
-                      <a:round/>
-                      <a:headEnd len="sm" w="sm" type="none"/>
-                      <a:tailEnd len="sm" w="sm" type="none"/>
-                    </a:lnL>
-                    <a:lnR cap="flat" cmpd="sng" w="38100">
-                      <a:solidFill>
-                        <a:schemeClr val="lt1"/>
-                      </a:solidFill>
-                      <a:prstDash val="solid"/>
-                      <a:round/>
-                      <a:headEnd len="sm" w="sm" type="none"/>
-                      <a:tailEnd len="sm" w="sm" type="none"/>
-                    </a:lnR>
-                    <a:lnT cap="flat" cmpd="sng" w="38100">
-                      <a:solidFill>
-                        <a:schemeClr val="lt1"/>
-                      </a:solidFill>
-                      <a:prstDash val="solid"/>
-                      <a:round/>
-                      <a:headEnd len="sm" w="sm" type="none"/>
-                      <a:tailEnd len="sm" w="sm" type="none"/>
-                    </a:lnT>
-                    <a:lnB cap="flat" cmpd="sng" w="38100">
-                      <a:solidFill>
-                        <a:schemeClr val="lt1"/>
-                      </a:solidFill>
-                      <a:prstDash val="solid"/>
-                      <a:round/>
-                      <a:headEnd len="sm" w="sm" type="none"/>
-                      <a:tailEnd len="sm" w="sm" type="none"/>
-                    </a:lnB>
-                    <a:solidFill>
-                      <a:schemeClr val="dk2"/>
-                    </a:solidFill>
-                  </a:tcPr>
-                </a:tc>
-                <a:tc>
-                  <a:txBody>
-                    <a:bodyPr/>
-                    <a:lstStyle/>
-                    <a:p>
-                      <a:pPr indent="0" lvl="0" marL="0" rtl="0" algn="ctr">
-                        <a:spcBef>
-                          <a:spcPts val="0"/>
-                        </a:spcBef>
-                        <a:spcAft>
-                          <a:spcPts val="0"/>
-                        </a:spcAft>
-                        <a:buNone/>
-                      </a:pPr>
-                      <a:r>
-                        <a:t/>
-                      </a:r>
-                      <a:endParaRPr b="1">
-                        <a:solidFill>
-                          <a:schemeClr val="lt1"/>
-                        </a:solidFill>
-                      </a:endParaRPr>
-                    </a:p>
-                  </a:txBody>
-                  <a:tcPr marT="91425" marB="91425" marR="91425" marL="91425" anchor="ctr">
-                    <a:lnL cap="flat" cmpd="sng" w="38100">
-                      <a:solidFill>
-                        <a:schemeClr val="lt1"/>
-                      </a:solidFill>
-                      <a:prstDash val="solid"/>
-                      <a:round/>
-                      <a:headEnd len="sm" w="sm" type="none"/>
-                      <a:tailEnd len="sm" w="sm" type="none"/>
-                    </a:lnL>
-                    <a:lnR cap="flat" cmpd="sng" w="38100">
-                      <a:solidFill>
-                        <a:schemeClr val="lt1"/>
-                      </a:solidFill>
-                      <a:prstDash val="solid"/>
-                      <a:round/>
-                      <a:headEnd len="sm" w="sm" type="none"/>
-                      <a:tailEnd len="sm" w="sm" type="none"/>
-                    </a:lnR>
-                    <a:lnT cap="flat" cmpd="sng" w="38100">
-                      <a:solidFill>
-                        <a:schemeClr val="lt1"/>
-                      </a:solidFill>
-                      <a:prstDash val="solid"/>
-                      <a:round/>
-                      <a:headEnd len="sm" w="sm" type="none"/>
-                      <a:tailEnd len="sm" w="sm" type="none"/>
-                    </a:lnT>
-                    <a:lnB cap="flat" cmpd="sng" w="38100">
-                      <a:solidFill>
-                        <a:schemeClr val="lt1"/>
-                      </a:solidFill>
-                      <a:prstDash val="solid"/>
-                      <a:round/>
-                      <a:headEnd len="sm" w="sm" type="none"/>
-                      <a:tailEnd len="sm" w="sm" type="none"/>
-                    </a:lnB>
-                    <a:solidFill>
-                      <a:schemeClr val="lt1"/>
-                    </a:solidFill>
-                  </a:tcPr>
-                </a:tc>
-                <a:tc>
-                  <a:txBody>
-                    <a:bodyPr/>
-                    <a:lstStyle/>
-                    <a:p>
-                      <a:pPr indent="0" lvl="0" marL="0" rtl="0" algn="ctr">
-                        <a:spcBef>
-                          <a:spcPts val="0"/>
-                        </a:spcBef>
-                        <a:spcAft>
-                          <a:spcPts val="0"/>
-                        </a:spcAft>
-                        <a:buNone/>
-                      </a:pPr>
-                      <a:r>
-                        <a:t/>
-                      </a:r>
-                      <a:endParaRPr b="1">
-                        <a:solidFill>
-                          <a:schemeClr val="lt1"/>
-                        </a:solidFill>
-                      </a:endParaRPr>
-                    </a:p>
-                  </a:txBody>
-                  <a:tcPr marT="91425" marB="91425" marR="91425" marL="91425" anchor="ctr">
-                    <a:lnL cap="flat" cmpd="sng" w="38100">
-                      <a:solidFill>
-                        <a:schemeClr val="lt1"/>
-                      </a:solidFill>
-                      <a:prstDash val="solid"/>
-                      <a:round/>
-                      <a:headEnd len="sm" w="sm" type="none"/>
-                      <a:tailEnd len="sm" w="sm" type="none"/>
-                    </a:lnL>
-                    <a:lnR cap="flat" cmpd="sng" w="38100">
-                      <a:solidFill>
-                        <a:schemeClr val="lt1"/>
-                      </a:solidFill>
-                      <a:prstDash val="solid"/>
-                      <a:round/>
-                      <a:headEnd len="sm" w="sm" type="none"/>
-                      <a:tailEnd len="sm" w="sm" type="none"/>
-                    </a:lnR>
-                    <a:lnT cap="flat" cmpd="sng" w="38100">
-                      <a:solidFill>
-                        <a:schemeClr val="lt1"/>
-                      </a:solidFill>
-                      <a:prstDash val="solid"/>
-                      <a:round/>
-                      <a:headEnd len="sm" w="sm" type="none"/>
-                      <a:tailEnd len="sm" w="sm" type="none"/>
-                    </a:lnT>
-                    <a:lnB cap="flat" cmpd="sng" w="38100">
-                      <a:solidFill>
-                        <a:schemeClr val="lt1"/>
-                      </a:solidFill>
-                      <a:prstDash val="solid"/>
-                      <a:round/>
-                      <a:headEnd len="sm" w="sm" type="none"/>
-                      <a:tailEnd len="sm" w="sm" type="none"/>
-                    </a:lnB>
-                    <a:solidFill>
-                      <a:schemeClr val="lt1"/>
-                    </a:solidFill>
-                  </a:tcPr>
-                </a:tc>
-                <a:tc>
-                  <a:txBody>
-                    <a:bodyPr/>
-                    <a:lstStyle/>
-                    <a:p>
-                      <a:pPr indent="0" lvl="0" marL="0" rtl="0" algn="ctr">
-                        <a:spcBef>
-                          <a:spcPts val="0"/>
-                        </a:spcBef>
-                        <a:spcAft>
-                          <a:spcPts val="0"/>
-                        </a:spcAft>
-                        <a:buNone/>
-                      </a:pPr>
-                      <a:r>
-                        <a:t/>
-                      </a:r>
-                      <a:endParaRPr b="1">
-                        <a:solidFill>
-                          <a:schemeClr val="lt1"/>
-                        </a:solidFill>
-                      </a:endParaRPr>
-                    </a:p>
-                  </a:txBody>
-                  <a:tcPr marT="91425" marB="91425" marR="91425" marL="91425" anchor="ctr">
-                    <a:lnL cap="flat" cmpd="sng" w="38100">
-                      <a:solidFill>
-                        <a:schemeClr val="lt1"/>
-                      </a:solidFill>
-                      <a:prstDash val="solid"/>
-                      <a:round/>
-                      <a:headEnd len="sm" w="sm" type="none"/>
-                      <a:tailEnd len="sm" w="sm" type="none"/>
-                    </a:lnL>
-                    <a:lnR cap="flat" cmpd="sng" w="38100">
-                      <a:solidFill>
-                        <a:schemeClr val="lt1"/>
-                      </a:solidFill>
-                      <a:prstDash val="solid"/>
-                      <a:round/>
-                      <a:headEnd len="sm" w="sm" type="none"/>
-                      <a:tailEnd len="sm" w="sm" type="none"/>
-                    </a:lnR>
-                    <a:lnT cap="flat" cmpd="sng" w="38100">
-                      <a:solidFill>
-                        <a:schemeClr val="lt1"/>
-                      </a:solidFill>
-                      <a:prstDash val="solid"/>
-                      <a:round/>
-                      <a:headEnd len="sm" w="sm" type="none"/>
-                      <a:tailEnd len="sm" w="sm" type="none"/>
-                    </a:lnT>
-                    <a:lnB cap="flat" cmpd="sng" w="38100">
-                      <a:solidFill>
-                        <a:schemeClr val="lt1"/>
-                      </a:solidFill>
-                      <a:prstDash val="solid"/>
-                      <a:round/>
-                      <a:headEnd len="sm" w="sm" type="none"/>
-                      <a:tailEnd len="sm" w="sm" type="none"/>
-                    </a:lnB>
-                    <a:solidFill>
-                      <a:schemeClr val="lt1"/>
-                    </a:solidFill>
-                  </a:tcPr>
-                </a:tc>
-                <a:tc>
-                  <a:txBody>
-                    <a:bodyPr/>
-                    <a:lstStyle/>
-                    <a:p>
-                      <a:pPr indent="0" lvl="0" marL="0" rtl="0" algn="ctr">
-                        <a:spcBef>
-                          <a:spcPts val="0"/>
-                        </a:spcBef>
-                        <a:spcAft>
-                          <a:spcPts val="0"/>
-                        </a:spcAft>
-                        <a:buNone/>
-                      </a:pPr>
-                      <a:r>
-                        <a:rPr b="1" lang="en">
-                          <a:solidFill>
-                            <a:schemeClr val="lt1"/>
-                          </a:solidFill>
-                        </a:rPr>
-                        <a:t>KOLL</a:t>
-                      </a:r>
-                      <a:endParaRPr b="1">
-                        <a:solidFill>
-                          <a:schemeClr val="lt1"/>
-                        </a:solidFill>
-                      </a:endParaRPr>
-                    </a:p>
-                  </a:txBody>
-                  <a:tcPr marT="91425" marB="91425" marR="91425" marL="91425" anchor="ctr">
-                    <a:lnL cap="flat" cmpd="sng" w="38100">
-                      <a:solidFill>
-                        <a:schemeClr val="lt1"/>
-                      </a:solidFill>
-                      <a:prstDash val="solid"/>
-                      <a:round/>
-                      <a:headEnd len="sm" w="sm" type="none"/>
-                      <a:tailEnd len="sm" w="sm" type="none"/>
-                    </a:lnL>
-                    <a:lnR cap="flat" cmpd="sng" w="38100">
-                      <a:solidFill>
-                        <a:schemeClr val="lt1"/>
-                      </a:solidFill>
-                      <a:prstDash val="solid"/>
-                      <a:round/>
-                      <a:headEnd len="sm" w="sm" type="none"/>
-                      <a:tailEnd len="sm" w="sm" type="none"/>
-                    </a:lnR>
-                    <a:lnT cap="flat" cmpd="sng" w="38100">
-                      <a:solidFill>
-                        <a:schemeClr val="lt1"/>
-                      </a:solidFill>
-                      <a:prstDash val="solid"/>
-                      <a:round/>
-                      <a:headEnd len="sm" w="sm" type="none"/>
-                      <a:tailEnd len="sm" w="sm" type="none"/>
-                    </a:lnT>
-                    <a:lnB cap="flat" cmpd="sng" w="38100">
-                      <a:solidFill>
-                        <a:schemeClr val="lt1"/>
-                      </a:solidFill>
-                      <a:prstDash val="solid"/>
-                      <a:round/>
-                      <a:headEnd len="sm" w="sm" type="none"/>
-                      <a:tailEnd len="sm" w="sm" type="none"/>
-                    </a:lnB>
-                    <a:solidFill>
-                      <a:schemeClr val="dk2"/>
-                    </a:solidFill>
-                  </a:tcPr>
-                </a:tc>
+                <a:tc hMerge="1"/>
+                <a:tc hMerge="1"/>
+                <a:tc hMerge="1"/>
               </a:tr>
             </a:tbl>
           </a:graphicData>
@@ -27255,7 +24851,7 @@
 </file>
 
 <file path=ppt/theme/theme1.xml><?xml version="1.0" encoding="utf-8"?>
-<a:theme xmlns:a="http://schemas.openxmlformats.org/drawingml/2006/main" xmlns:r="http://schemas.openxmlformats.org/officeDocument/2006/relationships" name="POSS Slides Template">
+<a:theme xmlns:a="http://schemas.openxmlformats.org/drawingml/2006/main" xmlns:r="http://schemas.openxmlformats.org/officeDocument/2006/relationships" name="AMOS Slides Template">
   <a:themeElements>
     <a:clrScheme name="Simple Light">
       <a:dk1>
@@ -27813,7 +25409,7 @@
 </file>
 
 <file path=ppt/theme/theme3.xml><?xml version="1.0" encoding="utf-8"?>
-<a:theme xmlns:a="http://schemas.openxmlformats.org/drawingml/2006/main" xmlns:r="http://schemas.openxmlformats.org/officeDocument/2006/relationships" name="AMOS Slides Template">
+<a:theme xmlns:a="http://schemas.openxmlformats.org/drawingml/2006/main" xmlns:r="http://schemas.openxmlformats.org/officeDocument/2006/relationships" name="POSS Slides Template">
   <a:themeElements>
     <a:clrScheme name="Simple Light">
       <a:dk1>

</xml_diff>